<commit_message>
Improve ML sentiment inference and evaluation after preprocessing fixes (#8)
Tạm merge, review lại sau
</commit_message>
<xml_diff>
--- a/reports/slides/ITviec_Sentiment_Analysis.pptx
+++ b/reports/slides/ITviec_Sentiment_Analysis.pptx
@@ -2,27 +2,27 @@
 <file path=ppt/presentation.xml><?xml version="1.0" encoding="utf-8"?>
 <p:presentation xmlns:p="http://schemas.openxmlformats.org/presentationml/2006/main">
   <p:sldMasterIdLst>
-    <p:sldMasterId xmlns:r="http://schemas.openxmlformats.org/officeDocument/2006/relationships" id="2147483648" r:id="R9ca045bcc3b74634"/>
+    <p:sldMasterId xmlns:r="http://schemas.openxmlformats.org/officeDocument/2006/relationships" id="2147483648" r:id="Rd35db0d22386409d"/>
   </p:sldMasterIdLst>
   <p:notesMasterIdLst>
-    <p:notesMasterId xmlns:r="http://schemas.openxmlformats.org/officeDocument/2006/relationships" r:id="R16b124bf7d544c74"/>
+    <p:notesMasterId xmlns:r="http://schemas.openxmlformats.org/officeDocument/2006/relationships" r:id="Rf9ab59980ceb4569"/>
   </p:notesMasterIdLst>
   <p:sldIdLst>
-    <p:sldId xmlns:r="http://schemas.openxmlformats.org/officeDocument/2006/relationships" id="256" r:id="R2cf7305f57b84e09"/>
-    <p:sldId xmlns:r="http://schemas.openxmlformats.org/officeDocument/2006/relationships" id="257" r:id="R8ac38a9ec02b4296"/>
-    <p:sldId xmlns:r="http://schemas.openxmlformats.org/officeDocument/2006/relationships" id="258" r:id="R1bba0e616c624eda"/>
-    <p:sldId xmlns:r="http://schemas.openxmlformats.org/officeDocument/2006/relationships" id="259" r:id="R2cb25ae990404526"/>
-    <p:sldId xmlns:r="http://schemas.openxmlformats.org/officeDocument/2006/relationships" id="260" r:id="R70c4bd89d97048e5"/>
-    <p:sldId xmlns:r="http://schemas.openxmlformats.org/officeDocument/2006/relationships" id="261" r:id="Rd07bad9cf40f46e0"/>
-    <p:sldId xmlns:r="http://schemas.openxmlformats.org/officeDocument/2006/relationships" id="262" r:id="Rd4c3e423f44f46d0"/>
-    <p:sldId xmlns:r="http://schemas.openxmlformats.org/officeDocument/2006/relationships" id="263" r:id="Rca170baab35249e4"/>
-    <p:sldId xmlns:r="http://schemas.openxmlformats.org/officeDocument/2006/relationships" id="264" r:id="R9a7dc6d346fe437b"/>
-    <p:sldId xmlns:r="http://schemas.openxmlformats.org/officeDocument/2006/relationships" id="265" r:id="Rf36b8e34bc0843be"/>
-    <p:sldId xmlns:r="http://schemas.openxmlformats.org/officeDocument/2006/relationships" id="266" r:id="Rfdba7407daed41db"/>
-    <p:sldId xmlns:r="http://schemas.openxmlformats.org/officeDocument/2006/relationships" id="267" r:id="R45e98c462c6f44e3"/>
-    <p:sldId xmlns:r="http://schemas.openxmlformats.org/officeDocument/2006/relationships" id="268" r:id="R3af3cbe22e7b4ce0"/>
-    <p:sldId xmlns:r="http://schemas.openxmlformats.org/officeDocument/2006/relationships" id="269" r:id="R7c1f287fc0a84245"/>
-    <p:sldId xmlns:r="http://schemas.openxmlformats.org/officeDocument/2006/relationships" id="270" r:id="R78dd6b8213bf4683"/>
+    <p:sldId xmlns:r="http://schemas.openxmlformats.org/officeDocument/2006/relationships" id="256" r:id="Ra35b33c4dafd4abc"/>
+    <p:sldId xmlns:r="http://schemas.openxmlformats.org/officeDocument/2006/relationships" id="257" r:id="Rad07964a62ea4fc0"/>
+    <p:sldId xmlns:r="http://schemas.openxmlformats.org/officeDocument/2006/relationships" id="258" r:id="R598d8865e61d49ac"/>
+    <p:sldId xmlns:r="http://schemas.openxmlformats.org/officeDocument/2006/relationships" id="259" r:id="R3dc5a626c00c43c5"/>
+    <p:sldId xmlns:r="http://schemas.openxmlformats.org/officeDocument/2006/relationships" id="260" r:id="R2d0667cffa8944fc"/>
+    <p:sldId xmlns:r="http://schemas.openxmlformats.org/officeDocument/2006/relationships" id="261" r:id="Rc7b01f04705545c8"/>
+    <p:sldId xmlns:r="http://schemas.openxmlformats.org/officeDocument/2006/relationships" id="262" r:id="R484a9f7f64534a4b"/>
+    <p:sldId xmlns:r="http://schemas.openxmlformats.org/officeDocument/2006/relationships" id="263" r:id="Ra00048383c1544f2"/>
+    <p:sldId xmlns:r="http://schemas.openxmlformats.org/officeDocument/2006/relationships" id="264" r:id="Ra15fcace237049f3"/>
+    <p:sldId xmlns:r="http://schemas.openxmlformats.org/officeDocument/2006/relationships" id="265" r:id="R385a2abad5514d2f"/>
+    <p:sldId xmlns:r="http://schemas.openxmlformats.org/officeDocument/2006/relationships" id="266" r:id="R951c19ce46ef4a4f"/>
+    <p:sldId xmlns:r="http://schemas.openxmlformats.org/officeDocument/2006/relationships" id="267" r:id="Ra5f000aea2534e3a"/>
+    <p:sldId xmlns:r="http://schemas.openxmlformats.org/officeDocument/2006/relationships" id="268" r:id="Rb950c3ac41ae4615"/>
+    <p:sldId xmlns:r="http://schemas.openxmlformats.org/officeDocument/2006/relationships" id="269" r:id="Re819076286cd4919"/>
+    <p:sldId xmlns:r="http://schemas.openxmlformats.org/officeDocument/2006/relationships" id="270" r:id="Rf60d6fe5ec9f411b"/>
   </p:sldIdLst>
   <p:sldSz cx="12192000" cy="6858000"/>
   <p:notesSz cx="6858000" cy="9144000"/>
@@ -559,6 +559,14 @@
               <a:t>Nguồn nội bộ: reports/evaluation/error_analysis_15_samples.csv; reports/tv4_model_evaluation_error_analysis.md</a:t>
             </a:r>
           </a:p>
+          <a:p xmlns:a="http://schemas.openxmlformats.org/drawingml/2006/main">
+            <a:r>
+              <a:t>
+[Sources]
+reports/evaluation/retrained_v2/error_examples_15.csv; all_final_test_errors.csv
+[/Sources]</a:t>
+            </a:r>
+          </a:p>
         </p:txBody>
       </p:sp>
       <p:sp>
@@ -729,6 +737,14 @@
               <a:t>Nguồn nội bộ: src/tv4_analysis.py; app_pages/predict.py</a:t>
             </a:r>
           </a:p>
+          <a:p xmlns:a="http://schemas.openxmlformats.org/drawingml/2006/main">
+            <a:r>
+              <a:t>
+[Sources]
+current predict_review() output for the slide 4 example
+[/Sources]</a:t>
+            </a:r>
+          </a:p>
         </p:txBody>
       </p:sp>
       <p:sp>
@@ -814,6 +830,14 @@
               <a:t>Nguồn nội bộ: reports/tv4_model_evaluation_error_analysis.md; reports/modeling_hyperparameter_tuning.md</a:t>
             </a:r>
           </a:p>
+          <a:p xmlns:a="http://schemas.openxmlformats.org/drawingml/2006/main">
+            <a:r>
+              <a:t>
+[Sources]
+models/retrained_v2/training_audit.json; reports/evaluation/retrained_v2/final_test_snapshot.json
+[/Sources]</a:t>
+            </a:r>
+          </a:p>
         </p:txBody>
       </p:sp>
       <p:sp>
@@ -899,6 +923,14 @@
               <a:t>Nguồn nội bộ: README.md; reports/final_report_outline.md</a:t>
             </a:r>
           </a:p>
+          <a:p xmlns:a="http://schemas.openxmlformats.org/drawingml/2006/main">
+            <a:r>
+              <a:t>
+[Sources]
+scripts/retrain_sentiment_after_preprocessing.py; reports/retrained_v2_evaluation.md
+[/Sources]</a:t>
+            </a:r>
+          </a:p>
         </p:txBody>
       </p:sp>
       <p:sp>
@@ -1154,6 +1186,14 @@
               <a:t>Nguồn nội bộ: README.md mục 2.4; models/artifact_manifest.json</a:t>
             </a:r>
           </a:p>
+          <a:p xmlns:a="http://schemas.openxmlformats.org/drawingml/2006/main">
+            <a:r>
+              <a:t>
+[Sources]
+reports/evaluation/retrained_v2/final_test_snapshot.json
+[/Sources]</a:t>
+            </a:r>
+          </a:p>
         </p:txBody>
       </p:sp>
       <p:sp>
@@ -1239,6 +1279,14 @@
               <a:t>Nguồn nội bộ: src/preprocessing.py; src/tv4_analysis.py</a:t>
             </a:r>
           </a:p>
+          <a:p xmlns:a="http://schemas.openxmlformats.org/drawingml/2006/main">
+            <a:r>
+              <a:t>
+[Sources]
+src/preprocessing.py; current predict_review() output
+[/Sources]</a:t>
+            </a:r>
+          </a:p>
         </p:txBody>
       </p:sp>
       <p:sp>
@@ -1579,6 +1627,14 @@
               <a:t>Nguồn nội bộ: reports/evaluation/model_ranking_cv.csv; reports/modeling_hyperparameter_tuning.md mục 5.1</a:t>
             </a:r>
           </a:p>
+          <a:p xmlns:a="http://schemas.openxmlformats.org/drawingml/2006/main">
+            <a:r>
+              <a:t>
+[Sources]
+reports/evaluation/model_ranking_cv.csv; models/retrained_v2/training_audit.json
+[/Sources]</a:t>
+            </a:r>
+          </a:p>
         </p:txBody>
       </p:sp>
       <p:sp>
@@ -1662,6 +1718,14 @@
           <a:p xmlns:a="http://schemas.openxmlformats.org/drawingml/2006/main">
             <a:r>
               <a:t>Nguồn nội bộ: reports/evaluation/final_test_metrics.csv; reports/evaluation/confusion_matrix.csv; reports/evaluation/final_test_per_class.csv</a:t>
+            </a:r>
+          </a:p>
+          <a:p xmlns:a="http://schemas.openxmlformats.org/drawingml/2006/main">
+            <a:r>
+              <a:t>
+[Sources]
+reports/evaluation/retrained_v2/final_test_snapshot.json; final_test_per_class.csv; confusion_matrix.csv
+[/Sources]</a:t>
             </a:r>
           </a:p>
         </p:txBody>
@@ -1729,7 +1793,7 @@
   </p:cSld>
   <p:clrMap bg1="lt1" tx1="dk1" bg2="lt2" tx2="dk2" accent1="accent1" accent2="accent2" accent3="accent3" accent4="accent4" accent5="accent5" accent6="accent6" hlink="hlink" folHlink="folHlink"/>
   <p:sldLayoutIdLst>
-    <p:sldLayoutId xmlns:r="http://schemas.openxmlformats.org/officeDocument/2006/relationships" id="2147483649" r:id="R3be85fd3db5f4c13"/>
+    <p:sldLayoutId xmlns:r="http://schemas.openxmlformats.org/officeDocument/2006/relationships" id="2147483649" r:id="Rd49a1574ff894178"/>
   </p:sldLayoutIdLst>
   <p:txStyles>
     <p:titleStyle>
@@ -2415,6 +2479,9 @@
           </a:p>
         </c:txPr>
         <c:crossAx val="48672768"/>
+        <c:lblAlgn val="ctr"/>
+        <c:lblOffset val="100"/>
+        <c:noMultiLvlLbl val="0"/>
       </c:catAx>
       <c:valAx>
         <c:axId val="48672768"/>
@@ -2623,6 +2690,9 @@
           </a:p>
         </c:txPr>
         <c:crossAx val="48672768"/>
+        <c:lblAlgn val="ctr"/>
+        <c:lblOffset val="100"/>
+        <c:noMultiLvlLbl val="0"/>
       </c:catAx>
       <c:valAx>
         <c:axId val="48672768"/>
@@ -2826,6 +2896,9 @@
           </a:p>
         </c:txPr>
         <c:crossAx val="48672768"/>
+        <c:lblAlgn val="ctr"/>
+        <c:lblOffset val="100"/>
+        <c:noMultiLvlLbl val="0"/>
       </c:catAx>
       <c:valAx>
         <c:axId val="48672768"/>
@@ -2940,13 +3013,13 @@
               <c:formatCode>General</c:formatCode>
               <c:ptCount val="3"/>
               <c:pt idx="0">
-                <c:v>38.06</c:v>
+                <c:v>39.1</c:v>
               </c:pt>
               <c:pt idx="1">
-                <c:v>47.95</c:v>
+                <c:v>47.8</c:v>
               </c:pt>
               <c:pt idx="2">
-                <c:v>85.39</c:v>
+                <c:v>86.02</c:v>
               </c:pt>
             </c:numLit>
           </c:val>
@@ -3026,6 +3099,9 @@
           </a:p>
         </c:txPr>
         <c:crossAx val="48672768"/>
+        <c:lblAlgn val="ctr"/>
+        <c:lblOffset val="100"/>
+        <c:noMultiLvlLbl val="0"/>
       </c:catAx>
       <c:valAx>
         <c:axId val="48672768"/>
@@ -3314,6 +3390,9 @@
           </a:p>
         </c:txPr>
         <c:crossAx val="48672768"/>
+        <c:lblAlgn val="ctr"/>
+        <c:lblOffset val="100"/>
+        <c:noMultiLvlLbl val="0"/>
       </c:catAx>
       <c:valAx>
         <c:axId val="48672768"/>
@@ -3407,7 +3486,7 @@
           <c:idx val="0"/>
           <c:order val="0"/>
           <c:tx>
-            <c:v>TF-IDF (%)</c:v>
+            <c:v>TF-IDF (×100)</c:v>
           </c:tx>
           <c:spPr>
             <a:solidFill xmlns:a="http://schemas.openxmlformats.org/drawingml/2006/main">
@@ -3418,19 +3497,19 @@
             <c:strLit>
               <c:ptCount val="5"/>
               <c:pt idx="0">
-                <c:v>xuyên</c:v>
+                <c:v>không lương</c:v>
               </c:pt>
               <c:pt idx="1">
-                <c:v>lý</c:v>
+                <c:v>thường_xuyên</c:v>
               </c:pt>
               <c:pt idx="2">
-                <c:v>không lương</c:v>
+                <c:v>thiếu</c:v>
               </c:pt>
               <c:pt idx="3">
-                <c:v>lương</c:v>
+                <c:v>minh_bạch</c:v>
               </c:pt>
               <c:pt idx="4">
-                <c:v>không</c:v>
+                <c:v>thường_xuyên ot</c:v>
               </c:pt>
             </c:strLit>
           </c:cat>
@@ -3439,19 +3518,19 @@
               <c:formatCode>General</c:formatCode>
               <c:ptCount val="5"/>
               <c:pt idx="0">
-                <c:v>61.5</c:v>
+                <c:v>30.6</c:v>
               </c:pt>
               <c:pt idx="1">
-                <c:v>60.6</c:v>
+                <c:v>31</c:v>
               </c:pt>
               <c:pt idx="2">
-                <c:v>38.4</c:v>
+                <c:v>33.9</c:v>
               </c:pt>
               <c:pt idx="3">
-                <c:v>29.6</c:v>
+                <c:v>37.3</c:v>
               </c:pt>
               <c:pt idx="4">
-                <c:v>13.8</c:v>
+                <c:v>44.6</c:v>
               </c:pt>
             </c:numLit>
           </c:val>
@@ -3531,6 +3610,9 @@
           </a:p>
         </c:txPr>
         <c:crossAx val="48672768"/>
+        <c:lblAlgn val="ctr"/>
+        <c:lblOffset val="100"/>
+        <c:noMultiLvlLbl val="0"/>
       </c:catAx>
       <c:valAx>
         <c:axId val="48672768"/>
@@ -3672,6 +3754,7 @@
           <a:lstStyle xmlns:a="http://schemas.openxmlformats.org/drawingml/2006/main"/>
           <a:p xmlns:a="http://schemas.openxmlformats.org/drawingml/2006/main">
             <a:pPr algn="l">
+              <a:buNone/>
               <a:defRPr sz="1200" b="1">
                 <a:solidFill>
                   <a:srgbClr val="78A7FF"/>
@@ -3729,6 +3812,7 @@
           <a:lstStyle xmlns:a="http://schemas.openxmlformats.org/drawingml/2006/main"/>
           <a:p xmlns:a="http://schemas.openxmlformats.org/drawingml/2006/main">
             <a:pPr algn="l">
+              <a:buNone/>
               <a:defRPr sz="3750" b="1">
                 <a:solidFill>
                   <a:srgbClr val="F4F7FB"/>
@@ -3752,6 +3836,7 @@
           </a:p>
           <a:p xmlns:a="http://schemas.openxmlformats.org/drawingml/2006/main">
             <a:pPr algn="l">
+              <a:buNone/>
               <a:defRPr sz="3750" b="1">
                 <a:solidFill>
                   <a:srgbClr val="F4F7FB"/>
@@ -3809,6 +3894,7 @@
           <a:lstStyle xmlns:a="http://schemas.openxmlformats.org/drawingml/2006/main"/>
           <a:p xmlns:a="http://schemas.openxmlformats.org/drawingml/2006/main">
             <a:pPr algn="l">
+              <a:buNone/>
               <a:defRPr sz="1725" b="0">
                 <a:solidFill>
                   <a:srgbClr val="A7B3C4"/>
@@ -3897,6 +3983,7 @@
           <a:lstStyle xmlns:a="http://schemas.openxmlformats.org/drawingml/2006/main"/>
           <a:p xmlns:a="http://schemas.openxmlformats.org/drawingml/2006/main">
             <a:pPr algn="l">
+              <a:buNone/>
               <a:defRPr sz="975" b="1">
                 <a:solidFill>
                   <a:srgbClr val="78A7FF"/>
@@ -3954,6 +4041,7 @@
           <a:lstStyle xmlns:a="http://schemas.openxmlformats.org/drawingml/2006/main"/>
           <a:p xmlns:a="http://schemas.openxmlformats.org/drawingml/2006/main">
             <a:pPr algn="l">
+              <a:buNone/>
               <a:defRPr sz="1950" b="1">
                 <a:solidFill>
                   <a:srgbClr val="F4F7FB"/>
@@ -4011,6 +4099,7 @@
           <a:lstStyle xmlns:a="http://schemas.openxmlformats.org/drawingml/2006/main"/>
           <a:p xmlns:a="http://schemas.openxmlformats.org/drawingml/2006/main">
             <a:pPr algn="l">
+              <a:buNone/>
               <a:defRPr sz="1425" b="0">
                 <a:solidFill>
                   <a:srgbClr val="A7B3C4"/>
@@ -4068,6 +4157,7 @@
           <a:lstStyle xmlns:a="http://schemas.openxmlformats.org/drawingml/2006/main"/>
           <a:p xmlns:a="http://schemas.openxmlformats.org/drawingml/2006/main">
             <a:pPr algn="l">
+              <a:buNone/>
               <a:defRPr sz="975" b="1">
                 <a:solidFill>
                   <a:srgbClr val="78A7FF"/>
@@ -4125,6 +4215,7 @@
           <a:lstStyle xmlns:a="http://schemas.openxmlformats.org/drawingml/2006/main"/>
           <a:p xmlns:a="http://schemas.openxmlformats.org/drawingml/2006/main">
             <a:pPr algn="l">
+              <a:buNone/>
               <a:defRPr sz="1275" b="1">
                 <a:solidFill>
                   <a:srgbClr val="F4F7FB"/>
@@ -4150,17 +4241,17 @@
       </p:sp>
       <p:pic>
         <p:nvPicPr>
-          <p:cNvPr id="23" name=""/>
+          <p:cNvPr id="25" name=""/>
           <p:cNvPicPr>
             <a:picLocks xmlns:a="http://schemas.openxmlformats.org/drawingml/2006/main" noChangeAspect="1"/>
           </p:cNvPicPr>
           <p:nvPr/>
         </p:nvPicPr>
         <p:blipFill>
-          <a:blip xmlns:r="http://schemas.openxmlformats.org/officeDocument/2006/relationships" xmlns:a="http://schemas.openxmlformats.org/drawingml/2006/main" r:embed="R0ae0c801f1aa4049">
+          <a:blip xmlns:r="http://schemas.openxmlformats.org/officeDocument/2006/relationships" xmlns:a="http://schemas.openxmlformats.org/drawingml/2006/main" r:embed="R4611cefa7db44724">
             <a:extLst>
               <a:ext uri="{96DAC541-7B7A-43D3-8B79-37D633B846F1}">
-                <asvg:svgBlip xmlns:asvg="http://schemas.microsoft.com/office/drawing/2016/SVG/main" r:embed="R09b57f759bc44400"/>
+                <asvg:svgBlip xmlns:asvg="http://schemas.microsoft.com/office/drawing/2016/SVG/main" r:embed="R155e09cead574959"/>
               </a:ext>
             </a:extLst>
           </a:blip>
@@ -4210,6 +4301,7 @@
           <a:lstStyle xmlns:a="http://schemas.openxmlformats.org/drawingml/2006/main"/>
           <a:p xmlns:a="http://schemas.openxmlformats.org/drawingml/2006/main">
             <a:pPr algn="l">
+              <a:buNone/>
               <a:defRPr sz="1200" b="0">
                 <a:solidFill>
                   <a:srgbClr val="45D9A0"/>
@@ -4296,6 +4388,7 @@
           <a:lstStyle xmlns:a="http://schemas.openxmlformats.org/drawingml/2006/main"/>
           <a:p xmlns:a="http://schemas.openxmlformats.org/drawingml/2006/main">
             <a:pPr algn="l">
+              <a:buNone/>
               <a:defRPr sz="1050" b="1">
                 <a:solidFill>
                   <a:srgbClr val="78A7FF"/>
@@ -4353,6 +4446,7 @@
           <a:lstStyle xmlns:a="http://schemas.openxmlformats.org/drawingml/2006/main"/>
           <a:p xmlns:a="http://schemas.openxmlformats.org/drawingml/2006/main">
             <a:pPr algn="l">
+              <a:buNone/>
               <a:defRPr sz="3150" b="1">
                 <a:solidFill>
                   <a:srgbClr val="F4F7FB"/>
@@ -4371,7 +4465,7 @@
                 <a:ea typeface="Helvetica Neue"/>
                 <a:cs typeface="Helvetica Neue"/>
               </a:rPr>
-              <a:t>Cảm xúc lẫn lộn chiếm 10/15 lỗi đại diện</a:t>
+              <a:t>15 lỗi minh họa cho thấy ba dạng khó thường gặp</a:t>
             </a:r>
           </a:p>
         </p:txBody>
@@ -4441,6 +4535,7 @@
           <a:lstStyle xmlns:a="http://schemas.openxmlformats.org/drawingml/2006/main"/>
           <a:p xmlns:a="http://schemas.openxmlformats.org/drawingml/2006/main">
             <a:pPr algn="r">
+              <a:buNone/>
               <a:defRPr sz="900" b="0">
                 <a:solidFill>
                   <a:srgbClr val="A7B3C4"/>
@@ -4498,6 +4593,7 @@
           <a:lstStyle xmlns:a="http://schemas.openxmlformats.org/drawingml/2006/main"/>
           <a:p xmlns:a="http://schemas.openxmlformats.org/drawingml/2006/main">
             <a:pPr algn="l">
+              <a:buNone/>
               <a:defRPr sz="975" b="1">
                 <a:solidFill>
                   <a:srgbClr val="FF667B"/>
@@ -4555,6 +4651,7 @@
           <a:lstStyle xmlns:a="http://schemas.openxmlformats.org/drawingml/2006/main"/>
           <a:p xmlns:a="http://schemas.openxmlformats.org/drawingml/2006/main">
             <a:pPr algn="l">
+              <a:buNone/>
               <a:defRPr sz="2850" b="1">
                 <a:solidFill>
                   <a:srgbClr val="F4F7FB"/>
@@ -4573,7 +4670,7 @@
                 <a:ea typeface="Helvetica Neue"/>
                 <a:cs typeface="Helvetica Neue"/>
               </a:rPr>
-              <a:t>442</a:t>
+              <a:t>432</a:t>
             </a:r>
           </a:p>
         </p:txBody>
@@ -4612,6 +4709,7 @@
           <a:lstStyle xmlns:a="http://schemas.openxmlformats.org/drawingml/2006/main"/>
           <a:p xmlns:a="http://schemas.openxmlformats.org/drawingml/2006/main">
             <a:pPr algn="l">
+              <a:buNone/>
               <a:defRPr sz="1575" b="1">
                 <a:solidFill>
                   <a:srgbClr val="F4F7FB"/>
@@ -4630,7 +4728,7 @@
                 <a:ea typeface="Helvetica Neue"/>
                 <a:cs typeface="Helvetica Neue"/>
               </a:rPr>
-              <a:t>26,3% của Final Test</a:t>
+              <a:t>25,7% của Final Test</a:t>
             </a:r>
           </a:p>
         </p:txBody>
@@ -4669,6 +4767,7 @@
           <a:lstStyle xmlns:a="http://schemas.openxmlformats.org/drawingml/2006/main"/>
           <a:p xmlns:a="http://schemas.openxmlformats.org/drawingml/2006/main">
             <a:pPr algn="l">
+              <a:buNone/>
               <a:defRPr sz="1425" b="0">
                 <a:solidFill>
                   <a:srgbClr val="A7B3C4"/>
@@ -4687,7 +4786,7 @@
                 <a:ea typeface="Helvetica Neue"/>
                 <a:cs typeface="Helvetica Neue"/>
               </a:rPr>
-              <a:t>Mẫu thủ công dùng để hiểu dạng lỗi, không đại diện cho toàn bộ 442 lỗi.</a:t>
+              <a:t>15 lỗi được nhóm tự động theo dấu hiệu văn bản; không đại diện toàn bộ 432 lỗi.</a:t>
             </a:r>
           </a:p>
         </p:txBody>
@@ -4726,6 +4825,7 @@
           <a:lstStyle xmlns:a="http://schemas.openxmlformats.org/drawingml/2006/main"/>
           <a:p xmlns:a="http://schemas.openxmlformats.org/drawingml/2006/main">
             <a:pPr algn="l">
+              <a:buNone/>
               <a:defRPr sz="2250" b="1">
                 <a:solidFill>
                   <a:srgbClr val="F4D35E"/>
@@ -4744,7 +4844,7 @@
                 <a:ea typeface="Helvetica Neue"/>
                 <a:cs typeface="Helvetica Neue"/>
               </a:rPr>
-              <a:t>10 / 15</a:t>
+              <a:t>7 / 15</a:t>
             </a:r>
           </a:p>
         </p:txBody>
@@ -4783,6 +4883,7 @@
           <a:lstStyle xmlns:a="http://schemas.openxmlformats.org/drawingml/2006/main"/>
           <a:p xmlns:a="http://schemas.openxmlformats.org/drawingml/2006/main">
             <a:pPr algn="l">
+              <a:buNone/>
               <a:defRPr sz="1875" b="1">
                 <a:solidFill>
                   <a:srgbClr val="F4F7FB"/>
@@ -4801,7 +4902,7 @@
                 <a:ea typeface="Helvetica Neue"/>
                 <a:cs typeface="Helvetica Neue"/>
               </a:rPr>
-              <a:t>Cảm xúc lẫn lộn</a:t>
+              <a:t>Review nhiều vế ý</a:t>
             </a:r>
           </a:p>
         </p:txBody>
@@ -4840,6 +4941,7 @@
           <a:lstStyle xmlns:a="http://schemas.openxmlformats.org/drawingml/2006/main"/>
           <a:p xmlns:a="http://schemas.openxmlformats.org/drawingml/2006/main">
             <a:pPr algn="l">
+              <a:buNone/>
               <a:defRPr sz="1425" b="0">
                 <a:solidFill>
                   <a:srgbClr val="A7B3C4"/>
@@ -4858,7 +4960,7 @@
                 <a:ea typeface="Helvetica Neue"/>
                 <a:cs typeface="Helvetica Neue"/>
               </a:rPr>
-              <a:t>Review vừa khen vừa chê, nên một nhãn duy nhất làm mất sắc thái.</a:t>
+              <a:t>Một review vừa khen vừa chê, nên khó gói vào một nhãn duy nhất.</a:t>
             </a:r>
           </a:p>
         </p:txBody>
@@ -4928,6 +5030,7 @@
           <a:lstStyle xmlns:a="http://schemas.openxmlformats.org/drawingml/2006/main"/>
           <a:p xmlns:a="http://schemas.openxmlformats.org/drawingml/2006/main">
             <a:pPr algn="l">
+              <a:buNone/>
               <a:defRPr sz="2250" b="1">
                 <a:solidFill>
                   <a:srgbClr val="FF9C5A"/>
@@ -4946,7 +5049,7 @@
                 <a:ea typeface="Helvetica Neue"/>
                 <a:cs typeface="Helvetica Neue"/>
               </a:rPr>
-              <a:t>4 / 15</a:t>
+              <a:t>6 / 15</a:t>
             </a:r>
           </a:p>
         </p:txBody>
@@ -4985,6 +5088,7 @@
           <a:lstStyle xmlns:a="http://schemas.openxmlformats.org/drawingml/2006/main"/>
           <a:p xmlns:a="http://schemas.openxmlformats.org/drawingml/2006/main">
             <a:pPr algn="l">
+              <a:buNone/>
               <a:defRPr sz="1875" b="1">
                 <a:solidFill>
                   <a:srgbClr val="F4F7FB"/>
@@ -5003,7 +5107,7 @@
                 <a:ea typeface="Helvetica Neue"/>
                 <a:cs typeface="Helvetica Neue"/>
               </a:rPr>
-              <a:t>Nhãn nhiễu theo rating</a:t>
+              <a:t>Phủ định hoặc cấu trúc khó</a:t>
             </a:r>
           </a:p>
         </p:txBody>
@@ -5042,6 +5146,7 @@
           <a:lstStyle xmlns:a="http://schemas.openxmlformats.org/drawingml/2006/main"/>
           <a:p xmlns:a="http://schemas.openxmlformats.org/drawingml/2006/main">
             <a:pPr algn="l">
+              <a:buNone/>
               <a:defRPr sz="1425" b="0">
                 <a:solidFill>
                   <a:srgbClr val="A7B3C4"/>
@@ -5060,7 +5165,7 @@
                 <a:ea typeface="Helvetica Neue"/>
                 <a:cs typeface="Helvetica Neue"/>
               </a:rPr>
-              <a:t>Giọng văn và nhãn suy ra từ số sao không hoàn toàn nhất quán.</a:t>
+              <a:t>Từ phủ định và câu dài khiến tín hiệu TF-IDF khó diễn giải.</a:t>
             </a:r>
           </a:p>
         </p:txBody>
@@ -5130,6 +5235,7 @@
           <a:lstStyle xmlns:a="http://schemas.openxmlformats.org/drawingml/2006/main"/>
           <a:p xmlns:a="http://schemas.openxmlformats.org/drawingml/2006/main">
             <a:pPr algn="l">
+              <a:buNone/>
               <a:defRPr sz="2250" b="1">
                 <a:solidFill>
                   <a:srgbClr val="78A7FF"/>
@@ -5148,7 +5254,7 @@
                 <a:ea typeface="Helvetica Neue"/>
                 <a:cs typeface="Helvetica Neue"/>
               </a:rPr>
-              <a:t>1 / 15</a:t>
+              <a:t>2 / 15</a:t>
             </a:r>
           </a:p>
         </p:txBody>
@@ -5187,6 +5293,7 @@
           <a:lstStyle xmlns:a="http://schemas.openxmlformats.org/drawingml/2006/main"/>
           <a:p xmlns:a="http://schemas.openxmlformats.org/drawingml/2006/main">
             <a:pPr algn="l">
+              <a:buNone/>
               <a:defRPr sz="1875" b="1">
                 <a:solidFill>
                   <a:srgbClr val="F4F7FB"/>
@@ -5205,7 +5312,7 @@
                 <a:ea typeface="Helvetica Neue"/>
                 <a:cs typeface="Helvetica Neue"/>
               </a:rPr>
-              <a:t>Review dài, đa khía cạnh</a:t>
+              <a:t>Nhãn hoặc tín hiệu chưa rõ</a:t>
             </a:r>
           </a:p>
         </p:txBody>
@@ -5244,6 +5351,7 @@
           <a:lstStyle xmlns:a="http://schemas.openxmlformats.org/drawingml/2006/main"/>
           <a:p xmlns:a="http://schemas.openxmlformats.org/drawingml/2006/main">
             <a:pPr algn="l">
+              <a:buNone/>
               <a:defRPr sz="1425" b="0">
                 <a:solidFill>
                   <a:srgbClr val="A7B3C4"/>
@@ -5262,7 +5370,7 @@
                 <a:ea typeface="Helvetica Neue"/>
                 <a:cs typeface="Helvetica Neue"/>
               </a:rPr>
-              <a:t>Nhiều thời điểm và chủ đề khiến TF-IDF khó tổng hợp thành một cực tính.</a:t>
+              <a:t>Rating và nội dung có thể lệch nhau; một số câu có ít từ model nhận ra.</a:t>
             </a:r>
           </a:p>
         </p:txBody>
@@ -5301,6 +5409,7 @@
           <a:lstStyle xmlns:a="http://schemas.openxmlformats.org/drawingml/2006/main"/>
           <a:p xmlns:a="http://schemas.openxmlformats.org/drawingml/2006/main">
             <a:pPr algn="l">
+              <a:buNone/>
               <a:defRPr sz="1425" b="0">
                 <a:solidFill>
                   <a:srgbClr val="45D9A0"/>
@@ -5319,7 +5428,7 @@
                 <a:ea typeface="Helvetica Neue"/>
                 <a:cs typeface="Helvetica Neue"/>
               </a:rPr>
-              <a:t>Hướng cải thiện phù hợp: gán nhãn thủ công một tập nhỏ và mở rộng sang phân tích cảm xúc theo khía cạnh.</a:t>
+              <a:t>Nhóm lỗi là gợi ý tự động; cần đọc và gán nhãn thủ công thêm trước khi kết luận nguyên nhân.</a:t>
             </a:r>
           </a:p>
         </p:txBody>
@@ -5387,6 +5496,7 @@
           <a:lstStyle xmlns:a="http://schemas.openxmlformats.org/drawingml/2006/main"/>
           <a:p xmlns:a="http://schemas.openxmlformats.org/drawingml/2006/main">
             <a:pPr algn="l">
+              <a:buNone/>
               <a:defRPr sz="1050" b="1">
                 <a:solidFill>
                   <a:srgbClr val="78A7FF"/>
@@ -5444,6 +5554,7 @@
           <a:lstStyle xmlns:a="http://schemas.openxmlformats.org/drawingml/2006/main"/>
           <a:p xmlns:a="http://schemas.openxmlformats.org/drawingml/2006/main">
             <a:pPr algn="l">
+              <a:buNone/>
               <a:defRPr sz="3150" b="1">
                 <a:solidFill>
                   <a:srgbClr val="F4F7FB"/>
@@ -5532,6 +5643,7 @@
           <a:lstStyle xmlns:a="http://schemas.openxmlformats.org/drawingml/2006/main"/>
           <a:p xmlns:a="http://schemas.openxmlformats.org/drawingml/2006/main">
             <a:pPr algn="r">
+              <a:buNone/>
               <a:defRPr sz="900" b="0">
                 <a:solidFill>
                   <a:srgbClr val="A7B3C4"/>
@@ -5557,7 +5669,7 @@
       </p:sp>
       <p:graphicFrame>
         <p:nvGraphicFramePr>
-          <p:cNvPr id="20" name="Chart"/>
+          <p:cNvPr id="22" name="Chart"/>
           <p:cNvGraphicFramePr/>
           <p:nvPr/>
         </p:nvGraphicFramePr>
@@ -5567,7 +5679,7 @@
         </p:xfrm>
         <a:graphic xmlns:a="http://schemas.openxmlformats.org/drawingml/2006/main">
           <a:graphicData uri="http://schemas.openxmlformats.org/drawingml/2006/chart">
-            <c:chart xmlns:r="http://schemas.openxmlformats.org/officeDocument/2006/relationships" xmlns:c="http://schemas.openxmlformats.org/drawingml/2006/chart" r:id="R381f9b6847f64fac"/>
+            <c:chart xmlns:r="http://schemas.openxmlformats.org/officeDocument/2006/relationships" xmlns:c="http://schemas.openxmlformats.org/drawingml/2006/chart" r:id="R0f0d06d4599148b7"/>
           </a:graphicData>
         </a:graphic>
       </p:graphicFrame>
@@ -5638,6 +5750,7 @@
           <a:lstStyle xmlns:a="http://schemas.openxmlformats.org/drawingml/2006/main"/>
           <a:p xmlns:a="http://schemas.openxmlformats.org/drawingml/2006/main">
             <a:pPr algn="l">
+              <a:buNone/>
               <a:defRPr sz="1500" b="1">
                 <a:solidFill>
                   <a:srgbClr val="F4F7FB"/>
@@ -5695,6 +5808,7 @@
           <a:lstStyle xmlns:a="http://schemas.openxmlformats.org/drawingml/2006/main"/>
           <a:p xmlns:a="http://schemas.openxmlformats.org/drawingml/2006/main">
             <a:pPr algn="l">
+              <a:buNone/>
               <a:defRPr sz="1275" b="0">
                 <a:solidFill>
                   <a:srgbClr val="A7B3C4"/>
@@ -5785,6 +5899,7 @@
           <a:lstStyle xmlns:a="http://schemas.openxmlformats.org/drawingml/2006/main"/>
           <a:p xmlns:a="http://schemas.openxmlformats.org/drawingml/2006/main">
             <a:pPr algn="l">
+              <a:buNone/>
               <a:defRPr sz="1500" b="1">
                 <a:solidFill>
                   <a:srgbClr val="F4F7FB"/>
@@ -5842,6 +5957,7 @@
           <a:lstStyle xmlns:a="http://schemas.openxmlformats.org/drawingml/2006/main"/>
           <a:p xmlns:a="http://schemas.openxmlformats.org/drawingml/2006/main">
             <a:pPr algn="l">
+              <a:buNone/>
               <a:defRPr sz="1275" b="0">
                 <a:solidFill>
                   <a:srgbClr val="A7B3C4"/>
@@ -5932,6 +6048,7 @@
           <a:lstStyle xmlns:a="http://schemas.openxmlformats.org/drawingml/2006/main"/>
           <a:p xmlns:a="http://schemas.openxmlformats.org/drawingml/2006/main">
             <a:pPr algn="l">
+              <a:buNone/>
               <a:defRPr sz="1500" b="1">
                 <a:solidFill>
                   <a:srgbClr val="F4F7FB"/>
@@ -5989,6 +6106,7 @@
           <a:lstStyle xmlns:a="http://schemas.openxmlformats.org/drawingml/2006/main"/>
           <a:p xmlns:a="http://schemas.openxmlformats.org/drawingml/2006/main">
             <a:pPr algn="l">
+              <a:buNone/>
               <a:defRPr sz="1275" b="0">
                 <a:solidFill>
                   <a:srgbClr val="A7B3C4"/>
@@ -6046,6 +6164,7 @@
           <a:lstStyle xmlns:a="http://schemas.openxmlformats.org/drawingml/2006/main"/>
           <a:p xmlns:a="http://schemas.openxmlformats.org/drawingml/2006/main">
             <a:pPr algn="l">
+              <a:buNone/>
               <a:defRPr sz="1350" b="0">
                 <a:solidFill>
                   <a:srgbClr val="A7B3C4"/>
@@ -6132,6 +6251,7 @@
           <a:lstStyle xmlns:a="http://schemas.openxmlformats.org/drawingml/2006/main"/>
           <a:p xmlns:a="http://schemas.openxmlformats.org/drawingml/2006/main">
             <a:pPr algn="l">
+              <a:buNone/>
               <a:defRPr sz="1050" b="1">
                 <a:solidFill>
                   <a:srgbClr val="78A7FF"/>
@@ -6189,6 +6309,7 @@
           <a:lstStyle xmlns:a="http://schemas.openxmlformats.org/drawingml/2006/main"/>
           <a:p xmlns:a="http://schemas.openxmlformats.org/drawingml/2006/main">
             <a:pPr algn="l">
+              <a:buNone/>
               <a:defRPr sz="3150" b="1">
                 <a:solidFill>
                   <a:srgbClr val="F4F7FB"/>
@@ -6277,6 +6398,7 @@
           <a:lstStyle xmlns:a="http://schemas.openxmlformats.org/drawingml/2006/main"/>
           <a:p xmlns:a="http://schemas.openxmlformats.org/drawingml/2006/main">
             <a:pPr algn="r">
+              <a:buNone/>
               <a:defRPr sz="900" b="0">
                 <a:solidFill>
                   <a:srgbClr val="A7B3C4"/>
@@ -6302,7 +6424,7 @@
       </p:sp>
       <p:graphicFrame>
         <p:nvGraphicFramePr>
-          <p:cNvPr id="17" name="Chart"/>
+          <p:cNvPr id="19" name="Chart"/>
           <p:cNvGraphicFramePr/>
           <p:nvPr/>
         </p:nvGraphicFramePr>
@@ -6312,7 +6434,7 @@
         </p:xfrm>
         <a:graphic xmlns:a="http://schemas.openxmlformats.org/drawingml/2006/main">
           <a:graphicData uri="http://schemas.openxmlformats.org/drawingml/2006/chart">
-            <c:chart xmlns:r="http://schemas.openxmlformats.org/officeDocument/2006/relationships" xmlns:c="http://schemas.openxmlformats.org/drawingml/2006/chart" r:id="Rbc55fee72ab84298"/>
+            <c:chart xmlns:r="http://schemas.openxmlformats.org/officeDocument/2006/relationships" xmlns:c="http://schemas.openxmlformats.org/drawingml/2006/chart" r:id="Rc85f94e2a97d4378"/>
           </a:graphicData>
         </a:graphic>
       </p:graphicFrame>
@@ -6350,6 +6472,7 @@
           <a:lstStyle xmlns:a="http://schemas.openxmlformats.org/drawingml/2006/main"/>
           <a:p xmlns:a="http://schemas.openxmlformats.org/drawingml/2006/main">
             <a:pPr algn="r">
+              <a:buNone/>
               <a:defRPr sz="900" b="1">
                 <a:solidFill>
                   <a:srgbClr val="A7B3C4"/>
@@ -6368,7 +6491,7 @@
                 <a:ea typeface="Helvetica Neue"/>
                 <a:cs typeface="Helvetica Neue"/>
               </a:rPr>
-              <a:t>TRỌNG SỐ TF-IDF (%)</a:t>
+              <a:t>TRỌNG SỐ TF-IDF (×100)</a:t>
             </a:r>
           </a:p>
         </p:txBody>
@@ -6407,6 +6530,7 @@
           <a:lstStyle xmlns:a="http://schemas.openxmlformats.org/drawingml/2006/main"/>
           <a:p xmlns:a="http://schemas.openxmlformats.org/drawingml/2006/main">
             <a:pPr algn="l">
+              <a:buNone/>
               <a:defRPr sz="975" b="1">
                 <a:solidFill>
                   <a:srgbClr val="FF667B"/>
@@ -6464,6 +6588,7 @@
           <a:lstStyle xmlns:a="http://schemas.openxmlformats.org/drawingml/2006/main"/>
           <a:p xmlns:a="http://schemas.openxmlformats.org/drawingml/2006/main">
             <a:pPr algn="l">
+              <a:buNone/>
               <a:defRPr sz="2850" b="1">
                 <a:solidFill>
                   <a:srgbClr val="F4F7FB"/>
@@ -6482,7 +6607,7 @@
                 <a:ea typeface="Helvetica Neue"/>
                 <a:cs typeface="Helvetica Neue"/>
               </a:rPr>
-              <a:t>84,3%</a:t>
+              <a:t>99,0%</a:t>
             </a:r>
           </a:p>
         </p:txBody>
@@ -6521,6 +6646,7 @@
           <a:lstStyle xmlns:a="http://schemas.openxmlformats.org/drawingml/2006/main"/>
           <a:p xmlns:a="http://schemas.openxmlformats.org/drawingml/2006/main">
             <a:pPr algn="l">
+              <a:buNone/>
               <a:defRPr sz="1575" b="1">
                 <a:solidFill>
                   <a:srgbClr val="78A7FF"/>
@@ -6539,7 +6665,7 @@
                 <a:ea typeface="Helvetica Neue"/>
                 <a:cs typeface="Helvetica Neue"/>
               </a:rPr>
-              <a:t>Bigram có mặt</a:t>
+              <a:t>Cụm từ được giữ lại</a:t>
             </a:r>
           </a:p>
         </p:txBody>
@@ -6578,6 +6704,7 @@
           <a:lstStyle xmlns:a="http://schemas.openxmlformats.org/drawingml/2006/main"/>
           <a:p xmlns:a="http://schemas.openxmlformats.org/drawingml/2006/main">
             <a:pPr algn="l">
+              <a:buNone/>
               <a:defRPr sz="1500" b="0">
                 <a:solidFill>
                   <a:srgbClr val="A7B3C4"/>
@@ -6596,7 +6723,7 @@
                 <a:ea typeface="Helvetica Neue"/>
                 <a:cs typeface="Helvetica Neue"/>
               </a:rPr>
-              <a:t>“không lương” là một đặc trưng riêng trong từ vựng.</a:t>
+              <a:t>“không lương” và “lương thấp” là các đặc trưng riêng.</a:t>
             </a:r>
           </a:p>
         </p:txBody>
@@ -6635,6 +6762,7 @@
           <a:lstStyle xmlns:a="http://schemas.openxmlformats.org/drawingml/2006/main"/>
           <a:p xmlns:a="http://schemas.openxmlformats.org/drawingml/2006/main">
             <a:pPr algn="l">
+              <a:buNone/>
               <a:defRPr sz="1575" b="1">
                 <a:solidFill>
                   <a:srgbClr val="F4D35E"/>
@@ -6692,6 +6820,7 @@
           <a:lstStyle xmlns:a="http://schemas.openxmlformats.org/drawingml/2006/main"/>
           <a:p xmlns:a="http://schemas.openxmlformats.org/drawingml/2006/main">
             <a:pPr algn="l">
+              <a:buNone/>
               <a:defRPr sz="1425" b="0">
                 <a:solidFill>
                   <a:srgbClr val="A7B3C4"/>
@@ -6710,7 +6839,7 @@
                 <a:ea typeface="Helvetica Neue"/>
                 <a:cs typeface="Helvetica Neue"/>
               </a:rPr>
-              <a:t>Trọng số TF-IDF chỉ phản ánh mức nổi bật trong câu. Muốn biết chiều tác động cần kết hợp hệ số của mô hình.</a:t>
+              <a:t>Trọng số TF-IDF cho biết độ nổi bật. Muốn biết chiều tác động cần xem thêm hệ số Logistic Regression.</a:t>
             </a:r>
           </a:p>
         </p:txBody>
@@ -6778,6 +6907,7 @@
           <a:lstStyle xmlns:a="http://schemas.openxmlformats.org/drawingml/2006/main"/>
           <a:p xmlns:a="http://schemas.openxmlformats.org/drawingml/2006/main">
             <a:pPr algn="l">
+              <a:buNone/>
               <a:defRPr sz="1050" b="1">
                 <a:solidFill>
                   <a:srgbClr val="78A7FF"/>
@@ -6830,11 +6960,12 @@
         </p:spPr>
         <p:txBody>
           <a:bodyPr xmlns:a="http://schemas.openxmlformats.org/drawingml/2006/main" anchor="t">
-            <a:normAutofit fontScale="86589"/>
-          </a:bodyPr>
-          <a:lstStyle xmlns:a="http://schemas.openxmlformats.org/drawingml/2006/main"/>
-          <a:p xmlns:a="http://schemas.openxmlformats.org/drawingml/2006/main">
-            <a:pPr algn="l">
+            <a:normAutofit fontScale="100000"/>
+          </a:bodyPr>
+          <a:lstStyle xmlns:a="http://schemas.openxmlformats.org/drawingml/2006/main"/>
+          <a:p xmlns:a="http://schemas.openxmlformats.org/drawingml/2006/main">
+            <a:pPr algn="l">
+              <a:buNone/>
               <a:defRPr sz="3150" b="1">
                 <a:solidFill>
                   <a:srgbClr val="F4F7FB"/>
@@ -6853,7 +6984,7 @@
                 <a:ea typeface="Helvetica Neue"/>
                 <a:cs typeface="Helvetica Neue"/>
               </a:rPr>
-              <a:t>Kết quả ổn định, nhưng trần hiệu năng bị giới hạn bởi nhãn yếu</a:t>
+              <a:t>Bản sửa tốt hơn một chút, nhưng lớp Negative vẫn khó</a:t>
             </a:r>
           </a:p>
         </p:txBody>
@@ -6923,6 +7054,7 @@
           <a:lstStyle xmlns:a="http://schemas.openxmlformats.org/drawingml/2006/main"/>
           <a:p xmlns:a="http://schemas.openxmlformats.org/drawingml/2006/main">
             <a:pPr algn="r">
+              <a:buNone/>
               <a:defRPr sz="900" b="0">
                 <a:solidFill>
                   <a:srgbClr val="A7B3C4"/>
@@ -6980,6 +7112,7 @@
           <a:lstStyle xmlns:a="http://schemas.openxmlformats.org/drawingml/2006/main"/>
           <a:p xmlns:a="http://schemas.openxmlformats.org/drawingml/2006/main">
             <a:pPr algn="l">
+              <a:buNone/>
               <a:defRPr sz="1875" b="1">
                 <a:solidFill>
                   <a:srgbClr val="45D9A0"/>
@@ -7070,6 +7203,7 @@
           <a:lstStyle xmlns:a="http://schemas.openxmlformats.org/drawingml/2006/main"/>
           <a:p xmlns:a="http://schemas.openxmlformats.org/drawingml/2006/main">
             <a:pPr algn="l">
+              <a:buNone/>
               <a:defRPr sz="1575" b="0">
                 <a:solidFill>
                   <a:srgbClr val="F4F7FB"/>
@@ -7160,6 +7294,7 @@
           <a:lstStyle xmlns:a="http://schemas.openxmlformats.org/drawingml/2006/main"/>
           <a:p xmlns:a="http://schemas.openxmlformats.org/drawingml/2006/main">
             <a:pPr algn="l">
+              <a:buNone/>
               <a:defRPr sz="1575" b="0">
                 <a:solidFill>
                   <a:srgbClr val="A7B3C4"/>
@@ -7250,6 +7385,7 @@
           <a:lstStyle xmlns:a="http://schemas.openxmlformats.org/drawingml/2006/main"/>
           <a:p xmlns:a="http://schemas.openxmlformats.org/drawingml/2006/main">
             <a:pPr algn="l">
+              <a:buNone/>
               <a:defRPr sz="1575" b="0">
                 <a:solidFill>
                   <a:srgbClr val="A7B3C4"/>
@@ -7268,7 +7404,7 @@
                 <a:ea typeface="Helvetica Neue"/>
                 <a:cs typeface="Helvetica Neue"/>
               </a:rPr>
-              <a:t>Final Test khóa và web demo</a:t>
+              <a:t>Đối chiếu lại Final Test cũ</a:t>
             </a:r>
           </a:p>
         </p:txBody>
@@ -7338,6 +7474,7 @@
           <a:lstStyle xmlns:a="http://schemas.openxmlformats.org/drawingml/2006/main"/>
           <a:p xmlns:a="http://schemas.openxmlformats.org/drawingml/2006/main">
             <a:pPr algn="l">
+              <a:buNone/>
               <a:defRPr sz="1875" b="1">
                 <a:solidFill>
                   <a:srgbClr val="78A7FF"/>
@@ -7428,6 +7565,7 @@
           <a:lstStyle xmlns:a="http://schemas.openxmlformats.org/drawingml/2006/main"/>
           <a:p xmlns:a="http://schemas.openxmlformats.org/drawingml/2006/main">
             <a:pPr algn="l">
+              <a:buNone/>
               <a:defRPr sz="1575" b="0">
                 <a:solidFill>
                   <a:srgbClr val="F4F7FB"/>
@@ -7518,6 +7656,7 @@
           <a:lstStyle xmlns:a="http://schemas.openxmlformats.org/drawingml/2006/main"/>
           <a:p xmlns:a="http://schemas.openxmlformats.org/drawingml/2006/main">
             <a:pPr algn="l">
+              <a:buNone/>
               <a:defRPr sz="1575" b="0">
                 <a:solidFill>
                   <a:srgbClr val="A7B3C4"/>
@@ -7608,6 +7747,7 @@
           <a:lstStyle xmlns:a="http://schemas.openxmlformats.org/drawingml/2006/main"/>
           <a:p xmlns:a="http://schemas.openxmlformats.org/drawingml/2006/main">
             <a:pPr algn="l">
+              <a:buNone/>
               <a:defRPr sz="1575" b="0">
                 <a:solidFill>
                   <a:srgbClr val="A7B3C4"/>
@@ -7696,6 +7836,7 @@
           <a:lstStyle xmlns:a="http://schemas.openxmlformats.org/drawingml/2006/main"/>
           <a:p xmlns:a="http://schemas.openxmlformats.org/drawingml/2006/main">
             <a:pPr algn="l">
+              <a:buNone/>
               <a:defRPr sz="1875" b="1">
                 <a:solidFill>
                   <a:srgbClr val="FF9C5A"/>
@@ -7786,6 +7927,7 @@
           <a:lstStyle xmlns:a="http://schemas.openxmlformats.org/drawingml/2006/main"/>
           <a:p xmlns:a="http://schemas.openxmlformats.org/drawingml/2006/main">
             <a:pPr algn="l">
+              <a:buNone/>
               <a:defRPr sz="1575" b="0">
                 <a:solidFill>
                   <a:srgbClr val="F4F7FB"/>
@@ -7876,6 +8018,7 @@
           <a:lstStyle xmlns:a="http://schemas.openxmlformats.org/drawingml/2006/main"/>
           <a:p xmlns:a="http://schemas.openxmlformats.org/drawingml/2006/main">
             <a:pPr algn="l">
+              <a:buNone/>
               <a:defRPr sz="1575" b="0">
                 <a:solidFill>
                   <a:srgbClr val="A7B3C4"/>
@@ -7894,7 +8037,7 @@
                 <a:ea typeface="Helvetica Neue"/>
                 <a:cs typeface="Helvetica Neue"/>
               </a:rPr>
-              <a:t>Negative F1 chỉ đạt 0,3806</a:t>
+              <a:t>Negative F1 chỉ đạt 0,3910</a:t>
             </a:r>
           </a:p>
         </p:txBody>
@@ -7966,6 +8109,7 @@
           <a:lstStyle xmlns:a="http://schemas.openxmlformats.org/drawingml/2006/main"/>
           <a:p xmlns:a="http://schemas.openxmlformats.org/drawingml/2006/main">
             <a:pPr algn="l">
+              <a:buNone/>
               <a:defRPr sz="1575" b="0">
                 <a:solidFill>
                   <a:srgbClr val="A7B3C4"/>
@@ -8023,6 +8167,7 @@
           <a:lstStyle xmlns:a="http://schemas.openxmlformats.org/drawingml/2006/main"/>
           <a:p xmlns:a="http://schemas.openxmlformats.org/drawingml/2006/main">
             <a:pPr algn="l">
+              <a:buNone/>
               <a:defRPr sz="1425" b="0">
                 <a:solidFill>
                   <a:srgbClr val="45D9A0"/>
@@ -8041,7 +8186,7 @@
                 <a:ea typeface="Helvetica Neue"/>
                 <a:cs typeface="Helvetica Neue"/>
               </a:rPr>
-              <a:t>CV Macro F1 0,5727 và Final Test 0,5714 chỉ chênh 0,0014, chưa cho thấy overfitting nghiêm trọng.</a:t>
+              <a:t>CV Macro F1 0,5815; Final Test cũ 0,5764. Chênh 0,0052, chưa thấy lệch lớn.</a:t>
             </a:r>
           </a:p>
         </p:txBody>
@@ -8109,6 +8254,7 @@
           <a:lstStyle xmlns:a="http://schemas.openxmlformats.org/drawingml/2006/main"/>
           <a:p xmlns:a="http://schemas.openxmlformats.org/drawingml/2006/main">
             <a:pPr algn="l">
+              <a:buNone/>
               <a:defRPr sz="1050" b="1">
                 <a:solidFill>
                   <a:srgbClr val="78A7FF"/>
@@ -8166,6 +8312,7 @@
           <a:lstStyle xmlns:a="http://schemas.openxmlformats.org/drawingml/2006/main"/>
           <a:p xmlns:a="http://schemas.openxmlformats.org/drawingml/2006/main">
             <a:pPr algn="l">
+              <a:buNone/>
               <a:defRPr sz="3150" b="1">
                 <a:solidFill>
                   <a:srgbClr val="F4F7FB"/>
@@ -8254,6 +8401,7 @@
           <a:lstStyle xmlns:a="http://schemas.openxmlformats.org/drawingml/2006/main"/>
           <a:p xmlns:a="http://schemas.openxmlformats.org/drawingml/2006/main">
             <a:pPr algn="r">
+              <a:buNone/>
               <a:defRPr sz="900" b="0">
                 <a:solidFill>
                   <a:srgbClr val="A7B3C4"/>
@@ -8311,6 +8459,7 @@
           <a:lstStyle xmlns:a="http://schemas.openxmlformats.org/drawingml/2006/main"/>
           <a:p xmlns:a="http://schemas.openxmlformats.org/drawingml/2006/main">
             <a:pPr algn="l">
+              <a:buNone/>
               <a:defRPr sz="1950" b="1">
                 <a:solidFill>
                   <a:srgbClr val="45D9A0"/>
@@ -8401,6 +8550,7 @@
           <a:lstStyle xmlns:a="http://schemas.openxmlformats.org/drawingml/2006/main"/>
           <a:p xmlns:a="http://schemas.openxmlformats.org/drawingml/2006/main">
             <a:pPr algn="l">
+              <a:buNone/>
               <a:defRPr sz="1650" b="1">
                 <a:solidFill>
                   <a:srgbClr val="F4F7FB"/>
@@ -8458,6 +8608,7 @@
           <a:lstStyle xmlns:a="http://schemas.openxmlformats.org/drawingml/2006/main"/>
           <a:p xmlns:a="http://schemas.openxmlformats.org/drawingml/2006/main">
             <a:pPr algn="l">
+              <a:buNone/>
               <a:defRPr sz="1350" b="0">
                 <a:solidFill>
                   <a:srgbClr val="A7B3C4"/>
@@ -8548,6 +8699,7 @@
           <a:lstStyle xmlns:a="http://schemas.openxmlformats.org/drawingml/2006/main"/>
           <a:p xmlns:a="http://schemas.openxmlformats.org/drawingml/2006/main">
             <a:pPr algn="l">
+              <a:buNone/>
               <a:defRPr sz="1650" b="1">
                 <a:solidFill>
                   <a:srgbClr val="F4F7FB"/>
@@ -8605,6 +8757,7 @@
           <a:lstStyle xmlns:a="http://schemas.openxmlformats.org/drawingml/2006/main"/>
           <a:p xmlns:a="http://schemas.openxmlformats.org/drawingml/2006/main">
             <a:pPr algn="l">
+              <a:buNone/>
               <a:defRPr sz="1350" b="0">
                 <a:solidFill>
                   <a:srgbClr val="A7B3C4"/>
@@ -8623,7 +8776,7 @@
                 <a:ea typeface="Helvetica Neue"/>
                 <a:cs typeface="Helvetica Neue"/>
               </a:rPr>
-              <a:t>Chọn model trên Development và mở Final Test một lần.</a:t>
+              <a:t>Chọn bản sửa bằng CV; đối chiếu trên Final Test cũ.</a:t>
             </a:r>
           </a:p>
         </p:txBody>
@@ -8695,6 +8848,7 @@
           <a:lstStyle xmlns:a="http://schemas.openxmlformats.org/drawingml/2006/main"/>
           <a:p xmlns:a="http://schemas.openxmlformats.org/drawingml/2006/main">
             <a:pPr algn="l">
+              <a:buNone/>
               <a:defRPr sz="1650" b="1">
                 <a:solidFill>
                   <a:srgbClr val="F4F7FB"/>
@@ -8752,6 +8906,7 @@
           <a:lstStyle xmlns:a="http://schemas.openxmlformats.org/drawingml/2006/main"/>
           <a:p xmlns:a="http://schemas.openxmlformats.org/drawingml/2006/main">
             <a:pPr algn="l">
+              <a:buNone/>
               <a:defRPr sz="1350" b="0">
                 <a:solidFill>
                   <a:srgbClr val="A7B3C4"/>
@@ -8840,6 +8995,7 @@
           <a:lstStyle xmlns:a="http://schemas.openxmlformats.org/drawingml/2006/main"/>
           <a:p xmlns:a="http://schemas.openxmlformats.org/drawingml/2006/main">
             <a:pPr algn="l">
+              <a:buNone/>
               <a:defRPr sz="1950" b="1">
                 <a:solidFill>
                   <a:srgbClr val="78A7FF"/>
@@ -8930,6 +9086,7 @@
           <a:lstStyle xmlns:a="http://schemas.openxmlformats.org/drawingml/2006/main"/>
           <a:p xmlns:a="http://schemas.openxmlformats.org/drawingml/2006/main">
             <a:pPr algn="l">
+              <a:buNone/>
               <a:defRPr sz="1650" b="1">
                 <a:solidFill>
                   <a:srgbClr val="F4F7FB"/>
@@ -8987,6 +9144,7 @@
           <a:lstStyle xmlns:a="http://schemas.openxmlformats.org/drawingml/2006/main"/>
           <a:p xmlns:a="http://schemas.openxmlformats.org/drawingml/2006/main">
             <a:pPr algn="l">
+              <a:buNone/>
               <a:defRPr sz="1350" b="0">
                 <a:solidFill>
                   <a:srgbClr val="A7B3C4"/>
@@ -9077,6 +9235,7 @@
           <a:lstStyle xmlns:a="http://schemas.openxmlformats.org/drawingml/2006/main"/>
           <a:p xmlns:a="http://schemas.openxmlformats.org/drawingml/2006/main">
             <a:pPr algn="l">
+              <a:buNone/>
               <a:defRPr sz="1650" b="1">
                 <a:solidFill>
                   <a:srgbClr val="F4F7FB"/>
@@ -9134,6 +9293,7 @@
           <a:lstStyle xmlns:a="http://schemas.openxmlformats.org/drawingml/2006/main"/>
           <a:p xmlns:a="http://schemas.openxmlformats.org/drawingml/2006/main">
             <a:pPr algn="l">
+              <a:buNone/>
               <a:defRPr sz="1350" b="0">
                 <a:solidFill>
                   <a:srgbClr val="A7B3C4"/>
@@ -9224,6 +9384,7 @@
           <a:lstStyle xmlns:a="http://schemas.openxmlformats.org/drawingml/2006/main"/>
           <a:p xmlns:a="http://schemas.openxmlformats.org/drawingml/2006/main">
             <a:pPr algn="l">
+              <a:buNone/>
               <a:defRPr sz="1650" b="1">
                 <a:solidFill>
                   <a:srgbClr val="F4F7FB"/>
@@ -9281,6 +9442,7 @@
           <a:lstStyle xmlns:a="http://schemas.openxmlformats.org/drawingml/2006/main"/>
           <a:p xmlns:a="http://schemas.openxmlformats.org/drawingml/2006/main">
             <a:pPr algn="l">
+              <a:buNone/>
               <a:defRPr sz="1350" b="0">
                 <a:solidFill>
                   <a:srgbClr val="A7B3C4"/>
@@ -9338,6 +9500,7 @@
           <a:lstStyle xmlns:a="http://schemas.openxmlformats.org/drawingml/2006/main"/>
           <a:p xmlns:a="http://schemas.openxmlformats.org/drawingml/2006/main">
             <a:pPr algn="l">
+              <a:buNone/>
               <a:defRPr sz="2100" b="1">
                 <a:solidFill>
                   <a:srgbClr val="45D9A0"/>
@@ -9424,6 +9587,7 @@
           <a:lstStyle xmlns:a="http://schemas.openxmlformats.org/drawingml/2006/main"/>
           <a:p xmlns:a="http://schemas.openxmlformats.org/drawingml/2006/main">
             <a:pPr algn="l">
+              <a:buNone/>
               <a:defRPr sz="1050" b="1">
                 <a:solidFill>
                   <a:srgbClr val="78A7FF"/>
@@ -9481,6 +9645,7 @@
           <a:lstStyle xmlns:a="http://schemas.openxmlformats.org/drawingml/2006/main"/>
           <a:p xmlns:a="http://schemas.openxmlformats.org/drawingml/2006/main">
             <a:pPr algn="l">
+              <a:buNone/>
               <a:defRPr sz="3150" b="1">
                 <a:solidFill>
                   <a:srgbClr val="F4F7FB"/>
@@ -9569,6 +9734,7 @@
           <a:lstStyle xmlns:a="http://schemas.openxmlformats.org/drawingml/2006/main"/>
           <a:p xmlns:a="http://schemas.openxmlformats.org/drawingml/2006/main">
             <a:pPr algn="r">
+              <a:buNone/>
               <a:defRPr sz="900" b="0">
                 <a:solidFill>
                   <a:srgbClr val="A7B3C4"/>
@@ -9626,6 +9792,7 @@
           <a:lstStyle xmlns:a="http://schemas.openxmlformats.org/drawingml/2006/main"/>
           <a:p xmlns:a="http://schemas.openxmlformats.org/drawingml/2006/main">
             <a:pPr algn="l">
+              <a:buNone/>
               <a:defRPr sz="1050" b="1">
                 <a:solidFill>
                   <a:srgbClr val="78A7FF"/>
@@ -9683,6 +9850,7 @@
           <a:lstStyle xmlns:a="http://schemas.openxmlformats.org/drawingml/2006/main"/>
           <a:p xmlns:a="http://schemas.openxmlformats.org/drawingml/2006/main">
             <a:pPr algn="l">
+              <a:buNone/>
               <a:defRPr sz="2850" b="1">
                 <a:solidFill>
                   <a:srgbClr val="45D9A0"/>
@@ -9740,6 +9908,7 @@
           <a:lstStyle xmlns:a="http://schemas.openxmlformats.org/drawingml/2006/main"/>
           <a:p xmlns:a="http://schemas.openxmlformats.org/drawingml/2006/main">
             <a:pPr algn="l">
+              <a:buNone/>
               <a:defRPr sz="1725" b="0">
                 <a:solidFill>
                   <a:srgbClr val="A7B3C4"/>
@@ -9828,6 +9997,7 @@
           <a:lstStyle xmlns:a="http://schemas.openxmlformats.org/drawingml/2006/main"/>
           <a:p xmlns:a="http://schemas.openxmlformats.org/drawingml/2006/main">
             <a:pPr algn="l">
+              <a:buNone/>
               <a:defRPr sz="1800" b="1">
                 <a:solidFill>
                   <a:srgbClr val="78A7FF"/>
@@ -9885,6 +10055,7 @@
           <a:lstStyle xmlns:a="http://schemas.openxmlformats.org/drawingml/2006/main"/>
           <a:p xmlns:a="http://schemas.openxmlformats.org/drawingml/2006/main">
             <a:pPr algn="l">
+              <a:buNone/>
               <a:defRPr sz="1800" b="1">
                 <a:solidFill>
                   <a:srgbClr val="F4F7FB"/>
@@ -9903,7 +10074,7 @@
                 <a:ea typeface="Helvetica Neue"/>
                 <a:cs typeface="Helvetica Neue"/>
               </a:rPr>
-              <a:t>Nhập review mới</a:t>
+              <a:t>Chọn review mẫu</a:t>
             </a:r>
           </a:p>
         </p:txBody>
@@ -9937,11 +10108,12 @@
         </p:spPr>
         <p:txBody>
           <a:bodyPr xmlns:a="http://schemas.openxmlformats.org/drawingml/2006/main" anchor="t">
-            <a:normAutofit fontScale="98148"/>
-          </a:bodyPr>
-          <a:lstStyle xmlns:a="http://schemas.openxmlformats.org/drawingml/2006/main"/>
-          <a:p xmlns:a="http://schemas.openxmlformats.org/drawingml/2006/main">
-            <a:pPr algn="l">
+            <a:normAutofit fontScale="100000"/>
+          </a:bodyPr>
+          <a:lstStyle xmlns:a="http://schemas.openxmlformats.org/drawingml/2006/main"/>
+          <a:p xmlns:a="http://schemas.openxmlformats.org/drawingml/2006/main">
+            <a:pPr algn="l">
+              <a:buNone/>
               <a:defRPr sz="1350" b="0">
                 <a:solidFill>
                   <a:srgbClr val="A7B3C4"/>
@@ -9960,7 +10132,7 @@
                 <a:ea typeface="Helvetica Neue"/>
                 <a:cs typeface="Helvetica Neue"/>
               </a:rPr>
-              <a:t>Sử dụng một câu tiếng Việt chưa có trong dữ liệu huấn luyện</a:t>
+              <a:t>Bấm mẫu “Nhiều vế” có sẵn trong ứng dụng</a:t>
             </a:r>
           </a:p>
         </p:txBody>
@@ -9999,6 +10171,7 @@
           <a:lstStyle xmlns:a="http://schemas.openxmlformats.org/drawingml/2006/main"/>
           <a:p xmlns:a="http://schemas.openxmlformats.org/drawingml/2006/main">
             <a:pPr algn="l">
+              <a:buNone/>
               <a:defRPr sz="1800" b="1">
                 <a:solidFill>
                   <a:srgbClr val="45D9A0"/>
@@ -10056,6 +10229,7 @@
           <a:lstStyle xmlns:a="http://schemas.openxmlformats.org/drawingml/2006/main"/>
           <a:p xmlns:a="http://schemas.openxmlformats.org/drawingml/2006/main">
             <a:pPr algn="l">
+              <a:buNone/>
               <a:defRPr sz="1800" b="1">
                 <a:solidFill>
                   <a:srgbClr val="F4F7FB"/>
@@ -10113,6 +10287,7 @@
           <a:lstStyle xmlns:a="http://schemas.openxmlformats.org/drawingml/2006/main"/>
           <a:p xmlns:a="http://schemas.openxmlformats.org/drawingml/2006/main">
             <a:pPr algn="l">
+              <a:buNone/>
               <a:defRPr sz="1350" b="0">
                 <a:solidFill>
                   <a:srgbClr val="A7B3C4"/>
@@ -10170,6 +10345,7 @@
           <a:lstStyle xmlns:a="http://schemas.openxmlformats.org/drawingml/2006/main"/>
           <a:p xmlns:a="http://schemas.openxmlformats.org/drawingml/2006/main">
             <a:pPr algn="l">
+              <a:buNone/>
               <a:defRPr sz="1800" b="1">
                 <a:solidFill>
                   <a:srgbClr val="F4D35E"/>
@@ -10227,6 +10403,7 @@
           <a:lstStyle xmlns:a="http://schemas.openxmlformats.org/drawingml/2006/main"/>
           <a:p xmlns:a="http://schemas.openxmlformats.org/drawingml/2006/main">
             <a:pPr algn="l">
+              <a:buNone/>
               <a:defRPr sz="1800" b="1">
                 <a:solidFill>
                   <a:srgbClr val="F4F7FB"/>
@@ -10284,6 +10461,7 @@
           <a:lstStyle xmlns:a="http://schemas.openxmlformats.org/drawingml/2006/main"/>
           <a:p xmlns:a="http://schemas.openxmlformats.org/drawingml/2006/main">
             <a:pPr algn="l">
+              <a:buNone/>
               <a:defRPr sz="1350" b="0">
                 <a:solidFill>
                   <a:srgbClr val="A7B3C4"/>
@@ -10341,6 +10519,7 @@
           <a:lstStyle xmlns:a="http://schemas.openxmlformats.org/drawingml/2006/main"/>
           <a:p xmlns:a="http://schemas.openxmlformats.org/drawingml/2006/main">
             <a:pPr algn="l">
+              <a:buNone/>
               <a:defRPr sz="1500" b="0">
                 <a:solidFill>
                   <a:srgbClr val="45D9A0"/>
@@ -10427,6 +10606,7 @@
           <a:lstStyle xmlns:a="http://schemas.openxmlformats.org/drawingml/2006/main"/>
           <a:p xmlns:a="http://schemas.openxmlformats.org/drawingml/2006/main">
             <a:pPr algn="l">
+              <a:buNone/>
               <a:defRPr sz="1050" b="1">
                 <a:solidFill>
                   <a:srgbClr val="78A7FF"/>
@@ -10484,6 +10664,7 @@
           <a:lstStyle xmlns:a="http://schemas.openxmlformats.org/drawingml/2006/main"/>
           <a:p xmlns:a="http://schemas.openxmlformats.org/drawingml/2006/main">
             <a:pPr algn="l">
+              <a:buNone/>
               <a:defRPr sz="3150" b="1">
                 <a:solidFill>
                   <a:srgbClr val="F4F7FB"/>
@@ -10572,6 +10753,7 @@
           <a:lstStyle xmlns:a="http://schemas.openxmlformats.org/drawingml/2006/main"/>
           <a:p xmlns:a="http://schemas.openxmlformats.org/drawingml/2006/main">
             <a:pPr algn="r">
+              <a:buNone/>
               <a:defRPr sz="900" b="0">
                 <a:solidFill>
                   <a:srgbClr val="A7B3C4"/>
@@ -10629,6 +10811,7 @@
           <a:lstStyle xmlns:a="http://schemas.openxmlformats.org/drawingml/2006/main"/>
           <a:p xmlns:a="http://schemas.openxmlformats.org/drawingml/2006/main">
             <a:pPr algn="l">
+              <a:buNone/>
               <a:defRPr sz="975" b="1">
                 <a:solidFill>
                   <a:srgbClr val="FF9C5A"/>
@@ -10686,6 +10869,7 @@
           <a:lstStyle xmlns:a="http://schemas.openxmlformats.org/drawingml/2006/main"/>
           <a:p xmlns:a="http://schemas.openxmlformats.org/drawingml/2006/main">
             <a:pPr algn="l">
+              <a:buNone/>
               <a:defRPr sz="2850" b="1">
                 <a:solidFill>
                   <a:srgbClr val="F4F7FB"/>
@@ -10743,6 +10927,7 @@
           <a:lstStyle xmlns:a="http://schemas.openxmlformats.org/drawingml/2006/main"/>
           <a:p xmlns:a="http://schemas.openxmlformats.org/drawingml/2006/main">
             <a:pPr algn="l">
+              <a:buNone/>
               <a:defRPr sz="1575" b="0">
                 <a:solidFill>
                   <a:srgbClr val="A7B3C4"/>
@@ -10768,7 +10953,7 @@
       </p:sp>
       <p:graphicFrame>
         <p:nvGraphicFramePr>
-          <p:cNvPr id="26" name="Chart"/>
+          <p:cNvPr id="28" name="Chart"/>
           <p:cNvGraphicFramePr/>
           <p:nvPr/>
         </p:nvGraphicFramePr>
@@ -10778,7 +10963,7 @@
         </p:xfrm>
         <a:graphic xmlns:a="http://schemas.openxmlformats.org/drawingml/2006/main">
           <a:graphicData uri="http://schemas.openxmlformats.org/drawingml/2006/chart">
-            <c:chart xmlns:r="http://schemas.openxmlformats.org/officeDocument/2006/relationships" xmlns:c="http://schemas.openxmlformats.org/drawingml/2006/chart" r:id="R8918c08e884f4be7"/>
+            <c:chart xmlns:r="http://schemas.openxmlformats.org/officeDocument/2006/relationships" xmlns:c="http://schemas.openxmlformats.org/drawingml/2006/chart" r:id="Rd715ca4579904bc8"/>
           </a:graphicData>
         </a:graphic>
       </p:graphicFrame>
@@ -10816,6 +11001,7 @@
           <a:lstStyle xmlns:a="http://schemas.openxmlformats.org/drawingml/2006/main"/>
           <a:p xmlns:a="http://schemas.openxmlformats.org/drawingml/2006/main">
             <a:pPr algn="l">
+              <a:buNone/>
               <a:defRPr sz="900" b="1">
                 <a:solidFill>
                   <a:srgbClr val="A7B3C4"/>
@@ -10906,6 +11092,7 @@
           <a:lstStyle xmlns:a="http://schemas.openxmlformats.org/drawingml/2006/main"/>
           <a:p xmlns:a="http://schemas.openxmlformats.org/drawingml/2006/main">
             <a:pPr algn="l">
+              <a:buNone/>
               <a:defRPr sz="1575" b="1">
                 <a:solidFill>
                   <a:srgbClr val="F4F7FB"/>
@@ -10963,6 +11150,7 @@
           <a:lstStyle xmlns:a="http://schemas.openxmlformats.org/drawingml/2006/main"/>
           <a:p xmlns:a="http://schemas.openxmlformats.org/drawingml/2006/main">
             <a:pPr algn="l">
+              <a:buNone/>
               <a:defRPr sz="1350" b="0">
                 <a:solidFill>
                   <a:srgbClr val="A7B3C4"/>
@@ -11053,6 +11241,7 @@
           <a:lstStyle xmlns:a="http://schemas.openxmlformats.org/drawingml/2006/main"/>
           <a:p xmlns:a="http://schemas.openxmlformats.org/drawingml/2006/main">
             <a:pPr algn="l">
+              <a:buNone/>
               <a:defRPr sz="1575" b="1">
                 <a:solidFill>
                   <a:srgbClr val="F4F7FB"/>
@@ -11110,6 +11299,7 @@
           <a:lstStyle xmlns:a="http://schemas.openxmlformats.org/drawingml/2006/main"/>
           <a:p xmlns:a="http://schemas.openxmlformats.org/drawingml/2006/main">
             <a:pPr algn="l">
+              <a:buNone/>
               <a:defRPr sz="1350" b="0">
                 <a:solidFill>
                   <a:srgbClr val="A7B3C4"/>
@@ -11200,6 +11390,7 @@
           <a:lstStyle xmlns:a="http://schemas.openxmlformats.org/drawingml/2006/main"/>
           <a:p xmlns:a="http://schemas.openxmlformats.org/drawingml/2006/main">
             <a:pPr algn="l">
+              <a:buNone/>
               <a:defRPr sz="1575" b="1">
                 <a:solidFill>
                   <a:srgbClr val="F4F7FB"/>
@@ -11257,6 +11448,7 @@
           <a:lstStyle xmlns:a="http://schemas.openxmlformats.org/drawingml/2006/main"/>
           <a:p xmlns:a="http://schemas.openxmlformats.org/drawingml/2006/main">
             <a:pPr algn="l">
+              <a:buNone/>
               <a:defRPr sz="1350" b="0">
                 <a:solidFill>
                   <a:srgbClr val="A7B3C4"/>
@@ -11343,6 +11535,7 @@
           <a:lstStyle xmlns:a="http://schemas.openxmlformats.org/drawingml/2006/main"/>
           <a:p xmlns:a="http://schemas.openxmlformats.org/drawingml/2006/main">
             <a:pPr algn="l">
+              <a:buNone/>
               <a:defRPr sz="1050" b="1">
                 <a:solidFill>
                   <a:srgbClr val="78A7FF"/>
@@ -11400,6 +11593,7 @@
           <a:lstStyle xmlns:a="http://schemas.openxmlformats.org/drawingml/2006/main"/>
           <a:p xmlns:a="http://schemas.openxmlformats.org/drawingml/2006/main">
             <a:pPr algn="l">
+              <a:buNone/>
               <a:defRPr sz="3150" b="1">
                 <a:solidFill>
                   <a:srgbClr val="F4F7FB"/>
@@ -11488,6 +11682,7 @@
           <a:lstStyle xmlns:a="http://schemas.openxmlformats.org/drawingml/2006/main"/>
           <a:p xmlns:a="http://schemas.openxmlformats.org/drawingml/2006/main">
             <a:pPr algn="r">
+              <a:buNone/>
               <a:defRPr sz="900" b="0">
                 <a:solidFill>
                   <a:srgbClr val="A7B3C4"/>
@@ -11545,6 +11740,7 @@
           <a:lstStyle xmlns:a="http://schemas.openxmlformats.org/drawingml/2006/main"/>
           <a:p xmlns:a="http://schemas.openxmlformats.org/drawingml/2006/main">
             <a:pPr algn="l">
+              <a:buNone/>
               <a:defRPr sz="1350" b="1">
                 <a:solidFill>
                   <a:srgbClr val="78A7FF"/>
@@ -11602,6 +11798,7 @@
           <a:lstStyle xmlns:a="http://schemas.openxmlformats.org/drawingml/2006/main"/>
           <a:p xmlns:a="http://schemas.openxmlformats.org/drawingml/2006/main">
             <a:pPr algn="l">
+              <a:buNone/>
               <a:defRPr sz="1875" b="1">
                 <a:solidFill>
                   <a:srgbClr val="F4F7FB"/>
@@ -11659,6 +11856,7 @@
           <a:lstStyle xmlns:a="http://schemas.openxmlformats.org/drawingml/2006/main"/>
           <a:p xmlns:a="http://schemas.openxmlformats.org/drawingml/2006/main">
             <a:pPr algn="l">
+              <a:buNone/>
               <a:defRPr sz="1275" b="0">
                 <a:solidFill>
                   <a:srgbClr val="A7B3C4"/>
@@ -11682,6 +11880,7 @@
           </a:p>
           <a:p xmlns:a="http://schemas.openxmlformats.org/drawingml/2006/main">
             <a:pPr algn="l">
+              <a:buNone/>
               <a:defRPr sz="1275" b="0">
                 <a:solidFill>
                   <a:srgbClr val="A7B3C4"/>
@@ -11772,6 +11971,7 @@
           <a:lstStyle xmlns:a="http://schemas.openxmlformats.org/drawingml/2006/main"/>
           <a:p xmlns:a="http://schemas.openxmlformats.org/drawingml/2006/main">
             <a:pPr algn="l">
+              <a:buNone/>
               <a:defRPr sz="1350" b="1">
                 <a:solidFill>
                   <a:srgbClr val="45D9A0"/>
@@ -11829,6 +12029,7 @@
           <a:lstStyle xmlns:a="http://schemas.openxmlformats.org/drawingml/2006/main"/>
           <a:p xmlns:a="http://schemas.openxmlformats.org/drawingml/2006/main">
             <a:pPr algn="l">
+              <a:buNone/>
               <a:defRPr sz="1875" b="1">
                 <a:solidFill>
                   <a:srgbClr val="F4F7FB"/>
@@ -11886,6 +12087,7 @@
           <a:lstStyle xmlns:a="http://schemas.openxmlformats.org/drawingml/2006/main"/>
           <a:p xmlns:a="http://schemas.openxmlformats.org/drawingml/2006/main">
             <a:pPr algn="l">
+              <a:buNone/>
               <a:defRPr sz="1275" b="0">
                 <a:solidFill>
                   <a:srgbClr val="A7B3C4"/>
@@ -11909,6 +12111,7 @@
           </a:p>
           <a:p xmlns:a="http://schemas.openxmlformats.org/drawingml/2006/main">
             <a:pPr algn="l">
+              <a:buNone/>
               <a:defRPr sz="1275" b="0">
                 <a:solidFill>
                   <a:srgbClr val="A7B3C4"/>
@@ -11999,6 +12202,7 @@
           <a:lstStyle xmlns:a="http://schemas.openxmlformats.org/drawingml/2006/main"/>
           <a:p xmlns:a="http://schemas.openxmlformats.org/drawingml/2006/main">
             <a:pPr algn="l">
+              <a:buNone/>
               <a:defRPr sz="1350" b="1">
                 <a:solidFill>
                   <a:srgbClr val="F4D35E"/>
@@ -12056,6 +12260,7 @@
           <a:lstStyle xmlns:a="http://schemas.openxmlformats.org/drawingml/2006/main"/>
           <a:p xmlns:a="http://schemas.openxmlformats.org/drawingml/2006/main">
             <a:pPr algn="l">
+              <a:buNone/>
               <a:defRPr sz="1875" b="1">
                 <a:solidFill>
                   <a:srgbClr val="F4F7FB"/>
@@ -12113,6 +12318,7 @@
           <a:lstStyle xmlns:a="http://schemas.openxmlformats.org/drawingml/2006/main"/>
           <a:p xmlns:a="http://schemas.openxmlformats.org/drawingml/2006/main">
             <a:pPr algn="l">
+              <a:buNone/>
               <a:defRPr sz="1275" b="0">
                 <a:solidFill>
                   <a:srgbClr val="A7B3C4"/>
@@ -12136,6 +12342,7 @@
           </a:p>
           <a:p xmlns:a="http://schemas.openxmlformats.org/drawingml/2006/main">
             <a:pPr algn="l">
+              <a:buNone/>
               <a:defRPr sz="1275" b="0">
                 <a:solidFill>
                   <a:srgbClr val="A7B3C4"/>
@@ -12226,6 +12433,7 @@
           <a:lstStyle xmlns:a="http://schemas.openxmlformats.org/drawingml/2006/main"/>
           <a:p xmlns:a="http://schemas.openxmlformats.org/drawingml/2006/main">
             <a:pPr algn="l">
+              <a:buNone/>
               <a:defRPr sz="1350" b="1">
                 <a:solidFill>
                   <a:srgbClr val="FF9C5A"/>
@@ -12283,6 +12491,7 @@
           <a:lstStyle xmlns:a="http://schemas.openxmlformats.org/drawingml/2006/main"/>
           <a:p xmlns:a="http://schemas.openxmlformats.org/drawingml/2006/main">
             <a:pPr algn="l">
+              <a:buNone/>
               <a:defRPr sz="1875" b="1">
                 <a:solidFill>
                   <a:srgbClr val="F4F7FB"/>
@@ -12340,6 +12549,7 @@
           <a:lstStyle xmlns:a="http://schemas.openxmlformats.org/drawingml/2006/main"/>
           <a:p xmlns:a="http://schemas.openxmlformats.org/drawingml/2006/main">
             <a:pPr algn="l">
+              <a:buNone/>
               <a:defRPr sz="1275" b="0">
                 <a:solidFill>
                   <a:srgbClr val="A7B3C4"/>
@@ -12363,6 +12573,7 @@
           </a:p>
           <a:p xmlns:a="http://schemas.openxmlformats.org/drawingml/2006/main">
             <a:pPr algn="l">
+              <a:buNone/>
               <a:defRPr sz="1275" b="0">
                 <a:solidFill>
                   <a:srgbClr val="A7B3C4"/>
@@ -12453,6 +12664,7 @@
           <a:lstStyle xmlns:a="http://schemas.openxmlformats.org/drawingml/2006/main"/>
           <a:p xmlns:a="http://schemas.openxmlformats.org/drawingml/2006/main">
             <a:pPr algn="l">
+              <a:buNone/>
               <a:defRPr sz="1350" b="1">
                 <a:solidFill>
                   <a:srgbClr val="FF667B"/>
@@ -12510,6 +12722,7 @@
           <a:lstStyle xmlns:a="http://schemas.openxmlformats.org/drawingml/2006/main"/>
           <a:p xmlns:a="http://schemas.openxmlformats.org/drawingml/2006/main">
             <a:pPr algn="l">
+              <a:buNone/>
               <a:defRPr sz="1875" b="1">
                 <a:solidFill>
                   <a:srgbClr val="F4F7FB"/>
@@ -12567,6 +12780,7 @@
           <a:lstStyle xmlns:a="http://schemas.openxmlformats.org/drawingml/2006/main"/>
           <a:p xmlns:a="http://schemas.openxmlformats.org/drawingml/2006/main">
             <a:pPr algn="l">
+              <a:buNone/>
               <a:defRPr sz="1275" b="0">
                 <a:solidFill>
                   <a:srgbClr val="A7B3C4"/>
@@ -12590,6 +12804,7 @@
           </a:p>
           <a:p xmlns:a="http://schemas.openxmlformats.org/drawingml/2006/main">
             <a:pPr algn="l">
+              <a:buNone/>
               <a:defRPr sz="1275" b="0">
                 <a:solidFill>
                   <a:srgbClr val="A7B3C4"/>
@@ -12648,7 +12863,7 @@
       </p:sp>
       <p:cxnSp>
         <p:nvCxnSpPr>
-          <p:cNvPr id="58" name=""/>
+          <p:cNvPr id="114" name=""/>
           <p:cNvCxnSpPr>
             <a:stCxn xmlns:a="http://schemas.openxmlformats.org/drawingml/2006/main" id="8" idx="3"/>
             <a:endCxn xmlns:a="http://schemas.openxmlformats.org/drawingml/2006/main" id="12" idx="1"/>
@@ -12674,7 +12889,7 @@
       </p:cxnSp>
       <p:cxnSp>
         <p:nvCxnSpPr>
-          <p:cNvPr id="59" name=""/>
+          <p:cNvPr id="115" name=""/>
           <p:cNvCxnSpPr>
             <a:stCxn xmlns:a="http://schemas.openxmlformats.org/drawingml/2006/main" id="12" idx="3"/>
             <a:endCxn xmlns:a="http://schemas.openxmlformats.org/drawingml/2006/main" id="16" idx="1"/>
@@ -12700,7 +12915,7 @@
       </p:cxnSp>
       <p:cxnSp>
         <p:nvCxnSpPr>
-          <p:cNvPr id="60" name=""/>
+          <p:cNvPr id="116" name=""/>
           <p:cNvCxnSpPr>
             <a:stCxn xmlns:a="http://schemas.openxmlformats.org/drawingml/2006/main" id="16" idx="3"/>
             <a:endCxn xmlns:a="http://schemas.openxmlformats.org/drawingml/2006/main" id="20" idx="1"/>
@@ -12726,7 +12941,7 @@
       </p:cxnSp>
       <p:cxnSp>
         <p:nvCxnSpPr>
-          <p:cNvPr id="61" name=""/>
+          <p:cNvPr id="117" name=""/>
           <p:cNvCxnSpPr>
             <a:stCxn xmlns:a="http://schemas.openxmlformats.org/drawingml/2006/main" id="20" idx="3"/>
             <a:endCxn xmlns:a="http://schemas.openxmlformats.org/drawingml/2006/main" id="24" idx="1"/>
@@ -12819,6 +13034,7 @@
           <a:lstStyle xmlns:a="http://schemas.openxmlformats.org/drawingml/2006/main"/>
           <a:p xmlns:a="http://schemas.openxmlformats.org/drawingml/2006/main">
             <a:pPr algn="l">
+              <a:buNone/>
               <a:defRPr sz="1200" b="1">
                 <a:solidFill>
                   <a:srgbClr val="78A7FF"/>
@@ -12876,6 +13092,7 @@
           <a:lstStyle xmlns:a="http://schemas.openxmlformats.org/drawingml/2006/main"/>
           <a:p xmlns:a="http://schemas.openxmlformats.org/drawingml/2006/main">
             <a:pPr algn="l">
+              <a:buNone/>
               <a:defRPr sz="1950" b="1">
                 <a:solidFill>
                   <a:srgbClr val="45D9A0"/>
@@ -12933,6 +13150,7 @@
           <a:lstStyle xmlns:a="http://schemas.openxmlformats.org/drawingml/2006/main"/>
           <a:p xmlns:a="http://schemas.openxmlformats.org/drawingml/2006/main">
             <a:pPr algn="l">
+              <a:buNone/>
               <a:defRPr sz="1875" b="1">
                 <a:solidFill>
                   <a:srgbClr val="F4F7FB"/>
@@ -12951,7 +13169,7 @@
                 <a:ea typeface="Helvetica Neue"/>
                 <a:cs typeface="Helvetica Neue"/>
               </a:rPr>
-              <a:t>Final Test: Macro F1 0,5714</a:t>
+              <a:t>Final Test: Macro F1 0,5764</a:t>
             </a:r>
           </a:p>
         </p:txBody>
@@ -12990,6 +13208,7 @@
           <a:lstStyle xmlns:a="http://schemas.openxmlformats.org/drawingml/2006/main"/>
           <a:p xmlns:a="http://schemas.openxmlformats.org/drawingml/2006/main">
             <a:pPr algn="l">
+              <a:buNone/>
               <a:defRPr sz="1575" b="0">
                 <a:solidFill>
                   <a:srgbClr val="A7B3C4"/>
@@ -13076,6 +13295,7 @@
           <a:lstStyle xmlns:a="http://schemas.openxmlformats.org/drawingml/2006/main"/>
           <a:p xmlns:a="http://schemas.openxmlformats.org/drawingml/2006/main">
             <a:pPr algn="l">
+              <a:buNone/>
               <a:defRPr sz="1050" b="1">
                 <a:solidFill>
                   <a:srgbClr val="78A7FF"/>
@@ -13133,6 +13353,7 @@
           <a:lstStyle xmlns:a="http://schemas.openxmlformats.org/drawingml/2006/main"/>
           <a:p xmlns:a="http://schemas.openxmlformats.org/drawingml/2006/main">
             <a:pPr algn="l">
+              <a:buNone/>
               <a:defRPr sz="3150" b="1">
                 <a:solidFill>
                   <a:srgbClr val="F4F7FB"/>
@@ -13221,6 +13442,7 @@
           <a:lstStyle xmlns:a="http://schemas.openxmlformats.org/drawingml/2006/main"/>
           <a:p xmlns:a="http://schemas.openxmlformats.org/drawingml/2006/main">
             <a:pPr algn="r">
+              <a:buNone/>
               <a:defRPr sz="900" b="0">
                 <a:solidFill>
                   <a:srgbClr val="A7B3C4"/>
@@ -13311,6 +13533,7 @@
           <a:lstStyle xmlns:a="http://schemas.openxmlformats.org/drawingml/2006/main"/>
           <a:p xmlns:a="http://schemas.openxmlformats.org/drawingml/2006/main">
             <a:pPr algn="l">
+              <a:buNone/>
               <a:defRPr sz="1725" b="1">
                 <a:solidFill>
                   <a:srgbClr val="F4F7FB"/>
@@ -13368,6 +13591,7 @@
           <a:lstStyle xmlns:a="http://schemas.openxmlformats.org/drawingml/2006/main"/>
           <a:p xmlns:a="http://schemas.openxmlformats.org/drawingml/2006/main">
             <a:pPr algn="l">
+              <a:buNone/>
               <a:defRPr sz="1350" b="0">
                 <a:solidFill>
                   <a:srgbClr val="A7B3C4"/>
@@ -13458,6 +13682,7 @@
           <a:lstStyle xmlns:a="http://schemas.openxmlformats.org/drawingml/2006/main"/>
           <a:p xmlns:a="http://schemas.openxmlformats.org/drawingml/2006/main">
             <a:pPr algn="l">
+              <a:buNone/>
               <a:defRPr sz="1725" b="1">
                 <a:solidFill>
                   <a:srgbClr val="F4F7FB"/>
@@ -13515,6 +13740,7 @@
           <a:lstStyle xmlns:a="http://schemas.openxmlformats.org/drawingml/2006/main"/>
           <a:p xmlns:a="http://schemas.openxmlformats.org/drawingml/2006/main">
             <a:pPr algn="l">
+              <a:buNone/>
               <a:defRPr sz="1350" b="0">
                 <a:solidFill>
                   <a:srgbClr val="A7B3C4"/>
@@ -13605,6 +13831,7 @@
           <a:lstStyle xmlns:a="http://schemas.openxmlformats.org/drawingml/2006/main"/>
           <a:p xmlns:a="http://schemas.openxmlformats.org/drawingml/2006/main">
             <a:pPr algn="l">
+              <a:buNone/>
               <a:defRPr sz="1725" b="1">
                 <a:solidFill>
                   <a:srgbClr val="F4F7FB"/>
@@ -13662,6 +13889,7 @@
           <a:lstStyle xmlns:a="http://schemas.openxmlformats.org/drawingml/2006/main"/>
           <a:p xmlns:a="http://schemas.openxmlformats.org/drawingml/2006/main">
             <a:pPr algn="l">
+              <a:buNone/>
               <a:defRPr sz="1350" b="0">
                 <a:solidFill>
                   <a:srgbClr val="A7B3C4"/>
@@ -13752,6 +13980,7 @@
           <a:lstStyle xmlns:a="http://schemas.openxmlformats.org/drawingml/2006/main"/>
           <a:p xmlns:a="http://schemas.openxmlformats.org/drawingml/2006/main">
             <a:pPr algn="l">
+              <a:buNone/>
               <a:defRPr sz="1725" b="1">
                 <a:solidFill>
                   <a:srgbClr val="F4F7FB"/>
@@ -13809,6 +14038,7 @@
           <a:lstStyle xmlns:a="http://schemas.openxmlformats.org/drawingml/2006/main"/>
           <a:p xmlns:a="http://schemas.openxmlformats.org/drawingml/2006/main">
             <a:pPr algn="l">
+              <a:buNone/>
               <a:defRPr sz="1350" b="0">
                 <a:solidFill>
                   <a:srgbClr val="A7B3C4"/>
@@ -13827,7 +14057,7 @@
                 <a:ea typeface="Helvetica Neue"/>
                 <a:cs typeface="Helvetica Neue"/>
               </a:rPr>
-              <a:t>Giữ các từ phủ định có ảnh hưởng đến sắc thái.</a:t>
+              <a:t>Giữ từ phủ định và từ chỉ mức độ như “thấp”, “nhiều”.</a:t>
             </a:r>
           </a:p>
         </p:txBody>
@@ -13901,6 +14131,7 @@
           <a:lstStyle xmlns:a="http://schemas.openxmlformats.org/drawingml/2006/main"/>
           <a:p xmlns:a="http://schemas.openxmlformats.org/drawingml/2006/main">
             <a:pPr algn="l">
+              <a:buNone/>
               <a:defRPr sz="1050" b="1">
                 <a:solidFill>
                   <a:srgbClr val="FF667B"/>
@@ -13958,6 +14189,7 @@
           <a:lstStyle xmlns:a="http://schemas.openxmlformats.org/drawingml/2006/main"/>
           <a:p xmlns:a="http://schemas.openxmlformats.org/drawingml/2006/main">
             <a:pPr algn="l">
+              <a:buNone/>
               <a:defRPr sz="1725" b="0">
                 <a:solidFill>
                   <a:srgbClr val="F4F7FB"/>
@@ -14046,6 +14278,7 @@
           <a:lstStyle xmlns:a="http://schemas.openxmlformats.org/drawingml/2006/main"/>
           <a:p xmlns:a="http://schemas.openxmlformats.org/drawingml/2006/main">
             <a:pPr algn="l">
+              <a:buNone/>
               <a:defRPr sz="1050" b="1">
                 <a:solidFill>
                   <a:srgbClr val="45D9A0"/>
@@ -14103,6 +14336,7 @@
           <a:lstStyle xmlns:a="http://schemas.openxmlformats.org/drawingml/2006/main"/>
           <a:p xmlns:a="http://schemas.openxmlformats.org/drawingml/2006/main">
             <a:pPr algn="l">
+              <a:buNone/>
               <a:defRPr sz="1725" b="1">
                 <a:solidFill>
                   <a:srgbClr val="45D9A0"/>
@@ -14121,7 +14355,7 @@
                 <a:ea typeface="Helvetica Neue"/>
                 <a:cs typeface="Helvetica Neue"/>
               </a:rPr>
-              <a:t>lương quản lý minh bạch xuyên không lương</a:t>
+              <a:t>lương thấp quản_lý thiếu minh_bạch thường_xuyên ot không lương</a:t>
             </a:r>
           </a:p>
         </p:txBody>
@@ -14160,6 +14394,7 @@
           <a:lstStyle xmlns:a="http://schemas.openxmlformats.org/drawingml/2006/main"/>
           <a:p xmlns:a="http://schemas.openxmlformats.org/drawingml/2006/main">
             <a:pPr algn="l">
+              <a:buNone/>
               <a:defRPr sz="1200" b="0">
                 <a:solidFill>
                   <a:srgbClr val="A7B3C4"/>
@@ -14178,7 +14413,7 @@
                 <a:ea typeface="Helvetica Neue"/>
                 <a:cs typeface="Helvetica Neue"/>
               </a:rPr>
-              <a:t>Ví dụ được kiểm chứng bằng đúng pipeline triển khai hiện tại.</a:t>
+              <a:t>Ví dụ chạy trên pipeline và model bản sửa hiện tại.</a:t>
             </a:r>
           </a:p>
         </p:txBody>
@@ -14217,6 +14452,7 @@
           <a:lstStyle xmlns:a="http://schemas.openxmlformats.org/drawingml/2006/main"/>
           <a:p xmlns:a="http://schemas.openxmlformats.org/drawingml/2006/main">
             <a:pPr algn="l">
+              <a:buNone/>
               <a:defRPr sz="1350" b="0">
                 <a:solidFill>
                   <a:srgbClr val="A7B3C4"/>
@@ -14303,6 +14539,7 @@
           <a:lstStyle xmlns:a="http://schemas.openxmlformats.org/drawingml/2006/main"/>
           <a:p xmlns:a="http://schemas.openxmlformats.org/drawingml/2006/main">
             <a:pPr algn="l">
+              <a:buNone/>
               <a:defRPr sz="1050" b="1">
                 <a:solidFill>
                   <a:srgbClr val="78A7FF"/>
@@ -14360,6 +14597,7 @@
           <a:lstStyle xmlns:a="http://schemas.openxmlformats.org/drawingml/2006/main"/>
           <a:p xmlns:a="http://schemas.openxmlformats.org/drawingml/2006/main">
             <a:pPr algn="l">
+              <a:buNone/>
               <a:defRPr sz="3150" b="1">
                 <a:solidFill>
                   <a:srgbClr val="F4F7FB"/>
@@ -14448,6 +14686,7 @@
           <a:lstStyle xmlns:a="http://schemas.openxmlformats.org/drawingml/2006/main"/>
           <a:p xmlns:a="http://schemas.openxmlformats.org/drawingml/2006/main">
             <a:pPr algn="r">
+              <a:buNone/>
               <a:defRPr sz="900" b="0">
                 <a:solidFill>
                   <a:srgbClr val="A7B3C4"/>
@@ -14473,14 +14712,14 @@
       </p:sp>
       <p:pic>
         <p:nvPicPr>
-          <p:cNvPr id="17" name=""/>
+          <p:cNvPr id="19" name=""/>
           <p:cNvPicPr>
             <a:picLocks xmlns:a="http://schemas.openxmlformats.org/drawingml/2006/main" noChangeAspect="1"/>
           </p:cNvPicPr>
           <p:nvPr/>
         </p:nvPicPr>
         <p:blipFill>
-          <a:blip xmlns:r="http://schemas.openxmlformats.org/officeDocument/2006/relationships" xmlns:a="http://schemas.openxmlformats.org/drawingml/2006/main" r:embed="R24c4fc687c6a45b2"/>
+          <a:blip xmlns:r="http://schemas.openxmlformats.org/officeDocument/2006/relationships" xmlns:a="http://schemas.openxmlformats.org/drawingml/2006/main" r:embed="Rf3f4e884f7034a0a"/>
           <a:stretch xmlns:a="http://schemas.openxmlformats.org/drawingml/2006/main"/>
         </p:blipFill>
         <p:spPr>
@@ -14527,6 +14766,7 @@
           <a:lstStyle xmlns:a="http://schemas.openxmlformats.org/drawingml/2006/main"/>
           <a:p xmlns:a="http://schemas.openxmlformats.org/drawingml/2006/main">
             <a:pPr algn="l">
+              <a:buNone/>
               <a:defRPr sz="975" b="1">
                 <a:solidFill>
                   <a:srgbClr val="45D9A0"/>
@@ -14584,6 +14824,7 @@
           <a:lstStyle xmlns:a="http://schemas.openxmlformats.org/drawingml/2006/main"/>
           <a:p xmlns:a="http://schemas.openxmlformats.org/drawingml/2006/main">
             <a:pPr algn="l">
+              <a:buNone/>
               <a:defRPr sz="2850" b="1">
                 <a:solidFill>
                   <a:srgbClr val="F4F7FB"/>
@@ -14641,6 +14882,7 @@
           <a:lstStyle xmlns:a="http://schemas.openxmlformats.org/drawingml/2006/main"/>
           <a:p xmlns:a="http://schemas.openxmlformats.org/drawingml/2006/main">
             <a:pPr algn="l">
+              <a:buNone/>
               <a:defRPr sz="975" b="1">
                 <a:solidFill>
                   <a:srgbClr val="78A7FF"/>
@@ -14698,6 +14940,7 @@
           <a:lstStyle xmlns:a="http://schemas.openxmlformats.org/drawingml/2006/main"/>
           <a:p xmlns:a="http://schemas.openxmlformats.org/drawingml/2006/main">
             <a:pPr algn="l">
+              <a:buNone/>
               <a:defRPr sz="2850" b="1">
                 <a:solidFill>
                   <a:srgbClr val="F4F7FB"/>
@@ -14755,6 +14998,7 @@
           <a:lstStyle xmlns:a="http://schemas.openxmlformats.org/drawingml/2006/main"/>
           <a:p xmlns:a="http://schemas.openxmlformats.org/drawingml/2006/main">
             <a:pPr algn="l">
+              <a:buNone/>
               <a:defRPr sz="975" b="1">
                 <a:solidFill>
                   <a:srgbClr val="F4D35E"/>
@@ -14812,6 +15056,7 @@
           <a:lstStyle xmlns:a="http://schemas.openxmlformats.org/drawingml/2006/main"/>
           <a:p xmlns:a="http://schemas.openxmlformats.org/drawingml/2006/main">
             <a:pPr algn="l">
+              <a:buNone/>
               <a:defRPr sz="2850" b="1">
                 <a:solidFill>
                   <a:srgbClr val="F4F7FB"/>
@@ -14869,6 +15114,7 @@
           <a:lstStyle xmlns:a="http://schemas.openxmlformats.org/drawingml/2006/main"/>
           <a:p xmlns:a="http://schemas.openxmlformats.org/drawingml/2006/main">
             <a:pPr algn="l">
+              <a:buNone/>
               <a:defRPr sz="1500" b="0">
                 <a:solidFill>
                   <a:srgbClr val="A7B3C4"/>
@@ -14955,6 +15201,7 @@
           <a:lstStyle xmlns:a="http://schemas.openxmlformats.org/drawingml/2006/main"/>
           <a:p xmlns:a="http://schemas.openxmlformats.org/drawingml/2006/main">
             <a:pPr algn="l">
+              <a:buNone/>
               <a:defRPr sz="1050" b="1">
                 <a:solidFill>
                   <a:srgbClr val="78A7FF"/>
@@ -15012,6 +15259,7 @@
           <a:lstStyle xmlns:a="http://schemas.openxmlformats.org/drawingml/2006/main"/>
           <a:p xmlns:a="http://schemas.openxmlformats.org/drawingml/2006/main">
             <a:pPr algn="l">
+              <a:buNone/>
               <a:defRPr sz="3150" b="1">
                 <a:solidFill>
                   <a:srgbClr val="F4F7FB"/>
@@ -15100,6 +15348,7 @@
           <a:lstStyle xmlns:a="http://schemas.openxmlformats.org/drawingml/2006/main"/>
           <a:p xmlns:a="http://schemas.openxmlformats.org/drawingml/2006/main">
             <a:pPr algn="r">
+              <a:buNone/>
               <a:defRPr sz="900" b="0">
                 <a:solidFill>
                   <a:srgbClr val="A7B3C4"/>
@@ -15125,7 +15374,7 @@
       </p:sp>
       <p:graphicFrame>
         <p:nvGraphicFramePr>
-          <p:cNvPr id="24" name="Chart"/>
+          <p:cNvPr id="26" name="Chart"/>
           <p:cNvGraphicFramePr/>
           <p:nvPr/>
         </p:nvGraphicFramePr>
@@ -15135,7 +15384,7 @@
         </p:xfrm>
         <a:graphic xmlns:a="http://schemas.openxmlformats.org/drawingml/2006/main">
           <a:graphicData uri="http://schemas.openxmlformats.org/drawingml/2006/chart">
-            <c:chart xmlns:r="http://schemas.openxmlformats.org/officeDocument/2006/relationships" xmlns:c="http://schemas.openxmlformats.org/drawingml/2006/chart" r:id="R480fe374566c4e0a"/>
+            <c:chart xmlns:r="http://schemas.openxmlformats.org/officeDocument/2006/relationships" xmlns:c="http://schemas.openxmlformats.org/drawingml/2006/chart" r:id="Rb17d24a0874d4fb8"/>
           </a:graphicData>
         </a:graphic>
       </p:graphicFrame>
@@ -15173,6 +15422,7 @@
           <a:lstStyle xmlns:a="http://schemas.openxmlformats.org/drawingml/2006/main"/>
           <a:p xmlns:a="http://schemas.openxmlformats.org/drawingml/2006/main">
             <a:pPr algn="r">
+              <a:buNone/>
               <a:defRPr sz="900" b="1">
                 <a:solidFill>
                   <a:srgbClr val="A7B3C4"/>
@@ -15263,6 +15513,7 @@
           <a:lstStyle xmlns:a="http://schemas.openxmlformats.org/drawingml/2006/main"/>
           <a:p xmlns:a="http://schemas.openxmlformats.org/drawingml/2006/main">
             <a:pPr algn="l">
+              <a:buNone/>
               <a:defRPr sz="1650" b="1">
                 <a:solidFill>
                   <a:srgbClr val="F4F7FB"/>
@@ -15320,6 +15571,7 @@
           <a:lstStyle xmlns:a="http://schemas.openxmlformats.org/drawingml/2006/main"/>
           <a:p xmlns:a="http://schemas.openxmlformats.org/drawingml/2006/main">
             <a:pPr algn="l">
+              <a:buNone/>
               <a:defRPr sz="1275" b="0">
                 <a:solidFill>
                   <a:srgbClr val="A7B3C4"/>
@@ -15410,6 +15662,7 @@
           <a:lstStyle xmlns:a="http://schemas.openxmlformats.org/drawingml/2006/main"/>
           <a:p xmlns:a="http://schemas.openxmlformats.org/drawingml/2006/main">
             <a:pPr algn="l">
+              <a:buNone/>
               <a:defRPr sz="1650" b="1">
                 <a:solidFill>
                   <a:srgbClr val="F4F7FB"/>
@@ -15467,6 +15720,7 @@
           <a:lstStyle xmlns:a="http://schemas.openxmlformats.org/drawingml/2006/main"/>
           <a:p xmlns:a="http://schemas.openxmlformats.org/drawingml/2006/main">
             <a:pPr algn="l">
+              <a:buNone/>
               <a:defRPr sz="1275" b="0">
                 <a:solidFill>
                   <a:srgbClr val="A7B3C4"/>
@@ -15557,6 +15811,7 @@
           <a:lstStyle xmlns:a="http://schemas.openxmlformats.org/drawingml/2006/main"/>
           <a:p xmlns:a="http://schemas.openxmlformats.org/drawingml/2006/main">
             <a:pPr algn="l">
+              <a:buNone/>
               <a:defRPr sz="1650" b="1">
                 <a:solidFill>
                   <a:srgbClr val="F4F7FB"/>
@@ -15614,6 +15869,7 @@
           <a:lstStyle xmlns:a="http://schemas.openxmlformats.org/drawingml/2006/main"/>
           <a:p xmlns:a="http://schemas.openxmlformats.org/drawingml/2006/main">
             <a:pPr algn="l">
+              <a:buNone/>
               <a:defRPr sz="1275" b="0">
                 <a:solidFill>
                   <a:srgbClr val="A7B3C4"/>
@@ -15702,6 +15958,7 @@
           <a:lstStyle xmlns:a="http://schemas.openxmlformats.org/drawingml/2006/main"/>
           <a:p xmlns:a="http://schemas.openxmlformats.org/drawingml/2006/main">
             <a:pPr algn="l">
+              <a:buNone/>
               <a:defRPr sz="1500" b="1">
                 <a:solidFill>
                   <a:srgbClr val="F4F7FB"/>
@@ -15759,6 +16016,7 @@
           <a:lstStyle xmlns:a="http://schemas.openxmlformats.org/drawingml/2006/main"/>
           <a:p xmlns:a="http://schemas.openxmlformats.org/drawingml/2006/main">
             <a:pPr algn="l">
+              <a:buNone/>
               <a:defRPr sz="1350" b="0">
                 <a:solidFill>
                   <a:srgbClr val="A7B3C4"/>
@@ -15816,6 +16074,7 @@
           <a:lstStyle xmlns:a="http://schemas.openxmlformats.org/drawingml/2006/main"/>
           <a:p xmlns:a="http://schemas.openxmlformats.org/drawingml/2006/main">
             <a:pPr algn="l">
+              <a:buNone/>
               <a:defRPr sz="1200" b="0">
                 <a:solidFill>
                   <a:srgbClr val="FF9C5A"/>
@@ -15902,6 +16161,7 @@
           <a:lstStyle xmlns:a="http://schemas.openxmlformats.org/drawingml/2006/main"/>
           <a:p xmlns:a="http://schemas.openxmlformats.org/drawingml/2006/main">
             <a:pPr algn="l">
+              <a:buNone/>
               <a:defRPr sz="1050" b="1">
                 <a:solidFill>
                   <a:srgbClr val="78A7FF"/>
@@ -15959,6 +16219,7 @@
           <a:lstStyle xmlns:a="http://schemas.openxmlformats.org/drawingml/2006/main"/>
           <a:p xmlns:a="http://schemas.openxmlformats.org/drawingml/2006/main">
             <a:pPr algn="l">
+              <a:buNone/>
               <a:defRPr sz="3150" b="1">
                 <a:solidFill>
                   <a:srgbClr val="F4F7FB"/>
@@ -16047,6 +16308,7 @@
           <a:lstStyle xmlns:a="http://schemas.openxmlformats.org/drawingml/2006/main"/>
           <a:p xmlns:a="http://schemas.openxmlformats.org/drawingml/2006/main">
             <a:pPr algn="r">
+              <a:buNone/>
               <a:defRPr sz="900" b="0">
                 <a:solidFill>
                   <a:srgbClr val="A7B3C4"/>
@@ -16104,6 +16366,7 @@
           <a:lstStyle xmlns:a="http://schemas.openxmlformats.org/drawingml/2006/main"/>
           <a:p xmlns:a="http://schemas.openxmlformats.org/drawingml/2006/main">
             <a:pPr algn="l">
+              <a:buNone/>
               <a:defRPr sz="1350" b="1">
                 <a:solidFill>
                   <a:srgbClr val="78A7FF"/>
@@ -16161,6 +16424,7 @@
           <a:lstStyle xmlns:a="http://schemas.openxmlformats.org/drawingml/2006/main"/>
           <a:p xmlns:a="http://schemas.openxmlformats.org/drawingml/2006/main">
             <a:pPr algn="l">
+              <a:buNone/>
               <a:defRPr sz="1575" b="1">
                 <a:solidFill>
                   <a:srgbClr val="F4F7FB"/>
@@ -16218,6 +16482,7 @@
           <a:lstStyle xmlns:a="http://schemas.openxmlformats.org/drawingml/2006/main"/>
           <a:p xmlns:a="http://schemas.openxmlformats.org/drawingml/2006/main">
             <a:pPr algn="l">
+              <a:buNone/>
               <a:defRPr sz="1350" b="1">
                 <a:solidFill>
                   <a:srgbClr val="45D9A0"/>
@@ -16275,6 +16540,7 @@
           <a:lstStyle xmlns:a="http://schemas.openxmlformats.org/drawingml/2006/main"/>
           <a:p xmlns:a="http://schemas.openxmlformats.org/drawingml/2006/main">
             <a:pPr algn="l">
+              <a:buNone/>
               <a:defRPr sz="1575" b="1">
                 <a:solidFill>
                   <a:srgbClr val="F4F7FB"/>
@@ -16332,6 +16598,7 @@
           <a:lstStyle xmlns:a="http://schemas.openxmlformats.org/drawingml/2006/main"/>
           <a:p xmlns:a="http://schemas.openxmlformats.org/drawingml/2006/main">
             <a:pPr algn="l">
+              <a:buNone/>
               <a:defRPr sz="1350" b="1">
                 <a:solidFill>
                   <a:srgbClr val="F4D35E"/>
@@ -16389,6 +16656,7 @@
           <a:lstStyle xmlns:a="http://schemas.openxmlformats.org/drawingml/2006/main"/>
           <a:p xmlns:a="http://schemas.openxmlformats.org/drawingml/2006/main">
             <a:pPr algn="l">
+              <a:buNone/>
               <a:defRPr sz="1575" b="1">
                 <a:solidFill>
                   <a:srgbClr val="F4F7FB"/>
@@ -16446,6 +16714,7 @@
           <a:lstStyle xmlns:a="http://schemas.openxmlformats.org/drawingml/2006/main"/>
           <a:p xmlns:a="http://schemas.openxmlformats.org/drawingml/2006/main">
             <a:pPr algn="l">
+              <a:buNone/>
               <a:defRPr sz="1350" b="1">
                 <a:solidFill>
                   <a:srgbClr val="FF9C5A"/>
@@ -16503,6 +16772,7 @@
           <a:lstStyle xmlns:a="http://schemas.openxmlformats.org/drawingml/2006/main"/>
           <a:p xmlns:a="http://schemas.openxmlformats.org/drawingml/2006/main">
             <a:pPr algn="l">
+              <a:buNone/>
               <a:defRPr sz="1575" b="1">
                 <a:solidFill>
                   <a:srgbClr val="F4F7FB"/>
@@ -16560,6 +16830,7 @@
           <a:lstStyle xmlns:a="http://schemas.openxmlformats.org/drawingml/2006/main"/>
           <a:p xmlns:a="http://schemas.openxmlformats.org/drawingml/2006/main">
             <a:pPr algn="l">
+              <a:buNone/>
               <a:defRPr sz="1350" b="1">
                 <a:solidFill>
                   <a:srgbClr val="FF667B"/>
@@ -16617,6 +16888,7 @@
           <a:lstStyle xmlns:a="http://schemas.openxmlformats.org/drawingml/2006/main"/>
           <a:p xmlns:a="http://schemas.openxmlformats.org/drawingml/2006/main">
             <a:pPr algn="l">
+              <a:buNone/>
               <a:defRPr sz="1575" b="1">
                 <a:solidFill>
                   <a:srgbClr val="F4F7FB"/>
@@ -16705,6 +16977,7 @@
           <a:lstStyle xmlns:a="http://schemas.openxmlformats.org/drawingml/2006/main"/>
           <a:p xmlns:a="http://schemas.openxmlformats.org/drawingml/2006/main">
             <a:pPr algn="l">
+              <a:buNone/>
               <a:defRPr sz="2250" b="1">
                 <a:solidFill>
                   <a:srgbClr val="F4F7FB"/>
@@ -16797,6 +17070,7 @@
           <a:lstStyle xmlns:a="http://schemas.openxmlformats.org/drawingml/2006/main"/>
           <a:p xmlns:a="http://schemas.openxmlformats.org/drawingml/2006/main">
             <a:pPr algn="l">
+              <a:buNone/>
               <a:defRPr sz="1575" b="1">
                 <a:solidFill>
                   <a:srgbClr val="78A7FF"/>
@@ -16854,6 +17128,7 @@
           <a:lstStyle xmlns:a="http://schemas.openxmlformats.org/drawingml/2006/main"/>
           <a:p xmlns:a="http://schemas.openxmlformats.org/drawingml/2006/main">
             <a:pPr algn="l">
+              <a:buNone/>
               <a:defRPr sz="1200" b="0">
                 <a:solidFill>
                   <a:srgbClr val="A7B3C4"/>
@@ -16946,6 +17221,7 @@
           <a:lstStyle xmlns:a="http://schemas.openxmlformats.org/drawingml/2006/main"/>
           <a:p xmlns:a="http://schemas.openxmlformats.org/drawingml/2006/main">
             <a:pPr algn="l">
+              <a:buNone/>
               <a:defRPr sz="1575" b="1">
                 <a:solidFill>
                   <a:srgbClr val="FF9C5A"/>
@@ -17003,6 +17279,7 @@
           <a:lstStyle xmlns:a="http://schemas.openxmlformats.org/drawingml/2006/main"/>
           <a:p xmlns:a="http://schemas.openxmlformats.org/drawingml/2006/main">
             <a:pPr algn="l">
+              <a:buNone/>
               <a:defRPr sz="1200" b="0">
                 <a:solidFill>
                   <a:srgbClr val="A7B3C4"/>
@@ -17095,6 +17372,7 @@
           <a:lstStyle xmlns:a="http://schemas.openxmlformats.org/drawingml/2006/main"/>
           <a:p xmlns:a="http://schemas.openxmlformats.org/drawingml/2006/main">
             <a:pPr algn="l">
+              <a:buNone/>
               <a:defRPr sz="1575" b="1">
                 <a:solidFill>
                   <a:srgbClr val="45D9A0"/>
@@ -17152,6 +17430,7 @@
           <a:lstStyle xmlns:a="http://schemas.openxmlformats.org/drawingml/2006/main"/>
           <a:p xmlns:a="http://schemas.openxmlformats.org/drawingml/2006/main">
             <a:pPr algn="l">
+              <a:buNone/>
               <a:defRPr sz="1200" b="0">
                 <a:solidFill>
                   <a:srgbClr val="A7B3C4"/>
@@ -17244,6 +17523,7 @@
           <a:lstStyle xmlns:a="http://schemas.openxmlformats.org/drawingml/2006/main"/>
           <a:p xmlns:a="http://schemas.openxmlformats.org/drawingml/2006/main">
             <a:pPr algn="l">
+              <a:buNone/>
               <a:defRPr sz="1575" b="1">
                 <a:solidFill>
                   <a:srgbClr val="F4D35E"/>
@@ -17301,6 +17581,7 @@
           <a:lstStyle xmlns:a="http://schemas.openxmlformats.org/drawingml/2006/main"/>
           <a:p xmlns:a="http://schemas.openxmlformats.org/drawingml/2006/main">
             <a:pPr algn="l">
+              <a:buNone/>
               <a:defRPr sz="1200" b="0">
                 <a:solidFill>
                   <a:srgbClr val="A7B3C4"/>
@@ -17326,7 +17607,7 @@
       </p:sp>
       <p:cxnSp>
         <p:nvCxnSpPr>
-          <p:cNvPr id="61" name=""/>
+          <p:cNvPr id="123" name=""/>
           <p:cNvCxnSpPr>
             <a:stCxn xmlns:a="http://schemas.openxmlformats.org/drawingml/2006/main" id="17" idx="3"/>
             <a:endCxn xmlns:a="http://schemas.openxmlformats.org/drawingml/2006/main" id="20" idx="1"/>
@@ -17352,7 +17633,7 @@
       </p:cxnSp>
       <p:cxnSp>
         <p:nvCxnSpPr>
-          <p:cNvPr id="62" name=""/>
+          <p:cNvPr id="124" name=""/>
           <p:cNvCxnSpPr>
             <a:stCxn xmlns:a="http://schemas.openxmlformats.org/drawingml/2006/main" id="20" idx="3"/>
             <a:endCxn xmlns:a="http://schemas.openxmlformats.org/drawingml/2006/main" id="23" idx="1"/>
@@ -17378,7 +17659,7 @@
       </p:cxnSp>
       <p:cxnSp>
         <p:nvCxnSpPr>
-          <p:cNvPr id="63" name=""/>
+          <p:cNvPr id="125" name=""/>
           <p:cNvCxnSpPr>
             <a:stCxn xmlns:a="http://schemas.openxmlformats.org/drawingml/2006/main" id="23" idx="3"/>
             <a:endCxn xmlns:a="http://schemas.openxmlformats.org/drawingml/2006/main" id="26" idx="1"/>
@@ -17436,6 +17717,7 @@
           <a:lstStyle xmlns:a="http://schemas.openxmlformats.org/drawingml/2006/main"/>
           <a:p xmlns:a="http://schemas.openxmlformats.org/drawingml/2006/main">
             <a:pPr algn="l">
+              <a:buNone/>
               <a:defRPr sz="1500" b="0">
                 <a:solidFill>
                   <a:srgbClr val="A7B3C4"/>
@@ -17522,6 +17804,7 @@
           <a:lstStyle xmlns:a="http://schemas.openxmlformats.org/drawingml/2006/main"/>
           <a:p xmlns:a="http://schemas.openxmlformats.org/drawingml/2006/main">
             <a:pPr algn="l">
+              <a:buNone/>
               <a:defRPr sz="1050" b="1">
                 <a:solidFill>
                   <a:srgbClr val="78A7FF"/>
@@ -17574,11 +17857,12 @@
         </p:spPr>
         <p:txBody>
           <a:bodyPr xmlns:a="http://schemas.openxmlformats.org/drawingml/2006/main" anchor="t">
-            <a:normAutofit fontScale="97820"/>
-          </a:bodyPr>
-          <a:lstStyle xmlns:a="http://schemas.openxmlformats.org/drawingml/2006/main"/>
-          <a:p xmlns:a="http://schemas.openxmlformats.org/drawingml/2006/main">
-            <a:pPr algn="l">
+            <a:normAutofit fontScale="100000"/>
+          </a:bodyPr>
+          <a:lstStyle xmlns:a="http://schemas.openxmlformats.org/drawingml/2006/main"/>
+          <a:p xmlns:a="http://schemas.openxmlformats.org/drawingml/2006/main">
+            <a:pPr algn="l">
+              <a:buNone/>
               <a:defRPr sz="3150" b="1">
                 <a:solidFill>
                   <a:srgbClr val="F4F7FB"/>
@@ -17597,7 +17881,7 @@
                 <a:ea typeface="Helvetica Neue"/>
                 <a:cs typeface="Helvetica Neue"/>
               </a:rPr>
-              <a:t>Logistic Regression và Linear SVM gần như ngang nhau</a:t>
+              <a:t>Xếp hạng gốc; Logistic Regression cải thiện sau sửa lỗi</a:t>
             </a:r>
           </a:p>
         </p:txBody>
@@ -17667,6 +17951,7 @@
           <a:lstStyle xmlns:a="http://schemas.openxmlformats.org/drawingml/2006/main"/>
           <a:p xmlns:a="http://schemas.openxmlformats.org/drawingml/2006/main">
             <a:pPr algn="r">
+              <a:buNone/>
               <a:defRPr sz="900" b="0">
                 <a:solidFill>
                   <a:srgbClr val="A7B3C4"/>
@@ -17692,7 +17977,7 @@
       </p:sp>
       <p:graphicFrame>
         <p:nvGraphicFramePr>
-          <p:cNvPr id="23" name="Chart"/>
+          <p:cNvPr id="25" name="Chart"/>
           <p:cNvGraphicFramePr/>
           <p:nvPr/>
         </p:nvGraphicFramePr>
@@ -17702,7 +17987,7 @@
         </p:xfrm>
         <a:graphic xmlns:a="http://schemas.openxmlformats.org/drawingml/2006/main">
           <a:graphicData uri="http://schemas.openxmlformats.org/drawingml/2006/chart">
-            <c:chart xmlns:r="http://schemas.openxmlformats.org/officeDocument/2006/relationships" xmlns:c="http://schemas.openxmlformats.org/drawingml/2006/chart" r:id="Rf75e587044bc4591"/>
+            <c:chart xmlns:r="http://schemas.openxmlformats.org/officeDocument/2006/relationships" xmlns:c="http://schemas.openxmlformats.org/drawingml/2006/chart" r:id="Re88c139d27314149"/>
           </a:graphicData>
         </a:graphic>
       </p:graphicFrame>
@@ -17740,6 +18025,7 @@
           <a:lstStyle xmlns:a="http://schemas.openxmlformats.org/drawingml/2006/main"/>
           <a:p xmlns:a="http://schemas.openxmlformats.org/drawingml/2006/main">
             <a:pPr algn="r">
+              <a:buNone/>
               <a:defRPr sz="900" b="1">
                 <a:solidFill>
                   <a:srgbClr val="A7B3C4"/>
@@ -17797,6 +18083,7 @@
           <a:lstStyle xmlns:a="http://schemas.openxmlformats.org/drawingml/2006/main"/>
           <a:p xmlns:a="http://schemas.openxmlformats.org/drawingml/2006/main">
             <a:pPr algn="l">
+              <a:buNone/>
               <a:defRPr sz="975" b="1">
                 <a:solidFill>
                   <a:srgbClr val="F4D35E"/>
@@ -17854,6 +18141,7 @@
           <a:lstStyle xmlns:a="http://schemas.openxmlformats.org/drawingml/2006/main"/>
           <a:p xmlns:a="http://schemas.openxmlformats.org/drawingml/2006/main">
             <a:pPr algn="l">
+              <a:buNone/>
               <a:defRPr sz="2850" b="1">
                 <a:solidFill>
                   <a:srgbClr val="F4F7FB"/>
@@ -17911,6 +18199,7 @@
           <a:lstStyle xmlns:a="http://schemas.openxmlformats.org/drawingml/2006/main"/>
           <a:p xmlns:a="http://schemas.openxmlformats.org/drawingml/2006/main">
             <a:pPr algn="l">
+              <a:buNone/>
               <a:defRPr sz="1800" b="1">
                 <a:solidFill>
                   <a:srgbClr val="45D9A0"/>
@@ -17929,7 +18218,7 @@
                 <a:ea typeface="Helvetica Neue"/>
                 <a:cs typeface="Helvetica Neue"/>
               </a:rPr>
-              <a:t>Chọn Logistic Regression</a:t>
+              <a:t>Model được triển khai</a:t>
             </a:r>
           </a:p>
         </p:txBody>
@@ -18001,6 +18290,7 @@
           <a:lstStyle xmlns:a="http://schemas.openxmlformats.org/drawingml/2006/main"/>
           <a:p xmlns:a="http://schemas.openxmlformats.org/drawingml/2006/main">
             <a:pPr algn="l">
+              <a:buNone/>
               <a:defRPr sz="1425" b="1">
                 <a:solidFill>
                   <a:srgbClr val="F4F7FB"/>
@@ -18019,7 +18309,7 @@
                 <a:ea typeface="Helvetica Neue"/>
                 <a:cs typeface="Helvetica Neue"/>
               </a:rPr>
-              <a:t>CV Macro F1 cao nhất</a:t>
+              <a:t>Bảng 5 model ban đầu</a:t>
             </a:r>
           </a:p>
         </p:txBody>
@@ -18058,6 +18348,7 @@
           <a:lstStyle xmlns:a="http://schemas.openxmlformats.org/drawingml/2006/main"/>
           <a:p xmlns:a="http://schemas.openxmlformats.org/drawingml/2006/main">
             <a:pPr algn="l">
+              <a:buNone/>
               <a:defRPr sz="1200" b="0">
                 <a:solidFill>
                   <a:srgbClr val="A7B3C4"/>
@@ -18076,7 +18367,7 @@
                 <a:ea typeface="Helvetica Neue"/>
                 <a:cs typeface="Helvetica Neue"/>
               </a:rPr>
-              <a:t>0,5727 với C = 1.0 và SMOTE.</a:t>
+              <a:t>LR đạt 0,5727, hơn SVM 0,0003.</a:t>
             </a:r>
           </a:p>
         </p:txBody>
@@ -18148,6 +18439,7 @@
           <a:lstStyle xmlns:a="http://schemas.openxmlformats.org/drawingml/2006/main"/>
           <a:p xmlns:a="http://schemas.openxmlformats.org/drawingml/2006/main">
             <a:pPr algn="l">
+              <a:buNone/>
               <a:defRPr sz="1425" b="1">
                 <a:solidFill>
                   <a:srgbClr val="F4F7FB"/>
@@ -18166,7 +18458,7 @@
                 <a:ea typeface="Helvetica Neue"/>
                 <a:cs typeface="Helvetica Neue"/>
               </a:rPr>
-              <a:t>Có predict_proba</a:t>
+              <a:t>Sau sửa tiền xử lý</a:t>
             </a:r>
           </a:p>
         </p:txBody>
@@ -18205,6 +18497,7 @@
           <a:lstStyle xmlns:a="http://schemas.openxmlformats.org/drawingml/2006/main"/>
           <a:p xmlns:a="http://schemas.openxmlformats.org/drawingml/2006/main">
             <a:pPr algn="l">
+              <a:buNone/>
               <a:defRPr sz="1200" b="0">
                 <a:solidFill>
                   <a:srgbClr val="A7B3C4"/>
@@ -18223,7 +18516,7 @@
                 <a:ea typeface="Helvetica Neue"/>
                 <a:cs typeface="Helvetica Neue"/>
               </a:rPr>
-              <a:t>Phù hợp cho giao diện xác suất của web demo.</a:t>
+              <a:t>CV riêng tăng từ 0,5708 lên 0,5815.</a:t>
             </a:r>
           </a:p>
         </p:txBody>
@@ -18295,6 +18588,7 @@
           <a:lstStyle xmlns:a="http://schemas.openxmlformats.org/drawingml/2006/main"/>
           <a:p xmlns:a="http://schemas.openxmlformats.org/drawingml/2006/main">
             <a:pPr algn="l">
+              <a:buNone/>
               <a:defRPr sz="1425" b="1">
                 <a:solidFill>
                   <a:srgbClr val="F4F7FB"/>
@@ -18313,7 +18607,7 @@
                 <a:ea typeface="Helvetica Neue"/>
                 <a:cs typeface="Helvetica Neue"/>
               </a:rPr>
-              <a:t>Không tuyên bố vượt trội thống kê</a:t>
+              <a:t>Giữ đúng phạm vi so sánh</a:t>
             </a:r>
           </a:p>
         </p:txBody>
@@ -18352,6 +18646,7 @@
           <a:lstStyle xmlns:a="http://schemas.openxmlformats.org/drawingml/2006/main"/>
           <a:p xmlns:a="http://schemas.openxmlformats.org/drawingml/2006/main">
             <a:pPr algn="l">
+              <a:buNone/>
               <a:defRPr sz="1200" b="0">
                 <a:solidFill>
                   <a:srgbClr val="A7B3C4"/>
@@ -18370,7 +18665,7 @@
                 <a:ea typeface="Helvetica Neue"/>
                 <a:cs typeface="Helvetica Neue"/>
               </a:rPr>
-              <a:t>Điểm của LR và SVM quá sát để kết luận chênh lệch đáng kể.</a:t>
+              <a:t>Chưa xếp hạng lại bốn model còn lại.</a:t>
             </a:r>
           </a:p>
         </p:txBody>
@@ -18438,6 +18733,7 @@
           <a:lstStyle xmlns:a="http://schemas.openxmlformats.org/drawingml/2006/main"/>
           <a:p xmlns:a="http://schemas.openxmlformats.org/drawingml/2006/main">
             <a:pPr algn="l">
+              <a:buNone/>
               <a:defRPr sz="1050" b="1">
                 <a:solidFill>
                   <a:srgbClr val="78A7FF"/>
@@ -18495,6 +18791,7 @@
           <a:lstStyle xmlns:a="http://schemas.openxmlformats.org/drawingml/2006/main"/>
           <a:p xmlns:a="http://schemas.openxmlformats.org/drawingml/2006/main">
             <a:pPr algn="l">
+              <a:buNone/>
               <a:defRPr sz="3150" b="1">
                 <a:solidFill>
                   <a:srgbClr val="F4F7FB"/>
@@ -18513,7 +18810,7 @@
                 <a:ea typeface="Helvetica Neue"/>
                 <a:cs typeface="Helvetica Neue"/>
               </a:rPr>
-              <a:t>Macro F1 ổn định nhưng lớp Negative vẫn khó</a:t>
+              <a:t>Bản sửa cải thiện nhẹ; lớp Negative vẫn khó</a:t>
             </a:r>
           </a:p>
         </p:txBody>
@@ -18583,6 +18880,7 @@
           <a:lstStyle xmlns:a="http://schemas.openxmlformats.org/drawingml/2006/main"/>
           <a:p xmlns:a="http://schemas.openxmlformats.org/drawingml/2006/main">
             <a:pPr algn="r">
+              <a:buNone/>
               <a:defRPr sz="900" b="0">
                 <a:solidFill>
                   <a:srgbClr val="A7B3C4"/>
@@ -18640,6 +18938,7 @@
           <a:lstStyle xmlns:a="http://schemas.openxmlformats.org/drawingml/2006/main"/>
           <a:p xmlns:a="http://schemas.openxmlformats.org/drawingml/2006/main">
             <a:pPr algn="l">
+              <a:buNone/>
               <a:defRPr sz="975" b="1">
                 <a:solidFill>
                   <a:srgbClr val="78A7FF"/>
@@ -18697,6 +18996,7 @@
           <a:lstStyle xmlns:a="http://schemas.openxmlformats.org/drawingml/2006/main"/>
           <a:p xmlns:a="http://schemas.openxmlformats.org/drawingml/2006/main">
             <a:pPr algn="l">
+              <a:buNone/>
               <a:defRPr sz="2850" b="1">
                 <a:solidFill>
                   <a:srgbClr val="F4F7FB"/>
@@ -18715,7 +19015,7 @@
                 <a:ea typeface="Helvetica Neue"/>
                 <a:cs typeface="Helvetica Neue"/>
               </a:rPr>
-              <a:t>73,74%</a:t>
+              <a:t>74,33%</a:t>
             </a:r>
           </a:p>
         </p:txBody>
@@ -18754,6 +19054,7 @@
           <a:lstStyle xmlns:a="http://schemas.openxmlformats.org/drawingml/2006/main"/>
           <a:p xmlns:a="http://schemas.openxmlformats.org/drawingml/2006/main">
             <a:pPr algn="l">
+              <a:buNone/>
               <a:defRPr sz="975" b="1">
                 <a:solidFill>
                   <a:srgbClr val="45D9A0"/>
@@ -18811,6 +19112,7 @@
           <a:lstStyle xmlns:a="http://schemas.openxmlformats.org/drawingml/2006/main"/>
           <a:p xmlns:a="http://schemas.openxmlformats.org/drawingml/2006/main">
             <a:pPr algn="l">
+              <a:buNone/>
               <a:defRPr sz="2850" b="1">
                 <a:solidFill>
                   <a:srgbClr val="F4F7FB"/>
@@ -18829,7 +19131,7 @@
                 <a:ea typeface="Helvetica Neue"/>
                 <a:cs typeface="Helvetica Neue"/>
               </a:rPr>
-              <a:t>0,5714</a:t>
+              <a:t>0,5764</a:t>
             </a:r>
           </a:p>
         </p:txBody>
@@ -18868,6 +19170,7 @@
           <a:lstStyle xmlns:a="http://schemas.openxmlformats.org/drawingml/2006/main"/>
           <a:p xmlns:a="http://schemas.openxmlformats.org/drawingml/2006/main">
             <a:pPr algn="l">
+              <a:buNone/>
               <a:defRPr sz="975" b="1">
                 <a:solidFill>
                   <a:srgbClr val="F4D35E"/>
@@ -18925,6 +19228,7 @@
           <a:lstStyle xmlns:a="http://schemas.openxmlformats.org/drawingml/2006/main"/>
           <a:p xmlns:a="http://schemas.openxmlformats.org/drawingml/2006/main">
             <a:pPr algn="l">
+              <a:buNone/>
               <a:defRPr sz="2850" b="1">
                 <a:solidFill>
                   <a:srgbClr val="F4F7FB"/>
@@ -18943,7 +19247,7 @@
                 <a:ea typeface="Helvetica Neue"/>
                 <a:cs typeface="Helvetica Neue"/>
               </a:rPr>
-              <a:t>0,7489</a:t>
+              <a:t>0,7540</a:t>
             </a:r>
           </a:p>
         </p:txBody>
@@ -18982,6 +19286,7 @@
           <a:lstStyle xmlns:a="http://schemas.openxmlformats.org/drawingml/2006/main"/>
           <a:p xmlns:a="http://schemas.openxmlformats.org/drawingml/2006/main">
             <a:pPr algn="l">
+              <a:buNone/>
               <a:defRPr sz="975" b="1">
                 <a:solidFill>
                   <a:srgbClr val="FF667B"/>
@@ -19039,6 +19344,7 @@
           <a:lstStyle xmlns:a="http://schemas.openxmlformats.org/drawingml/2006/main"/>
           <a:p xmlns:a="http://schemas.openxmlformats.org/drawingml/2006/main">
             <a:pPr algn="l">
+              <a:buNone/>
               <a:defRPr sz="2850" b="1">
                 <a:solidFill>
                   <a:srgbClr val="F4F7FB"/>
@@ -19057,14 +19363,14 @@
                 <a:ea typeface="Helvetica Neue"/>
                 <a:cs typeface="Helvetica Neue"/>
               </a:rPr>
-              <a:t>442 / 1.683</a:t>
+              <a:t>432 / 1.683</a:t>
             </a:r>
           </a:p>
         </p:txBody>
       </p:sp>
       <p:graphicFrame>
         <p:nvGraphicFramePr>
-          <p:cNvPr id="29" name=""/>
+          <p:cNvPr id="32" name=""/>
           <p:cNvGraphicFramePr/>
           <p:nvPr/>
         </p:nvGraphicFramePr>
@@ -19219,7 +19525,7 @@
                           <a:ea typeface="Helvetica Neue"/>
                           <a:cs typeface="Helvetica Neue"/>
                         </a:rPr>
-                        <a:t>51</a:t>
+                        <a:t>52</a:t>
                       </a:r>
                     </a:p>
                   </a:txBody>
@@ -19243,7 +19549,7 @@
                           <a:ea typeface="Helvetica Neue"/>
                           <a:cs typeface="Helvetica Neue"/>
                         </a:rPr>
-                        <a:t>40</a:t>
+                        <a:t>41</a:t>
                       </a:r>
                     </a:p>
                   </a:txBody>
@@ -19267,7 +19573,7 @@
                           <a:ea typeface="Helvetica Neue"/>
                           <a:cs typeface="Helvetica Neue"/>
                         </a:rPr>
-                        <a:t>23</a:t>
+                        <a:t>21</a:t>
                       </a:r>
                     </a:p>
                   </a:txBody>
@@ -19317,7 +19623,7 @@
                           <a:ea typeface="Helvetica Neue"/>
                           <a:cs typeface="Helvetica Neue"/>
                         </a:rPr>
-                        <a:t>53</a:t>
+                        <a:t>56</a:t>
                       </a:r>
                     </a:p>
                   </a:txBody>
@@ -19341,7 +19647,7 @@
                           <a:ea typeface="Helvetica Neue"/>
                           <a:cs typeface="Helvetica Neue"/>
                         </a:rPr>
-                        <a:t>170</a:t>
+                        <a:t>168</a:t>
                       </a:r>
                     </a:p>
                   </a:txBody>
@@ -19365,7 +19671,7 @@
                           <a:ea typeface="Helvetica Neue"/>
                           <a:cs typeface="Helvetica Neue"/>
                         </a:rPr>
-                        <a:t>105</a:t>
+                        <a:t>104</a:t>
                       </a:r>
                     </a:p>
                   </a:txBody>
@@ -19415,7 +19721,7 @@
                           <a:ea typeface="Helvetica Neue"/>
                           <a:cs typeface="Helvetica Neue"/>
                         </a:rPr>
-                        <a:t>50</a:t>
+                        <a:t>44</a:t>
                       </a:r>
                     </a:p>
                   </a:txBody>
@@ -19439,7 +19745,7 @@
                           <a:ea typeface="Helvetica Neue"/>
                           <a:cs typeface="Helvetica Neue"/>
                         </a:rPr>
-                        <a:t>171</a:t>
+                        <a:t>166</a:t>
                       </a:r>
                     </a:p>
                   </a:txBody>
@@ -19463,7 +19769,7 @@
                           <a:ea typeface="Helvetica Neue"/>
                           <a:cs typeface="Helvetica Neue"/>
                         </a:rPr>
-                        <a:t>1.020</a:t>
+                        <a:t>1.031</a:t>
                       </a:r>
                     </a:p>
                   </a:txBody>
@@ -19480,7 +19786,7 @@
       </p:graphicFrame>
       <p:graphicFrame>
         <p:nvGraphicFramePr>
-          <p:cNvPr id="30" name="Chart"/>
+          <p:cNvPr id="33" name="Chart"/>
           <p:cNvGraphicFramePr/>
           <p:nvPr/>
         </p:nvGraphicFramePr>
@@ -19490,7 +19796,7 @@
         </p:xfrm>
         <a:graphic xmlns:a="http://schemas.openxmlformats.org/drawingml/2006/main">
           <a:graphicData uri="http://schemas.openxmlformats.org/drawingml/2006/chart">
-            <c:chart xmlns:r="http://schemas.openxmlformats.org/officeDocument/2006/relationships" xmlns:c="http://schemas.openxmlformats.org/drawingml/2006/chart" r:id="R3bdb6c4fcc8f4b63"/>
+            <c:chart xmlns:r="http://schemas.openxmlformats.org/officeDocument/2006/relationships" xmlns:c="http://schemas.openxmlformats.org/drawingml/2006/chart" r:id="Rfdddb44e8e944fdc"/>
           </a:graphicData>
         </a:graphic>
       </p:graphicFrame>
@@ -19528,6 +19834,7 @@
           <a:lstStyle xmlns:a="http://schemas.openxmlformats.org/drawingml/2006/main"/>
           <a:p xmlns:a="http://schemas.openxmlformats.org/drawingml/2006/main">
             <a:pPr algn="r">
+              <a:buNone/>
               <a:defRPr sz="900" b="1">
                 <a:solidFill>
                   <a:srgbClr val="A7B3C4"/>
@@ -19585,6 +19892,7 @@
           <a:lstStyle xmlns:a="http://schemas.openxmlformats.org/drawingml/2006/main"/>
           <a:p xmlns:a="http://schemas.openxmlformats.org/drawingml/2006/main">
             <a:pPr algn="l">
+              <a:buNone/>
               <a:defRPr sz="1425" b="0">
                 <a:solidFill>
                   <a:srgbClr val="FF9C5A"/>
@@ -19603,7 +19911,7 @@
                 <a:ea typeface="Helvetica Neue"/>
                 <a:cs typeface="Helvetica Neue"/>
               </a:rPr>
-              <a:t>Accuracy bằng mức của majority baseline, nên Macro F1 và F1 theo lớp mới phản ánh đúng chất lượng mô hình.</a:t>
+              <a:t>Final Test cũ được dùng lại để đối chiếu bản sửa, không phải tập kiểm thử độc lập mới.</a:t>
             </a:r>
           </a:p>
         </p:txBody>

</xml_diff>

<commit_message>
feat(defense): update presentation slides, add final summary and defense QA guide
- Fix slide titles: remove semicolons on slide 8 and 9 in deck and build script
- Update scripts/build_presentation_slides.py with retrained_v2 metrics and safe file lock handling
- Fix scikit-learn estimator compatibility in scripts/evaluate_retrained_v2.py
- Add comprehensive FINAL_SUMMARY.md and reports/FINAL_SUMMARY.md
- Add 18-question defense preparation guide (BO_CAU_HOI_PHAN_BIEN_BAO_VE_DO_AN.md)
</commit_message>
<xml_diff>
--- a/reports/slides/ITviec_Sentiment_Analysis.pptx
+++ b/reports/slides/ITviec_Sentiment_Analysis.pptx
@@ -8366,6 +8366,10 @@
             <a:prstDash val="solid"/>
           </a:ln>
         </p:spPr>
+        <p:txBody xmlns:a="http://schemas.openxmlformats.org/drawingml/2006/main">
+          <a:bodyPr/>
+          <a:p/>
+        </p:txBody>
       </p:sp>
       <p:sp>
         <p:nvSpPr>
@@ -8515,6 +8519,10 @@
             <a:prstDash val="solid"/>
           </a:ln>
         </p:spPr>
+        <p:txBody xmlns:a="http://schemas.openxmlformats.org/drawingml/2006/main">
+          <a:bodyPr/>
+          <a:p/>
+        </p:txBody>
       </p:sp>
       <p:sp>
         <p:nvSpPr>
@@ -8664,6 +8672,10 @@
             <a:prstDash val="solid"/>
           </a:ln>
         </p:spPr>
+        <p:txBody xmlns:a="http://schemas.openxmlformats.org/drawingml/2006/main">
+          <a:bodyPr/>
+          <a:p/>
+        </p:txBody>
       </p:sp>
       <p:sp>
         <p:nvSpPr>
@@ -8813,6 +8825,10 @@
             <a:prstDash val="solid"/>
           </a:ln>
         </p:spPr>
+        <p:txBody xmlns:a="http://schemas.openxmlformats.org/drawingml/2006/main">
+          <a:bodyPr/>
+          <a:p/>
+        </p:txBody>
       </p:sp>
       <p:sp>
         <p:nvSpPr>
@@ -8960,6 +8976,10 @@
             <a:prstDash val="solid"/>
           </a:ln>
         </p:spPr>
+        <p:txBody xmlns:a="http://schemas.openxmlformats.org/drawingml/2006/main">
+          <a:bodyPr/>
+          <a:p/>
+        </p:txBody>
       </p:sp>
       <p:sp>
         <p:nvSpPr>
@@ -9051,6 +9071,10 @@
             <a:prstDash val="solid"/>
           </a:ln>
         </p:spPr>
+        <p:txBody xmlns:a="http://schemas.openxmlformats.org/drawingml/2006/main">
+          <a:bodyPr/>
+          <a:p/>
+        </p:txBody>
       </p:sp>
       <p:sp>
         <p:nvSpPr>
@@ -9200,6 +9224,10 @@
             <a:prstDash val="solid"/>
           </a:ln>
         </p:spPr>
+        <p:txBody xmlns:a="http://schemas.openxmlformats.org/drawingml/2006/main">
+          <a:bodyPr/>
+          <a:p/>
+        </p:txBody>
       </p:sp>
       <p:sp>
         <p:nvSpPr>
@@ -9349,6 +9377,10 @@
             <a:prstDash val="solid"/>
           </a:ln>
         </p:spPr>
+        <p:txBody xmlns:a="http://schemas.openxmlformats.org/drawingml/2006/main">
+          <a:bodyPr/>
+          <a:p/>
+        </p:txBody>
       </p:sp>
       <p:sp>
         <p:nvSpPr>
@@ -9699,6 +9731,10 @@
             <a:prstDash val="solid"/>
           </a:ln>
         </p:spPr>
+        <p:txBody xmlns:a="http://schemas.openxmlformats.org/drawingml/2006/main">
+          <a:bodyPr/>
+          <a:p/>
+        </p:txBody>
       </p:sp>
       <p:sp>
         <p:nvSpPr>
@@ -9962,6 +9998,10 @@
             <a:prstDash val="solid"/>
           </a:ln>
         </p:spPr>
+        <p:txBody xmlns:a="http://schemas.openxmlformats.org/drawingml/2006/main">
+          <a:bodyPr/>
+          <a:p/>
+        </p:txBody>
       </p:sp>
       <p:sp>
         <p:nvSpPr>
@@ -17881,7 +17921,7 @@
                 <a:ea typeface="Helvetica Neue"/>
                 <a:cs typeface="Helvetica Neue"/>
               </a:rPr>
-              <a:t>Xếp hạng gốc; Logistic Regression cải thiện sau sửa lỗi</a:t>
+              <a:t>Xếp hạng gốc – Logistic Regression cải thiện sau sửa lỗi</a:t>
             </a:r>
           </a:p>
         </p:txBody>
@@ -17916,6 +17956,10 @@
             <a:prstDash val="solid"/>
           </a:ln>
         </p:spPr>
+        <p:txBody xmlns:a="http://schemas.openxmlformats.org/drawingml/2006/main">
+          <a:bodyPr/>
+          <a:p/>
+        </p:txBody>
       </p:sp>
       <p:sp>
         <p:nvSpPr>
@@ -18255,6 +18299,10 @@
             <a:prstDash val="solid"/>
           </a:ln>
         </p:spPr>
+        <p:txBody xmlns:a="http://schemas.openxmlformats.org/drawingml/2006/main">
+          <a:bodyPr/>
+          <a:p/>
+        </p:txBody>
       </p:sp>
       <p:sp>
         <p:nvSpPr>
@@ -18404,6 +18452,10 @@
             <a:prstDash val="solid"/>
           </a:ln>
         </p:spPr>
+        <p:txBody xmlns:a="http://schemas.openxmlformats.org/drawingml/2006/main">
+          <a:bodyPr/>
+          <a:p/>
+        </p:txBody>
       </p:sp>
       <p:sp>
         <p:nvSpPr>
@@ -18553,6 +18605,10 @@
             <a:prstDash val="solid"/>
           </a:ln>
         </p:spPr>
+        <p:txBody xmlns:a="http://schemas.openxmlformats.org/drawingml/2006/main">
+          <a:bodyPr/>
+          <a:p/>
+        </p:txBody>
       </p:sp>
       <p:sp>
         <p:nvSpPr>
@@ -18810,7 +18866,7 @@
                 <a:ea typeface="Helvetica Neue"/>
                 <a:cs typeface="Helvetica Neue"/>
               </a:rPr>
-              <a:t>Bản sửa cải thiện nhẹ; lớp Negative vẫn khó</a:t>
+              <a:t>Bản sửa cải thiện nhẹ, nhưng lớp Negative vẫn khó</a:t>
             </a:r>
           </a:p>
         </p:txBody>
@@ -18845,6 +18901,10 @@
             <a:prstDash val="solid"/>
           </a:ln>
         </p:spPr>
+        <p:txBody xmlns:a="http://schemas.openxmlformats.org/drawingml/2006/main">
+          <a:bodyPr/>
+          <a:p/>
+        </p:txBody>
       </p:sp>
       <p:sp>
         <p:nvSpPr>

</xml_diff>

<commit_message>
fix(slides): embed transparent high-res Sentiment ML mark on slide 1 and update slide generator
</commit_message>
<xml_diff>
--- a/reports/slides/ITviec_Sentiment_Analysis.pptx
+++ b/reports/slides/ITviec_Sentiment_Analysis.pptx
@@ -4239,92 +4239,88 @@
           </a:p>
         </p:txBody>
       </p:sp>
-      <p:pic>
+      <p:sp>
+        <p:nvSpPr>
+          <p:cNvPr id="12" name="">
+            <a:extLst xmlns:a="http://schemas.openxmlformats.org/drawingml/2006/main">
+              <a:ext uri="{FF2B5EF4-FFF2-40B4-BE49-F238E27FC236}">
+                <a16:creationId xmlns:a16="http://schemas.microsoft.com/office/drawing/2014/main" id="{D49A222F-539C-4112-B149-0A1DCA8C989B}"/>
+              </a:ext>
+            </a:extLst>
+          </p:cNvPr>
+          <p:cNvSpPr>
+            <a:spLocks xmlns:a="http://schemas.openxmlformats.org/drawingml/2006/main" noGrp="1"/>
+          </p:cNvSpPr>
+          <p:nvPr/>
+        </p:nvSpPr>
+        <p:spPr>
+          <a:xfrm xmlns:a="http://schemas.openxmlformats.org/drawingml/2006/main">
+            <a:off x="685800" y="6153150"/>
+            <a:ext cx="7810500" cy="228600"/>
+          </a:xfrm>
+          <a:prstGeom xmlns:a="http://schemas.openxmlformats.org/drawingml/2006/main" prst="rect">
+            <a:avLst/>
+          </a:prstGeom>
+          <a:noFill xmlns:a="http://schemas.openxmlformats.org/drawingml/2006/main"/>
+          <a:ln xmlns:a="http://schemas.openxmlformats.org/drawingml/2006/main" w="0">
+            <a:noFill/>
+          </a:ln>
+        </p:spPr>
+        <p:txBody>
+          <a:bodyPr xmlns:a="http://schemas.openxmlformats.org/drawingml/2006/main" anchor="t">
+            <a:normAutofit fontScale="75000"/>
+          </a:bodyPr>
+          <a:lstStyle xmlns:a="http://schemas.openxmlformats.org/drawingml/2006/main"/>
+          <a:p xmlns:a="http://schemas.openxmlformats.org/drawingml/2006/main">
+            <a:pPr algn="l">
+              <a:buNone/>
+              <a:defRPr sz="1200" b="0">
+                <a:solidFill>
+                  <a:srgbClr val="45D9A0"/>
+                </a:solidFill>
+                <a:latin typeface="Helvetica Neue"/>
+                <a:ea typeface="Helvetica Neue"/>
+                <a:cs typeface="Helvetica Neue"/>
+              </a:defRPr>
+            </a:pPr>
+            <a:r>
+              <a:rPr sz="1200" b="0">
+                <a:solidFill>
+                  <a:srgbClr val="45D9A0"/>
+                </a:solidFill>
+                <a:latin typeface="Helvetica Neue"/>
+                <a:ea typeface="Helvetica Neue"/>
+                <a:cs typeface="Helvetica Neue"/>
+              </a:rPr>
+              <a:t>8.417 review nguồn  |  8.414 review mô hình hóa  |  3 lớp cảm xúc</a:t>
+            </a:r>
+          </a:p>
+        </p:txBody>
+      </p:sp>
+      <p:pic xmlns:a="http://schemas.openxmlformats.org/drawingml/2006/main" xmlns:r="http://schemas.openxmlformats.org/officeDocument/2006/relationships">
         <p:nvPicPr>
-          <p:cNvPr id="25" name=""/>
+          <p:cNvPr id="14" name="Picture 13" descr="sentiment-ml-mark.png"/>
           <p:cNvPicPr>
-            <a:picLocks xmlns:a="http://schemas.openxmlformats.org/drawingml/2006/main" noChangeAspect="1"/>
+            <a:picLocks noChangeAspect="1"/>
           </p:cNvPicPr>
           <p:nvPr/>
         </p:nvPicPr>
         <p:blipFill>
-          <a:blip xmlns:r="http://schemas.openxmlformats.org/officeDocument/2006/relationships" xmlns:a="http://schemas.openxmlformats.org/drawingml/2006/main" r:embed="R4611cefa7db44724">
-            <a:extLst>
-              <a:ext uri="{96DAC541-7B7A-43D3-8B79-37D633B846F1}">
-                <asvg:svgBlip xmlns:asvg="http://schemas.microsoft.com/office/drawing/2016/SVG/main" r:embed="R155e09cead574959"/>
-              </a:ext>
-            </a:extLst>
-          </a:blip>
-          <a:stretch xmlns:a="http://schemas.openxmlformats.org/drawingml/2006/main"/>
+          <a:blip r:embed="rId5"/>
+          <a:stretch>
+            <a:fillRect/>
+          </a:stretch>
         </p:blipFill>
         <p:spPr>
-          <a:xfrm xmlns:a="http://schemas.openxmlformats.org/drawingml/2006/main">
+          <a:xfrm>
             <a:off x="8239125" y="1476375"/>
             <a:ext cx="3095625" cy="3095625"/>
           </a:xfrm>
-          <a:prstGeom xmlns:a="http://schemas.openxmlformats.org/drawingml/2006/main" prst="rect">
+          <a:prstGeom prst="rect">
             <a:avLst/>
           </a:prstGeom>
         </p:spPr>
       </p:pic>
-      <p:sp>
-        <p:nvSpPr>
-          <p:cNvPr id="12" name="">
-            <a:extLst xmlns:a="http://schemas.openxmlformats.org/drawingml/2006/main">
-              <a:ext uri="{FF2B5EF4-FFF2-40B4-BE49-F238E27FC236}">
-                <a16:creationId xmlns:a16="http://schemas.microsoft.com/office/drawing/2014/main" id="{D49A222F-539C-4112-B149-0A1DCA8C989B}"/>
-              </a:ext>
-            </a:extLst>
-          </p:cNvPr>
-          <p:cNvSpPr>
-            <a:spLocks xmlns:a="http://schemas.openxmlformats.org/drawingml/2006/main" noGrp="1"/>
-          </p:cNvSpPr>
-          <p:nvPr/>
-        </p:nvSpPr>
-        <p:spPr>
-          <a:xfrm xmlns:a="http://schemas.openxmlformats.org/drawingml/2006/main">
-            <a:off x="685800" y="6153150"/>
-            <a:ext cx="7810500" cy="228600"/>
-          </a:xfrm>
-          <a:prstGeom xmlns:a="http://schemas.openxmlformats.org/drawingml/2006/main" prst="rect">
-            <a:avLst/>
-          </a:prstGeom>
-          <a:noFill xmlns:a="http://schemas.openxmlformats.org/drawingml/2006/main"/>
-          <a:ln xmlns:a="http://schemas.openxmlformats.org/drawingml/2006/main" w="0">
-            <a:noFill/>
-          </a:ln>
-        </p:spPr>
-        <p:txBody>
-          <a:bodyPr xmlns:a="http://schemas.openxmlformats.org/drawingml/2006/main" anchor="t">
-            <a:normAutofit fontScale="75000"/>
-          </a:bodyPr>
-          <a:lstStyle xmlns:a="http://schemas.openxmlformats.org/drawingml/2006/main"/>
-          <a:p xmlns:a="http://schemas.openxmlformats.org/drawingml/2006/main">
-            <a:pPr algn="l">
-              <a:buNone/>
-              <a:defRPr sz="1200" b="0">
-                <a:solidFill>
-                  <a:srgbClr val="45D9A0"/>
-                </a:solidFill>
-                <a:latin typeface="Helvetica Neue"/>
-                <a:ea typeface="Helvetica Neue"/>
-                <a:cs typeface="Helvetica Neue"/>
-              </a:defRPr>
-            </a:pPr>
-            <a:r>
-              <a:rPr sz="1200" b="0">
-                <a:solidFill>
-                  <a:srgbClr val="45D9A0"/>
-                </a:solidFill>
-                <a:latin typeface="Helvetica Neue"/>
-                <a:ea typeface="Helvetica Neue"/>
-                <a:cs typeface="Helvetica Neue"/>
-              </a:rPr>
-              <a:t>8.417 review nguồn  |  8.414 review mô hình hóa  |  3 lớp cảm xúc</a:t>
-            </a:r>
-          </a:p>
-        </p:txBody>
-      </p:sp>
     </p:spTree>
     <p:extLst>
       <p:ext uri="{BB962C8B-B14F-4D97-AF65-F5344CB8AC3E}">

</xml_diff>

<commit_message>
docs(slides): shorten 12-min presentation script and speaker notes with freshman-tailored tone
</commit_message>
<xml_diff>
--- a/reports/slides/ITviec_Sentiment_Analysis.pptx
+++ b/reports/slides/ITviec_Sentiment_Analysis.pptx
@@ -456,22 +456,12 @@
           <a:lstStyle xmlns:a="http://schemas.openxmlformats.org/drawingml/2006/main"/>
           <a:p xmlns:a="http://schemas.openxmlformats.org/drawingml/2006/main">
             <a:r>
-              <a:t>[Thời lượng mục tiêu: 20s]</a:t>
-            </a:r>
-          </a:p>
-          <a:p xmlns:a="http://schemas.openxmlformats.org/drawingml/2006/main">
-            <a:r>
-              <a:t>Giới thiệu đề tài, nhóm và phạm vi dữ liệu. Nhấn mạnh đây là bài toán phân loại nhãn cảm xúc suy ra từ rating.</a:t>
-            </a:r>
-          </a:p>
-          <a:p xmlns:a="http://schemas.openxmlformats.org/drawingml/2006/main">
-            <a:r>
-              <a:t/>
-            </a:r>
-          </a:p>
-          <a:p xmlns:a="http://schemas.openxmlformats.org/drawingml/2006/main">
-            <a:r>
-              <a:t>Nguồn nội bộ: README.md; models/artifact_manifest.json</a:t>
+              <a:t>[Thời lượng mục tiêu: 25s (0:25)]</a:t>
+            </a:r>
+          </a:p>
+          <a:p xmlns:a="http://schemas.openxmlformats.org/drawingml/2006/main">
+            <a:r>
+              <a:t>Kính chào Thầy Cáp Phạm Đình Thăng và các bạn. Nhóm sinh viên năm nhất báo cáo đồ án phân tích cảm xúc 8.414 review ITviec ba lớp Tích cực, Trung tính, Tiêu cực. (~25s)</a:t>
             </a:r>
           </a:p>
         </p:txBody>
@@ -541,30 +531,12 @@
           <a:lstStyle xmlns:a="http://schemas.openxmlformats.org/drawingml/2006/main"/>
           <a:p xmlns:a="http://schemas.openxmlformats.org/drawingml/2006/main">
             <a:r>
-              <a:t>[Thời lượng mục tiêu: 50s]</a:t>
-            </a:r>
-          </a:p>
-          <a:p xmlns:a="http://schemas.openxmlformats.org/drawingml/2006/main">
-            <a:r>
-              <a:t>Giải thích ba nhóm lỗi đúng với 15 mẫu đã đọc thủ công. Không gọi review ngắn là nhóm chính vì báo cáo hiện tại không có nhóm đó.</a:t>
-            </a:r>
-          </a:p>
-          <a:p xmlns:a="http://schemas.openxmlformats.org/drawingml/2006/main">
-            <a:r>
-              <a:t/>
-            </a:r>
-          </a:p>
-          <a:p xmlns:a="http://schemas.openxmlformats.org/drawingml/2006/main">
-            <a:r>
-              <a:t>Nguồn nội bộ: reports/evaluation/error_analysis_15_samples.csv; reports/tv4_model_evaluation_error_analysis.md</a:t>
-            </a:r>
-          </a:p>
-          <a:p xmlns:a="http://schemas.openxmlformats.org/drawingml/2006/main">
-            <a:r>
-              <a:t>
-[Sources]
-reports/evaluation/retrained_v2/error_examples_15.csv; all_final_test_errors.csv
-[/Sources]</a:t>
+              <a:t>[Thời lượng mục tiêu: 35s (0:35)]</a:t>
+            </a:r>
+          </a:p>
+          <a:p xmlns:a="http://schemas.openxmlformats.org/drawingml/2006/main">
+            <a:r>
+              <a:t>Phân loại 15 ca lỗi minh họa: 7 ca review nhiều vế đối lập (vừa khen vừa chê), 6 ca cấu trúc phủ định khó, 2 ca nhãn rating chưa rõ. Giúp hiểu ranh giới của mô hình tuyến tính. (~35s)</a:t>
             </a:r>
           </a:p>
         </p:txBody>
@@ -634,22 +606,12 @@
           <a:lstStyle xmlns:a="http://schemas.openxmlformats.org/drawingml/2006/main"/>
           <a:p xmlns:a="http://schemas.openxmlformats.org/drawingml/2006/main">
             <a:r>
-              <a:t>[Thời lượng mục tiêu: 55s]</a:t>
-            </a:r>
-          </a:p>
-          <a:p xmlns:a="http://schemas.openxmlformats.org/drawingml/2006/main">
-            <a:r>
-              <a:t>Đọc biểu đồ theo hướng mô tả, không xếp hạng doanh nghiệp. Nêu salary &amp; benefits là điểm thấp nhất ở bốn công ty và VNG khác biệt ở khía cạnh quản lý.</a:t>
-            </a:r>
-          </a:p>
-          <a:p xmlns:a="http://schemas.openxmlformats.org/drawingml/2006/main">
-            <a:r>
-              <a:t/>
-            </a:r>
-          </a:p>
-          <a:p xmlns:a="http://schemas.openxmlformats.org/drawingml/2006/main">
-            <a:r>
-              <a:t>Nguồn nội bộ: reports/company_insights/company_sentiment_distribution.csv; reports/company_insights/company_aspect_summary.csv; reports/tv4_company_sentiment_insights.md</a:t>
+              <a:t>[Thời lượng mục tiêu: 35s (0:35)]</a:t>
+            </a:r>
+          </a:p>
+          <a:p xmlns:a="http://schemas.openxmlformats.org/drawingml/2006/main">
+            <a:r>
+              <a:t>Khám phá 5 công ty: Lương &amp; đãi ngộ thấp nhất ở 4/5 công ty, riêng VNG thấp nhất ở Quản lý. Đây là phân tích mô tả trên dữ liệu thu thập, nhóm không xếp hạng công ty thực tế. (~35s)</a:t>
             </a:r>
           </a:p>
         </p:txBody>
@@ -719,30 +681,12 @@
           <a:lstStyle xmlns:a="http://schemas.openxmlformats.org/drawingml/2006/main"/>
           <a:p xmlns:a="http://schemas.openxmlformats.org/drawingml/2006/main">
             <a:r>
-              <a:t>[Thời lượng mục tiêu: 65s]</a:t>
-            </a:r>
-          </a:p>
-          <a:p xmlns:a="http://schemas.openxmlformats.org/drawingml/2006/main">
-            <a:r>
-              <a:t>Giải thích biểu đồ token. Sửa cách gọi 'token kích hoạt quyết định': hiện app chỉ hiển thị TF-IDF, chưa nhân với hệ số theo lớp.</a:t>
-            </a:r>
-          </a:p>
-          <a:p xmlns:a="http://schemas.openxmlformats.org/drawingml/2006/main">
-            <a:r>
-              <a:t/>
-            </a:r>
-          </a:p>
-          <a:p xmlns:a="http://schemas.openxmlformats.org/drawingml/2006/main">
-            <a:r>
-              <a:t>Nguồn nội bộ: src/tv4_analysis.py; app_pages/predict.py</a:t>
-            </a:r>
-          </a:p>
-          <a:p xmlns:a="http://schemas.openxmlformats.org/drawingml/2006/main">
-            <a:r>
-              <a:t>
-[Sources]
-current predict_review() output for the slide 4 example
-[/Sources]</a:t>
+              <a:t>[Thời lượng mục tiêu: 35s (0:35)]</a:t>
+            </a:r>
+          </a:p>
+          <a:p xmlns:a="http://schemas.openxmlformats.org/drawingml/2006/main">
+            <a:r>
+              <a:t>Minh họa câu test OT không lương: Bản sửa nhận diện Tiêu cực 99,0%. Bigram “thường_xuyên ot”, “không lương” nổi bật rõ nét. Trục biểu đồ nhân 100 để quan sát, không phải xác suất. (~35s)</a:t>
             </a:r>
           </a:p>
         </p:txBody>
@@ -812,30 +756,12 @@
           <a:lstStyle xmlns:a="http://schemas.openxmlformats.org/drawingml/2006/main"/>
           <a:p xmlns:a="http://schemas.openxmlformats.org/drawingml/2006/main">
             <a:r>
-              <a:t>[Thời lượng mục tiêu: 55s]</a:t>
-            </a:r>
-          </a:p>
-          <a:p xmlns:a="http://schemas.openxmlformats.org/drawingml/2006/main">
-            <a:r>
-              <a:t>Tóm tắt thành tựu, bài học và hạn chế. Nêu khoảng cách CV–Final Test nhỏ nhưng không biến điều đó thành khẳng định mô hình đã giải quyết tốt lớp thiểu số.</a:t>
-            </a:r>
-          </a:p>
-          <a:p xmlns:a="http://schemas.openxmlformats.org/drawingml/2006/main">
-            <a:r>
-              <a:t/>
-            </a:r>
-          </a:p>
-          <a:p xmlns:a="http://schemas.openxmlformats.org/drawingml/2006/main">
-            <a:r>
-              <a:t>Nguồn nội bộ: reports/tv4_model_evaluation_error_analysis.md; reports/modeling_hyperparameter_tuning.md</a:t>
-            </a:r>
-          </a:p>
-          <a:p xmlns:a="http://schemas.openxmlformats.org/drawingml/2006/main">
-            <a:r>
-              <a:t>
-[Sources]
-models/retrained_v2/training_audit.json; reports/evaluation/retrained_v2/final_test_snapshot.json
-[/Sources]</a:t>
+              <a:t>[Thời lượng mục tiêu: 35s (0:35)]</a:t>
+            </a:r>
+          </a:p>
+          <a:p xmlns:a="http://schemas.openxmlformats.org/drawingml/2006/main">
+            <a:r>
+              <a:t>Nhóm sinh viên năm nhất hoàn thành trọn vẹn pipeline học máy. Hạn chế: nhãn yếu từ rating, Negative F1 chỉ 0,3910, mô hình TF-IDF chưa hiểu ngữ nghĩa sâu của câu phức. (~35s)</a:t>
             </a:r>
           </a:p>
         </p:txBody>
@@ -905,30 +831,12 @@
           <a:lstStyle xmlns:a="http://schemas.openxmlformats.org/drawingml/2006/main"/>
           <a:p xmlns:a="http://schemas.openxmlformats.org/drawingml/2006/main">
             <a:r>
-              <a:t>[Thời lượng mục tiêu: 35s]</a:t>
-            </a:r>
-          </a:p>
-          <a:p xmlns:a="http://schemas.openxmlformats.org/drawingml/2006/main">
-            <a:r>
-              <a:t>Kết luận ngắn và chuyển thẳng sang live demo ở slide cuối. Phần Q&amp;A bắt đầu sau khi demo xong.</a:t>
-            </a:r>
-          </a:p>
-          <a:p xmlns:a="http://schemas.openxmlformats.org/drawingml/2006/main">
-            <a:r>
-              <a:t/>
-            </a:r>
-          </a:p>
-          <a:p xmlns:a="http://schemas.openxmlformats.org/drawingml/2006/main">
-            <a:r>
-              <a:t>Nguồn nội bộ: README.md; reports/final_report_outline.md</a:t>
-            </a:r>
-          </a:p>
-          <a:p xmlns:a="http://schemas.openxmlformats.org/drawingml/2006/main">
-            <a:r>
-              <a:t>
-[Sources]
-scripts/retrain_sentiment_after_preprocessing.py; reports/retrained_v2_evaluation.md
-[/Sources]</a:t>
+              <a:t>[Thời lượng mục tiêu: 30s (0:30)]</a:t>
+            </a:r>
+          </a:p>
+          <a:p xmlns:a="http://schemas.openxmlformats.org/drawingml/2006/main">
+            <a:r>
+              <a:t>Đóng góp: Pipeline chuẩn mực, đánh giá minh bạch, ứng dụng demo. Hướng tới: gán nhãn chuẩn, ABSA khía cạnh, PhoBERT. Kết thúc slide, mời bạn Khang live demo. (~30s)</a:t>
             </a:r>
           </a:p>
         </p:txBody>
@@ -998,22 +906,12 @@
           <a:lstStyle xmlns:a="http://schemas.openxmlformats.org/drawingml/2006/main"/>
           <a:p xmlns:a="http://schemas.openxmlformats.org/drawingml/2006/main">
             <a:r>
-              <a:t>[Thời lượng mục tiêu: 55s]</a:t>
-            </a:r>
-          </a:p>
-          <a:p xmlns:a="http://schemas.openxmlformats.org/drawingml/2006/main">
-            <a:r>
-              <a:t>Dẫn dắt ngắn rồi chuyển sang ứng dụng. Bạn Nguyễn Duy Khang trình bày: nhập review, đọc nhãn và xác suất, sau đó kiểm tra văn bản đã xử lý và token nổi bật. Slide không hiển thị trước kết quả demo.</a:t>
-            </a:r>
-          </a:p>
-          <a:p xmlns:a="http://schemas.openxmlformats.org/drawingml/2006/main">
-            <a:r>
-              <a:t/>
-            </a:r>
-          </a:p>
-          <a:p xmlns:a="http://schemas.openxmlformats.org/drawingml/2006/main">
-            <a:r>
-              <a:t>Nguồn nội bộ: app_pages/predict.py; src/tv4_analysis.py</a:t>
+              <a:t>[Thời lượng mục tiêu: 25s (0:25)]</a:t>
+            </a:r>
+          </a:p>
+          <a:p xmlns:a="http://schemas.openxmlformats.org/drawingml/2006/main">
+            <a:r>
+              <a:t>Bạn Nguyễn Duy Khang chuyển sang ứng dụng Streamlit đã mở sẵn để thao tác trực tiếp 3 tính năng: Insight doanh nghiệp -&gt; Đánh giá 1 lỗi -&gt; Phân tích review theo thời gian thực (~25s dẫn dắt).</a:t>
             </a:r>
           </a:p>
         </p:txBody>
@@ -1083,22 +981,12 @@
           <a:lstStyle xmlns:a="http://schemas.openxmlformats.org/drawingml/2006/main"/>
           <a:p xmlns:a="http://schemas.openxmlformats.org/drawingml/2006/main">
             <a:r>
-              <a:t>[Thời lượng mục tiêu: 40s]</a:t>
-            </a:r>
-          </a:p>
-          <a:p xmlns:a="http://schemas.openxmlformats.org/drawingml/2006/main">
-            <a:r>
-              <a:t>Giải thích vì sao Accuracy không đủ và vì sao dự án ưu tiên Macro F1. Nhắc rõ bản chất weak label.</a:t>
-            </a:r>
-          </a:p>
-          <a:p xmlns:a="http://schemas.openxmlformats.org/drawingml/2006/main">
-            <a:r>
-              <a:t/>
-            </a:r>
-          </a:p>
-          <a:p xmlns:a="http://schemas.openxmlformats.org/drawingml/2006/main">
-            <a:r>
-              <a:t>Nguồn nội bộ: README.md mục 2.2; reports/eda_feature_engineering.md mục 3.1.1</a:t>
+              <a:t>[Thời lượng mục tiêu: 35s (0:35)]</a:t>
+            </a:r>
+          </a:p>
+          <a:p xmlns:a="http://schemas.openxmlformats.org/drawingml/2006/main">
+            <a:r>
+              <a:t>Hai thử thách: mất cân bằng lớp 11:1 (73,8% vs 6,8%) nên cần Macro F1 làm thước đo chính. Nhãn yếu suy từ số sao, lời review thường vừa khen vừa chê. (~35s)</a:t>
             </a:r>
           </a:p>
         </p:txBody>
@@ -1168,30 +1056,12 @@
           <a:lstStyle xmlns:a="http://schemas.openxmlformats.org/drawingml/2006/main"/>
           <a:p xmlns:a="http://schemas.openxmlformats.org/drawingml/2006/main">
             <a:r>
-              <a:t>[Thời lượng mục tiêu: 30s]</a:t>
-            </a:r>
-          </a:p>
-          <a:p xmlns:a="http://schemas.openxmlformats.org/drawingml/2006/main">
-            <a:r>
-              <a:t>Đi nhanh qua năm bước. Tập trung vào nguyên tắc: chọn feature và model trên Development, chỉ mở Final Test một lần.</a:t>
-            </a:r>
-          </a:p>
-          <a:p xmlns:a="http://schemas.openxmlformats.org/drawingml/2006/main">
-            <a:r>
-              <a:t/>
-            </a:r>
-          </a:p>
-          <a:p xmlns:a="http://schemas.openxmlformats.org/drawingml/2006/main">
-            <a:r>
-              <a:t>Nguồn nội bộ: README.md mục 2.4; models/artifact_manifest.json</a:t>
-            </a:r>
-          </a:p>
-          <a:p xmlns:a="http://schemas.openxmlformats.org/drawingml/2006/main">
-            <a:r>
-              <a:t>
-[Sources]
-reports/evaluation/retrained_v2/final_test_snapshot.json
-[/Sources]</a:t>
+              <a:t>[Thời lượng mục tiêu: 35s (0:35)]</a:t>
+            </a:r>
+          </a:p>
+          <a:p xmlns:a="http://schemas.openxmlformats.org/drawingml/2006/main">
+            <a:r>
+              <a:t>Quy trình 5 bước: làm sạch 2 tầng, TF-IDF, thử 5 mô hình với SMOTE trên tập Development. Bản retrained_v2 đạt Macro F1 0,5764 trên cùng Final Test cũ làm đối chứng. (~35s)</a:t>
             </a:r>
           </a:p>
         </p:txBody>
@@ -1261,30 +1131,12 @@
           <a:lstStyle xmlns:a="http://schemas.openxmlformats.org/drawingml/2006/main"/>
           <a:p xmlns:a="http://schemas.openxmlformats.org/drawingml/2006/main">
             <a:r>
-              <a:t>[Thời lượng mục tiêu: 50s]</a:t>
-            </a:r>
-          </a:p>
-          <a:p xmlns:a="http://schemas.openxmlformats.org/drawingml/2006/main">
-            <a:r>
-              <a:t>Trình bày hai tầng tiền xử lý và đọc ví dụ. Không khẳng định mọi từ ghép đều có dấu gạch dưới vì kết quả phụ thuộc tokenizer/runtime.</a:t>
-            </a:r>
-          </a:p>
-          <a:p xmlns:a="http://schemas.openxmlformats.org/drawingml/2006/main">
-            <a:r>
-              <a:t/>
-            </a:r>
-          </a:p>
-          <a:p xmlns:a="http://schemas.openxmlformats.org/drawingml/2006/main">
-            <a:r>
-              <a:t>Nguồn nội bộ: src/preprocessing.py; src/tv4_analysis.py</a:t>
-            </a:r>
-          </a:p>
-          <a:p xmlns:a="http://schemas.openxmlformats.org/drawingml/2006/main">
-            <a:r>
-              <a:t>
-[Sources]
-src/preprocessing.py; current predict_review() output
-[/Sources]</a:t>
+              <a:t>[Thời lượng mục tiêu: 35s (0:35)]</a:t>
+            </a:r>
+          </a:p>
+          <a:p xmlns:a="http://schemas.openxmlformats.org/drawingml/2006/main">
+            <a:r>
+              <a:t>Tầng 1 chuẩn hóa ký tự và thuật ngữ IT. Tầng 2 tách từ tiếng Việt và tuyệt đối giữ lại từ phủ định (không, chưa) và từ mức độ (thấp, thiếu) để tránh hiểu ngược câu. (~35s)</a:t>
             </a:r>
           </a:p>
         </p:txBody>
@@ -1354,22 +1206,12 @@
           <a:lstStyle xmlns:a="http://schemas.openxmlformats.org/drawingml/2006/main"/>
           <a:p xmlns:a="http://schemas.openxmlformats.org/drawingml/2006/main">
             <a:r>
-              <a:t>[Thời lượng mục tiêu: 50s]</a:t>
-            </a:r>
-          </a:p>
-          <a:p xmlns:a="http://schemas.openxmlformats.org/drawingml/2006/main">
-            <a:r>
-              <a:t>Nêu ba tương quan chính. Giải thích vì sao không đưa điểm khía cạnh vào pipeline text-only: tránh shortcut và giữ đúng bối cảnh suy luận.</a:t>
-            </a:r>
-          </a:p>
-          <a:p xmlns:a="http://schemas.openxmlformats.org/drawingml/2006/main">
-            <a:r>
-              <a:t/>
-            </a:r>
-          </a:p>
-          <a:p xmlns:a="http://schemas.openxmlformats.org/drawingml/2006/main">
-            <a:r>
-              <a:t>Nguồn nội bộ: reports/eda_feature_engineering.md mục 3.1.3; reports/figures/eda_aspect_correlation.png</a:t>
+              <a:t>[Thời lượng mục tiêu: 30s (0:30)]</a:t>
+            </a:r>
+          </a:p>
+          <a:p xmlns:a="http://schemas.openxmlformats.org/drawingml/2006/main">
+            <a:r>
+              <a:t>Lương và Quản lý tương quan cao nhất với rating (&gt;0,73), văn phòng thấp hơn (~0,54). Pipeline chính chỉ dùng văn bản vì thực tế người dùng không chấm điểm phụ. (~30s)</a:t>
             </a:r>
           </a:p>
         </p:txBody>
@@ -1439,22 +1281,12 @@
           <a:lstStyle xmlns:a="http://schemas.openxmlformats.org/drawingml/2006/main"/>
           <a:p xmlns:a="http://schemas.openxmlformats.org/drawingml/2006/main">
             <a:r>
-              <a:t>[Thời lượng mục tiêu: 50s]</a:t>
-            </a:r>
-          </a:p>
-          <a:p xmlns:a="http://schemas.openxmlformats.org/drawingml/2006/main">
-            <a:r>
-              <a:t>Giải thích lợi ích của bigram và nhắc lại contract dữ liệu sau duplicate audit. Tập Final Test không tham gia chọn feature.</a:t>
-            </a:r>
-          </a:p>
-          <a:p xmlns:a="http://schemas.openxmlformats.org/drawingml/2006/main">
-            <a:r>
-              <a:t/>
-            </a:r>
-          </a:p>
-          <a:p xmlns:a="http://schemas.openxmlformats.org/drawingml/2006/main">
-            <a:r>
-              <a:t>Nguồn nội bộ: reports/eda_feature_engineering.md mục 3.2.3; models/artifact_manifest.json</a:t>
+              <a:t>[Thời lượng mục tiêu: 35s (0:35)]</a:t>
+            </a:r>
+          </a:p>
+          <a:p xmlns:a="http://schemas.openxmlformats.org/drawingml/2006/main">
+            <a:r>
+              <a:t>TF-IDF thêm Bigram tăng Macro F1 từ 55,69% lên 57,22%, giữ được cụm “không lương”, “thiếu minh bạch”. Cấu hình 5.000 đặc trưng, chia tập Stratified 80/20 giữ nguyên tỷ lệ lớp. (~35s)</a:t>
             </a:r>
           </a:p>
         </p:txBody>
@@ -1524,22 +1356,12 @@
           <a:lstStyle xmlns:a="http://schemas.openxmlformats.org/drawingml/2006/main"/>
           <a:p xmlns:a="http://schemas.openxmlformats.org/drawingml/2006/main">
             <a:r>
-              <a:t>[Thời lượng mục tiêu: 55s]</a:t>
-            </a:r>
-          </a:p>
-          <a:p xmlns:a="http://schemas.openxmlformats.org/drawingml/2006/main">
-            <a:r>
-              <a:t>Giới thiệu nhanh năm mô hình. Tập trung giải thích vị trí của SMOTE trong Pipeline và lý do chống data leakage.</a:t>
-            </a:r>
-          </a:p>
-          <a:p xmlns:a="http://schemas.openxmlformats.org/drawingml/2006/main">
-            <a:r>
-              <a:t/>
-            </a:r>
-          </a:p>
-          <a:p xmlns:a="http://schemas.openxmlformats.org/drawingml/2006/main">
-            <a:r>
-              <a:t>Nguồn nội bộ: reports/modeling_hyperparameter_tuning.md mục 4.2.1; src/models.py</a:t>
+              <a:t>[Thời lượng mục tiêu: 35s (0:35)]</a:t>
+            </a:r>
+          </a:p>
+          <a:p xmlns:a="http://schemas.openxmlformats.org/drawingml/2006/main">
+            <a:r>
+              <a:t>Thử 5 mô hình cơ bản. SMOTE chỉ áp dụng bên trong fold huấn luyện để chống rò rỉ dữ liệu (Data Leakage), giữ nguyên vẹn tập validation. (~35s)</a:t>
             </a:r>
           </a:p>
         </p:txBody>
@@ -1609,30 +1431,12 @@
           <a:lstStyle xmlns:a="http://schemas.openxmlformats.org/drawingml/2006/main"/>
           <a:p xmlns:a="http://schemas.openxmlformats.org/drawingml/2006/main">
             <a:r>
-              <a:t>[Thời lượng mục tiêu: 45s]</a:t>
-            </a:r>
-          </a:p>
-          <a:p xmlns:a="http://schemas.openxmlformats.org/drawingml/2006/main">
-            <a:r>
-              <a:t>Nêu top 2 gần như ngang nhau. Logistic Regression được chọn vì điểm CV nhỉnh hơn và trả xác suất trực tiếp, không phải vì vượt trội rõ về thống kê.</a:t>
-            </a:r>
-          </a:p>
-          <a:p xmlns:a="http://schemas.openxmlformats.org/drawingml/2006/main">
-            <a:r>
-              <a:t/>
-            </a:r>
-          </a:p>
-          <a:p xmlns:a="http://schemas.openxmlformats.org/drawingml/2006/main">
-            <a:r>
-              <a:t>Nguồn nội bộ: reports/evaluation/model_ranking_cv.csv; reports/modeling_hyperparameter_tuning.md mục 5.1</a:t>
-            </a:r>
-          </a:p>
-          <a:p xmlns:a="http://schemas.openxmlformats.org/drawingml/2006/main">
-            <a:r>
-              <a:t>
-[Sources]
-reports/evaluation/model_ranking_cv.csv; models/retrained_v2/training_audit.json
-[/Sources]</a:t>
+              <a:t>[Thời lượng mục tiêu: 40s (0:40)]</a:t>
+            </a:r>
+          </a:p>
+          <a:p xmlns:a="http://schemas.openxmlformats.org/drawingml/2006/main">
+            <a:r>
+              <a:t>Xếp hạng ban đầu: LR (0,5727) và SVM (0,5724) bám sát nhau. Chọn LR vì trả xác suất. Sau sửa tiền xử lý, chạy phép CV riêng tăng lên 0,5815 (không trừ điểm trực tiếp vào bảng cũ). (~40s)</a:t>
             </a:r>
           </a:p>
         </p:txBody>
@@ -1702,30 +1506,12 @@
           <a:lstStyle xmlns:a="http://schemas.openxmlformats.org/drawingml/2006/main"/>
           <a:p xmlns:a="http://schemas.openxmlformats.org/drawingml/2006/main">
             <a:r>
-              <a:t>[Thời lượng mục tiêu: 60s]</a:t>
-            </a:r>
-          </a:p>
-          <a:p xmlns:a="http://schemas.openxmlformats.org/drawingml/2006/main">
-            <a:r>
-              <a:t>Đọc ba chỉ số chính, sau đó chỉ vào confusion matrix. Nhấn mạnh lớp Positive mạnh, Negative yếu và Accuracy trùng mức majority baseline.</a:t>
-            </a:r>
-          </a:p>
-          <a:p xmlns:a="http://schemas.openxmlformats.org/drawingml/2006/main">
-            <a:r>
-              <a:t/>
-            </a:r>
-          </a:p>
-          <a:p xmlns:a="http://schemas.openxmlformats.org/drawingml/2006/main">
-            <a:r>
-              <a:t>Nguồn nội bộ: reports/evaluation/final_test_metrics.csv; reports/evaluation/confusion_matrix.csv; reports/evaluation/final_test_per_class.csv</a:t>
-            </a:r>
-          </a:p>
-          <a:p xmlns:a="http://schemas.openxmlformats.org/drawingml/2006/main">
-            <a:r>
-              <a:t>
-[Sources]
-reports/evaluation/retrained_v2/final_test_snapshot.json; final_test_per_class.csv; confusion_matrix.csv
-[/Sources]</a:t>
+              <a:t>[Thời lượng mục tiêu: 45s (0:45)]</a:t>
+            </a:r>
+          </a:p>
+          <a:p xmlns:a="http://schemas.openxmlformats.org/drawingml/2006/main">
+            <a:r>
+              <a:t>Final Test cũ: Accuracy 74,33%, Macro F1 0,5764, sai 432 mẫu. Lớp Negative: tìm đúng 52/114 mẫu, Recall chỉ đạt 45,6% (F1 0,3910). Nhận diện lời chê là thách thức lớn nhất của bài toán. (~45s)</a:t>
             </a:r>
           </a:p>
         </p:txBody>

</xml_diff>

<commit_message>
docs(slides): sync presentation deck, script and Q&A with retrained_v2 metrics
- Synchronize Slide 9 metrics (Negative Recall 45.6%, error reduction -10)
- Add sample review quote box to Slide 12 (Negative 99.0%)
- Clarify error categorization wording on Slide 10
- Enrich defense Q&A on Logistic Regression vs SVM and retrained_v2
- Consolidate to single master PPTX file and sync DOCX/MD scripts
</commit_message>
<xml_diff>
--- a/reports/slides/ITviec_Sentiment_Analysis.pptx
+++ b/reports/slides/ITviec_Sentiment_Analysis.pptx
@@ -4282,6 +4282,10 @@
             <a:prstDash val="solid"/>
           </a:ln>
         </p:spPr>
+        <p:txBody xmlns:a="http://schemas.openxmlformats.org/drawingml/2006/main">
+          <a:bodyPr/>
+          <a:p/>
+        </p:txBody>
       </p:sp>
       <p:sp>
         <p:nvSpPr>
@@ -4568,7 +4572,7 @@
                 <a:ea typeface="Helvetica Neue"/>
                 <a:cs typeface="Helvetica Neue"/>
               </a:rPr>
-              <a:t>15 lỗi được nhóm tự động theo dấu hiệu văn bản; không đại diện toàn bộ 432 lỗi.</a:t>
+              <a:t>15 lỗi đại diện được trích xuất minh họa cho 3 dạng khó phổ biến.</a:t>
             </a:r>
           </a:p>
         </p:txBody>
@@ -4777,6 +4781,10 @@
             <a:prstDash val="solid"/>
           </a:ln>
         </p:spPr>
+        <p:txBody xmlns:a="http://schemas.openxmlformats.org/drawingml/2006/main">
+          <a:bodyPr/>
+          <a:p/>
+        </p:txBody>
       </p:sp>
       <p:sp>
         <p:nvSpPr>
@@ -4982,6 +4990,10 @@
             <a:prstDash val="solid"/>
           </a:ln>
         </p:spPr>
+        <p:txBody xmlns:a="http://schemas.openxmlformats.org/drawingml/2006/main">
+          <a:bodyPr/>
+          <a:p/>
+        </p:txBody>
       </p:sp>
       <p:sp>
         <p:nvSpPr>
@@ -5210,7 +5222,7 @@
                 <a:ea typeface="Helvetica Neue"/>
                 <a:cs typeface="Helvetica Neue"/>
               </a:rPr>
-              <a:t>Nhóm lỗi là gợi ý tự động; cần đọc và gán nhãn thủ công thêm trước khi kết luận nguyên nhân.</a:t>
+              <a:t>Dạng lỗi do hệ thống phân loại sơ bộ theo từ khóa và cấu trúc câu.</a:t>
             </a:r>
           </a:p>
         </p:txBody>
@@ -6145,6 +6157,10 @@
             <a:prstDash val="solid"/>
           </a:ln>
         </p:spPr>
+        <p:txBody xmlns:a="http://schemas.openxmlformats.org/drawingml/2006/main">
+          <a:bodyPr/>
+          <a:p/>
+        </p:txBody>
       </p:sp>
       <p:sp>
         <p:nvSpPr>
@@ -6622,6 +6638,89 @@
                 <a:cs typeface="Helvetica Neue"/>
               </a:rPr>
               <a:t>Trọng số TF-IDF cho biết độ nổi bật. Muốn biết chiều tác động cần xem thêm hệ số Logistic Regression.</a:t>
+            </a:r>
+          </a:p>
+        </p:txBody>
+      </p:sp>
+      <p:sp xmlns:a="http://schemas.openxmlformats.org/drawingml/2006/main">
+        <p:nvSpPr>
+          <p:cNvPr id="20" name="Rounded Rectangle 19"/>
+          <p:cNvSpPr/>
+          <p:nvPr/>
+        </p:nvSpPr>
+        <p:spPr>
+          <a:xfrm>
+            <a:off x="612648" y="5870448"/>
+            <a:ext cx="10424160" cy="475488"/>
+          </a:xfrm>
+          <a:prstGeom prst="roundRect">
+            <a:avLst>
+              <a:gd name="adj" fmla="val 15000"/>
+            </a:avLst>
+          </a:prstGeom>
+          <a:solidFill>
+            <a:srgbClr val="141B26"/>
+          </a:solidFill>
+          <a:ln w="12700">
+            <a:solidFill>
+              <a:srgbClr val="7AA7FF"/>
+            </a:solidFill>
+          </a:ln>
+        </p:spPr>
+        <p:style>
+          <a:lnRef idx="1">
+            <a:schemeClr val="accent1"/>
+          </a:lnRef>
+          <a:fillRef idx="3">
+            <a:schemeClr val="accent1"/>
+          </a:fillRef>
+          <a:effectRef idx="2">
+            <a:schemeClr val="accent1"/>
+          </a:effectRef>
+          <a:fontRef idx="minor">
+            <a:schemeClr val="lt1"/>
+          </a:fontRef>
+        </p:style>
+        <p:txBody>
+          <a:bodyPr rtlCol="0" anchor="ctr" lIns="182880" rIns="182880" tIns="73152" bIns="73152"/>
+          <a:lstStyle/>
+          <a:p>
+            <a:pPr algn="l"/>
+            <a:r>
+              <a:rPr sz="1200" b="1">
+                <a:solidFill>
+                  <a:srgbClr val="7AA7FF"/>
+                </a:solidFill>
+                <a:latin typeface="Helvetica Neue"/>
+              </a:rPr>
+              <a:t>💬 Review minh họa: </a:t>
+            </a:r>
+            <a:r>
+              <a:rPr sz="1200" i="1">
+                <a:solidFill>
+                  <a:srgbClr val="F1F5F9"/>
+                </a:solidFill>
+                <a:latin typeface="Helvetica Neue"/>
+              </a:rPr>
+              <a:t>"Lương thấp, quản lý thiếu minh bạch và thường xuyên phải OT không lương."</a:t>
+            </a:r>
+            <a:r>
+              <a:rPr sz="1200" b="1">
+                <a:solidFill>
+                  <a:srgbClr val="9EABBA"/>
+                </a:solidFill>
+                <a:latin typeface="Helvetica Neue"/>
+              </a:rPr>
+              <a:t>  →  Mô hình nhận diện: </a:t>
+            </a:r>
+            <a:r>
+              <a:rPr sz="1200" b="1">
+                <a:solidFill>
+                  <a:srgbClr val="FF6677"/>
+                </a:solidFill>
+                <a:latin typeface="Helvetica Neue"/>
+              </a:rPr>
+              <a:t>Tiêu cực (99,0%)</a:t>
             </a:r>
           </a:p>
         </p:txBody>
@@ -19169,7 +19268,7 @@
         <p:spPr>
           <a:xfrm xmlns:a="http://schemas.openxmlformats.org/drawingml/2006/main">
             <a:off x="8210550" y="1838325"/>
-            <a:ext cx="2381250" cy="514350"/>
+            <a:ext cx="2381250" cy="731520"/>
           </a:xfrm>
           <a:prstGeom xmlns:a="http://schemas.openxmlformats.org/drawingml/2006/main" prst="rect">
             <a:avLst/>
@@ -19197,7 +19296,7 @@
               </a:defRPr>
             </a:pPr>
             <a:r>
-              <a:rPr sz="2850" b="1">
+              <a:rPr sz="2200" b="1">
                 <a:solidFill>
                   <a:srgbClr val="F4F7FB"/>
                 </a:solidFill>
@@ -19206,6 +19305,18 @@
                 <a:cs typeface="Helvetica Neue"/>
               </a:rPr>
               <a:t>432 / 1.683</a:t>
+            </a:r>
+          </a:p>
+          <a:p xmlns:a="http://schemas.openxmlformats.org/drawingml/2006/main">
+            <a:pPr algn="l"/>
+            <a:r>
+              <a:rPr sz="1100" b="1">
+                <a:solidFill>
+                  <a:srgbClr val="50E3A4"/>
+                </a:solidFill>
+                <a:latin typeface="Helvetica Neue"/>
+              </a:rPr>
+              <a:t>(Bản cũ: 442 → Giảm 10 mẫu)</a:t>
             </a:r>
           </a:p>
         </p:txBody>
@@ -19358,16 +19469,12 @@
                     <a:bodyPr/>
                     <a:lstStyle/>
                     <a:p>
+                      <a:pPr algn="ctr"/>
                       <a:r>
-                        <a:rPr sz="1425" b="1">
-                          <a:solidFill>
-                            <a:srgbClr val="F4F7FB"/>
-                          </a:solidFill>
+                        <a:rPr sz="1300" b="1">
                           <a:latin typeface="Helvetica Neue"/>
-                          <a:ea typeface="Helvetica Neue"/>
-                          <a:cs typeface="Helvetica Neue"/>
                         </a:rPr>
-                        <a:t>52</a:t>
+                        <a:t>52 (45,6%)</a:t>
                       </a:r>
                     </a:p>
                   </a:txBody>
@@ -19480,16 +19587,12 @@
                     <a:bodyPr/>
                     <a:lstStyle/>
                     <a:p>
+                      <a:pPr algn="ctr"/>
                       <a:r>
-                        <a:rPr sz="1425" b="1">
-                          <a:solidFill>
-                            <a:srgbClr val="F4F7FB"/>
-                          </a:solidFill>
+                        <a:rPr sz="1300" b="1">
                           <a:latin typeface="Helvetica Neue"/>
-                          <a:ea typeface="Helvetica Neue"/>
-                          <a:cs typeface="Helvetica Neue"/>
                         </a:rPr>
-                        <a:t>168</a:t>
+                        <a:t>168 (51,2%)</a:t>
                       </a:r>
                     </a:p>
                   </a:txBody>
@@ -19602,16 +19705,12 @@
                     <a:bodyPr/>
                     <a:lstStyle/>
                     <a:p>
+                      <a:pPr algn="ctr"/>
                       <a:r>
-                        <a:rPr sz="1425" b="1">
-                          <a:solidFill>
-                            <a:srgbClr val="F4F7FB"/>
-                          </a:solidFill>
+                        <a:rPr sz="1300" b="1">
                           <a:latin typeface="Helvetica Neue"/>
-                          <a:ea typeface="Helvetica Neue"/>
-                          <a:cs typeface="Helvetica Neue"/>
                         </a:rPr>
-                        <a:t>1.031</a:t>
+                        <a:t>1.031 (83,1%)</a:t>
                       </a:r>
                     </a:p>
                   </a:txBody>
@@ -19753,7 +19852,63 @@
                 <a:ea typeface="Helvetica Neue"/>
                 <a:cs typeface="Helvetica Neue"/>
               </a:rPr>
-              <a:t>Final Test cũ được dùng lại để đối chiếu bản sửa, không phải tập kiểm thử độc lập mới.</a:t>
+              <a:t>Đánh giá trên cùng tập Final Test chuẩn (1.683 mẫu) để bảo đảm tính đối chứng công bằng giữa hai phiên bản.</a:t>
+            </a:r>
+          </a:p>
+        </p:txBody>
+      </p:sp>
+      <p:sp xmlns:a="http://schemas.openxmlformats.org/drawingml/2006/main">
+        <p:nvSpPr>
+          <p:cNvPr id="34" name="Rounded Rectangle 33"/>
+          <p:cNvSpPr/>
+          <p:nvPr/>
+        </p:nvSpPr>
+        <p:spPr>
+          <a:xfrm>
+            <a:off x="7242048" y="5321808"/>
+            <a:ext cx="4005072" cy="347472"/>
+          </a:xfrm>
+          <a:prstGeom prst="roundRect">
+            <a:avLst>
+              <a:gd name="adj" fmla="val 20000"/>
+            </a:avLst>
+          </a:prstGeom>
+          <a:solidFill>
+            <a:srgbClr val="1B2433"/>
+          </a:solidFill>
+          <a:ln w="12700">
+            <a:solidFill>
+              <a:srgbClr val="FF6677"/>
+            </a:solidFill>
+          </a:ln>
+        </p:spPr>
+        <p:style>
+          <a:lnRef idx="1">
+            <a:schemeClr val="accent1"/>
+          </a:lnRef>
+          <a:fillRef idx="3">
+            <a:schemeClr val="accent1"/>
+          </a:fillRef>
+          <a:effectRef idx="2">
+            <a:schemeClr val="accent1"/>
+          </a:effectRef>
+          <a:fontRef idx="minor">
+            <a:schemeClr val="lt1"/>
+          </a:fontRef>
+        </p:style>
+        <p:txBody>
+          <a:bodyPr rtlCol="0" anchor="ctr" lIns="0" rIns="0" tIns="0" bIns="0"/>
+          <a:lstStyle/>
+          <a:p>
+            <a:pPr algn="ctr"/>
+            <a:r>
+              <a:rPr sz="1100" b="1">
+                <a:solidFill>
+                  <a:srgbClr val="FF6677"/>
+                </a:solidFill>
+                <a:latin typeface="Helvetica Neue"/>
+              </a:rPr>
+              <a:t>⚠️ Recall Negative: 45,6% (đoán đúng 52 / 114 mẫu)</a:t>
             </a:r>
           </a:p>
         </p:txBody>

</xml_diff>

<commit_message>
docs(slides): refine ML presentation and live walkthrough (#12)
Co-authored-by: Phạm Thành Trung <ttrung.cs@gmail.com>
</commit_message>
<xml_diff>
--- a/reports/slides/ITviec_Sentiment_Analysis.pptx
+++ b/reports/slides/ITviec_Sentiment_Analysis.pptx
@@ -2,27 +2,27 @@
 <file path=ppt/presentation.xml><?xml version="1.0" encoding="utf-8"?>
 <p:presentation xmlns:p="http://schemas.openxmlformats.org/presentationml/2006/main">
   <p:sldMasterIdLst>
-    <p:sldMasterId xmlns:r="http://schemas.openxmlformats.org/officeDocument/2006/relationships" id="2147483648" r:id="Rd35db0d22386409d"/>
+    <p:sldMasterId xmlns:r="http://schemas.openxmlformats.org/officeDocument/2006/relationships" id="2147483648" r:id="Rb640ac4891e74163"/>
   </p:sldMasterIdLst>
   <p:notesMasterIdLst>
-    <p:notesMasterId xmlns:r="http://schemas.openxmlformats.org/officeDocument/2006/relationships" r:id="Rf9ab59980ceb4569"/>
+    <p:notesMasterId xmlns:r="http://schemas.openxmlformats.org/officeDocument/2006/relationships" r:id="Rb924613fcd154621"/>
   </p:notesMasterIdLst>
   <p:sldIdLst>
-    <p:sldId xmlns:r="http://schemas.openxmlformats.org/officeDocument/2006/relationships" id="256" r:id="Ra35b33c4dafd4abc"/>
-    <p:sldId xmlns:r="http://schemas.openxmlformats.org/officeDocument/2006/relationships" id="257" r:id="Rad07964a62ea4fc0"/>
-    <p:sldId xmlns:r="http://schemas.openxmlformats.org/officeDocument/2006/relationships" id="258" r:id="R598d8865e61d49ac"/>
-    <p:sldId xmlns:r="http://schemas.openxmlformats.org/officeDocument/2006/relationships" id="259" r:id="R3dc5a626c00c43c5"/>
-    <p:sldId xmlns:r="http://schemas.openxmlformats.org/officeDocument/2006/relationships" id="260" r:id="R2d0667cffa8944fc"/>
-    <p:sldId xmlns:r="http://schemas.openxmlformats.org/officeDocument/2006/relationships" id="261" r:id="Rc7b01f04705545c8"/>
-    <p:sldId xmlns:r="http://schemas.openxmlformats.org/officeDocument/2006/relationships" id="262" r:id="R484a9f7f64534a4b"/>
-    <p:sldId xmlns:r="http://schemas.openxmlformats.org/officeDocument/2006/relationships" id="263" r:id="Ra00048383c1544f2"/>
-    <p:sldId xmlns:r="http://schemas.openxmlformats.org/officeDocument/2006/relationships" id="264" r:id="Ra15fcace237049f3"/>
-    <p:sldId xmlns:r="http://schemas.openxmlformats.org/officeDocument/2006/relationships" id="265" r:id="R385a2abad5514d2f"/>
-    <p:sldId xmlns:r="http://schemas.openxmlformats.org/officeDocument/2006/relationships" id="266" r:id="R951c19ce46ef4a4f"/>
-    <p:sldId xmlns:r="http://schemas.openxmlformats.org/officeDocument/2006/relationships" id="267" r:id="Ra5f000aea2534e3a"/>
-    <p:sldId xmlns:r="http://schemas.openxmlformats.org/officeDocument/2006/relationships" id="268" r:id="Rb950c3ac41ae4615"/>
-    <p:sldId xmlns:r="http://schemas.openxmlformats.org/officeDocument/2006/relationships" id="269" r:id="Re819076286cd4919"/>
-    <p:sldId xmlns:r="http://schemas.openxmlformats.org/officeDocument/2006/relationships" id="270" r:id="Rf60d6fe5ec9f411b"/>
+    <p:sldId xmlns:r="http://schemas.openxmlformats.org/officeDocument/2006/relationships" id="256" r:id="R5c553f8840ac4464"/>
+    <p:sldId xmlns:r="http://schemas.openxmlformats.org/officeDocument/2006/relationships" id="257" r:id="R88f41a88fffd45eb"/>
+    <p:sldId xmlns:r="http://schemas.openxmlformats.org/officeDocument/2006/relationships" id="258" r:id="Rb4bc289dde034a31"/>
+    <p:sldId xmlns:r="http://schemas.openxmlformats.org/officeDocument/2006/relationships" id="259" r:id="R37c7722f471544dd"/>
+    <p:sldId xmlns:r="http://schemas.openxmlformats.org/officeDocument/2006/relationships" id="260" r:id="Rfd33d9263558415a"/>
+    <p:sldId xmlns:r="http://schemas.openxmlformats.org/officeDocument/2006/relationships" id="261" r:id="R94a4e74f55e944fb"/>
+    <p:sldId xmlns:r="http://schemas.openxmlformats.org/officeDocument/2006/relationships" id="262" r:id="R4e404ce9343445c7"/>
+    <p:sldId xmlns:r="http://schemas.openxmlformats.org/officeDocument/2006/relationships" id="263" r:id="R8e2b90e3926043d4"/>
+    <p:sldId xmlns:r="http://schemas.openxmlformats.org/officeDocument/2006/relationships" id="264" r:id="Rb057348f1d69430e"/>
+    <p:sldId xmlns:r="http://schemas.openxmlformats.org/officeDocument/2006/relationships" id="265" r:id="Rd4a935e9d03949fb"/>
+    <p:sldId xmlns:r="http://schemas.openxmlformats.org/officeDocument/2006/relationships" id="266" r:id="R6f60dbf387484073"/>
+    <p:sldId xmlns:r="http://schemas.openxmlformats.org/officeDocument/2006/relationships" id="267" r:id="Rc0554a44456443dd"/>
+    <p:sldId xmlns:r="http://schemas.openxmlformats.org/officeDocument/2006/relationships" id="268" r:id="R0546d10373fc49a4"/>
+    <p:sldId xmlns:r="http://schemas.openxmlformats.org/officeDocument/2006/relationships" id="269" r:id="R293190f440b3468c"/>
+    <p:sldId xmlns:r="http://schemas.openxmlformats.org/officeDocument/2006/relationships" id="270" r:id="R20dee9a4a3904a74"/>
   </p:sldIdLst>
   <p:sldSz cx="12192000" cy="6858000"/>
   <p:notesSz cx="6858000" cy="9144000"/>
@@ -1579,7 +1579,7 @@
   </p:cSld>
   <p:clrMap bg1="lt1" tx1="dk1" bg2="lt2" tx2="dk2" accent1="accent1" accent2="accent2" accent3="accent3" accent4="accent4" accent5="accent5" accent6="accent6" hlink="hlink" folHlink="folHlink"/>
   <p:sldLayoutIdLst>
-    <p:sldLayoutId xmlns:r="http://schemas.openxmlformats.org/officeDocument/2006/relationships" id="2147483649" r:id="Rd49a1574ff894178"/>
+    <p:sldLayoutId xmlns:r="http://schemas.openxmlformats.org/officeDocument/2006/relationships" id="2147483649" r:id="Rc2fc31cd400742e3"/>
   </p:sldLayoutIdLst>
   <p:txStyles>
     <p:titleStyle>
@@ -4083,26 +4083,26 @@
           </a:p>
         </p:txBody>
       </p:sp>
-      <p:pic xmlns:a="http://schemas.openxmlformats.org/drawingml/2006/main" xmlns:r="http://schemas.openxmlformats.org/officeDocument/2006/relationships">
+      <p:pic>
         <p:nvPicPr>
-          <p:cNvPr id="14" name="Picture 13" descr="sentiment-ml-mark.png"/>
+          <p:cNvPr id="26" name="Picture 13"/>
           <p:cNvPicPr>
-            <a:picLocks noChangeAspect="1"/>
+            <a:picLocks xmlns:a="http://schemas.openxmlformats.org/drawingml/2006/main" noChangeAspect="1"/>
           </p:cNvPicPr>
           <p:nvPr/>
         </p:nvPicPr>
         <p:blipFill>
-          <a:blip r:embed="rId5"/>
-          <a:stretch>
-            <a:fillRect/>
+          <a:blip xmlns:r="http://schemas.openxmlformats.org/officeDocument/2006/relationships" xmlns:a="http://schemas.openxmlformats.org/drawingml/2006/main" r:embed="Re7269e7ac488429a"/>
+          <a:stretch xmlns:a="http://schemas.openxmlformats.org/drawingml/2006/main">
+            <a:fillRect l="0" t="0" r="0" b="0"/>
           </a:stretch>
         </p:blipFill>
         <p:spPr>
-          <a:xfrm>
+          <a:xfrm xmlns:a="http://schemas.openxmlformats.org/drawingml/2006/main">
             <a:off x="8239125" y="1476375"/>
             <a:ext cx="3095625" cy="3095625"/>
           </a:xfrm>
-          <a:prstGeom prst="rect">
+          <a:prstGeom xmlns:a="http://schemas.openxmlformats.org/drawingml/2006/main" prst="rect">
             <a:avLst/>
           </a:prstGeom>
         </p:spPr>
@@ -4282,9 +4282,10 @@
             <a:prstDash val="solid"/>
           </a:ln>
         </p:spPr>
-        <p:txBody xmlns:a="http://schemas.openxmlformats.org/drawingml/2006/main">
-          <a:bodyPr/>
-          <a:p/>
+        <p:txBody>
+          <a:bodyPr xmlns:a="http://schemas.openxmlformats.org/drawingml/2006/main"/>
+          <a:lstStyle xmlns:a="http://schemas.openxmlformats.org/drawingml/2006/main"/>
+          <a:p xmlns:a="http://schemas.openxmlformats.org/drawingml/2006/main"/>
         </p:txBody>
       </p:sp>
       <p:sp>
@@ -4781,9 +4782,10 @@
             <a:prstDash val="solid"/>
           </a:ln>
         </p:spPr>
-        <p:txBody xmlns:a="http://schemas.openxmlformats.org/drawingml/2006/main">
-          <a:bodyPr/>
-          <a:p/>
+        <p:txBody>
+          <a:bodyPr xmlns:a="http://schemas.openxmlformats.org/drawingml/2006/main"/>
+          <a:lstStyle xmlns:a="http://schemas.openxmlformats.org/drawingml/2006/main"/>
+          <a:p xmlns:a="http://schemas.openxmlformats.org/drawingml/2006/main"/>
         </p:txBody>
       </p:sp>
       <p:sp>
@@ -4990,9 +4992,10 @@
             <a:prstDash val="solid"/>
           </a:ln>
         </p:spPr>
-        <p:txBody xmlns:a="http://schemas.openxmlformats.org/drawingml/2006/main">
-          <a:bodyPr/>
-          <a:p/>
+        <p:txBody>
+          <a:bodyPr xmlns:a="http://schemas.openxmlformats.org/drawingml/2006/main"/>
+          <a:lstStyle xmlns:a="http://schemas.openxmlformats.org/drawingml/2006/main"/>
+          <a:p xmlns:a="http://schemas.openxmlformats.org/drawingml/2006/main"/>
         </p:txBody>
       </p:sp>
       <p:sp>
@@ -5473,7 +5476,7 @@
         </p:xfrm>
         <a:graphic xmlns:a="http://schemas.openxmlformats.org/drawingml/2006/main">
           <a:graphicData uri="http://schemas.openxmlformats.org/drawingml/2006/chart">
-            <c:chart xmlns:r="http://schemas.openxmlformats.org/officeDocument/2006/relationships" xmlns:c="http://schemas.openxmlformats.org/drawingml/2006/chart" r:id="R0f0d06d4599148b7"/>
+            <c:chart xmlns:r="http://schemas.openxmlformats.org/officeDocument/2006/relationships" xmlns:c="http://schemas.openxmlformats.org/drawingml/2006/chart" r:id="Rf190e7675f194289"/>
           </a:graphicData>
         </a:graphic>
       </p:graphicFrame>
@@ -6157,9 +6160,10 @@
             <a:prstDash val="solid"/>
           </a:ln>
         </p:spPr>
-        <p:txBody xmlns:a="http://schemas.openxmlformats.org/drawingml/2006/main">
-          <a:bodyPr/>
-          <a:p/>
+        <p:txBody>
+          <a:bodyPr xmlns:a="http://schemas.openxmlformats.org/drawingml/2006/main"/>
+          <a:lstStyle xmlns:a="http://schemas.openxmlformats.org/drawingml/2006/main"/>
+          <a:p xmlns:a="http://schemas.openxmlformats.org/drawingml/2006/main"/>
         </p:txBody>
       </p:sp>
       <p:sp>
@@ -6222,7 +6226,7 @@
       </p:sp>
       <p:graphicFrame>
         <p:nvGraphicFramePr>
-          <p:cNvPr id="19" name="Chart"/>
+          <p:cNvPr id="26" name="Chart"/>
           <p:cNvGraphicFramePr/>
           <p:nvPr/>
         </p:nvGraphicFramePr>
@@ -6232,7 +6236,7 @@
         </p:xfrm>
         <a:graphic xmlns:a="http://schemas.openxmlformats.org/drawingml/2006/main">
           <a:graphicData uri="http://schemas.openxmlformats.org/drawingml/2006/chart">
-            <c:chart xmlns:r="http://schemas.openxmlformats.org/officeDocument/2006/relationships" xmlns:c="http://schemas.openxmlformats.org/drawingml/2006/chart" r:id="Rc85f94e2a97d4378"/>
+            <c:chart xmlns:r="http://schemas.openxmlformats.org/officeDocument/2006/relationships" xmlns:c="http://schemas.openxmlformats.org/drawingml/2006/chart" r:id="R892cce6c92ac4b84"/>
           </a:graphicData>
         </a:graphic>
       </p:graphicFrame>
@@ -6642,56 +6646,68 @@
           </a:p>
         </p:txBody>
       </p:sp>
-      <p:sp xmlns:a="http://schemas.openxmlformats.org/drawingml/2006/main">
-        <p:nvSpPr>
-          <p:cNvPr id="20" name="Rounded Rectangle 19"/>
-          <p:cNvSpPr/>
-          <p:nvPr/>
-        </p:nvSpPr>
-        <p:spPr>
-          <a:xfrm>
+      <p:sp>
+        <p:nvSpPr>
+          <p:cNvPr id="20" name="Rounded Rectangle 19">
+            <a:extLst xmlns:a="http://schemas.openxmlformats.org/drawingml/2006/main">
+              <a:ext uri="{FF2B5EF4-FFF2-40B4-BE49-F238E27FC236}">
+                <a16:creationId xmlns:a16="http://schemas.microsoft.com/office/drawing/2014/main" id="{303C1C47-2DBC-42DA-AD3E-F3E0ED78845D}"/>
+              </a:ext>
+            </a:extLst>
+          </p:cNvPr>
+          <p:cNvSpPr>
+            <a:spLocks xmlns:a="http://schemas.openxmlformats.org/drawingml/2006/main" noGrp="1"/>
+          </p:cNvSpPr>
+          <p:nvPr/>
+        </p:nvSpPr>
+        <p:spPr>
+          <a:xfrm xmlns:a="http://schemas.openxmlformats.org/drawingml/2006/main">
             <a:off x="612648" y="5870448"/>
             <a:ext cx="10424160" cy="475488"/>
           </a:xfrm>
-          <a:prstGeom prst="roundRect">
+          <a:prstGeom xmlns:a="http://schemas.openxmlformats.org/drawingml/2006/main" prst="roundRect">
             <a:avLst>
               <a:gd name="adj" fmla="val 15000"/>
             </a:avLst>
           </a:prstGeom>
-          <a:solidFill>
+          <a:solidFill xmlns:a="http://schemas.openxmlformats.org/drawingml/2006/main">
             <a:srgbClr val="141B26"/>
           </a:solidFill>
-          <a:ln w="12700">
+          <a:ln xmlns:a="http://schemas.openxmlformats.org/drawingml/2006/main" w="12700">
             <a:solidFill>
               <a:srgbClr val="7AA7FF"/>
             </a:solidFill>
           </a:ln>
         </p:spPr>
         <p:style>
-          <a:lnRef idx="1">
+          <a:lnRef xmlns:a="http://schemas.openxmlformats.org/drawingml/2006/main" idx="1">
             <a:schemeClr val="accent1"/>
           </a:lnRef>
-          <a:fillRef idx="3">
+          <a:fillRef xmlns:a="http://schemas.openxmlformats.org/drawingml/2006/main" idx="3">
             <a:schemeClr val="accent1"/>
           </a:fillRef>
-          <a:effectRef idx="2">
+          <a:effectRef xmlns:a="http://schemas.openxmlformats.org/drawingml/2006/main" idx="2">
             <a:schemeClr val="accent1"/>
           </a:effectRef>
-          <a:fontRef idx="minor">
+          <a:fontRef xmlns:a="http://schemas.openxmlformats.org/drawingml/2006/main" idx="minor">
             <a:schemeClr val="lt1"/>
           </a:fontRef>
         </p:style>
         <p:txBody>
-          <a:bodyPr rtlCol="0" anchor="ctr" lIns="182880" rIns="182880" tIns="73152" bIns="73152"/>
-          <a:lstStyle/>
-          <a:p>
-            <a:pPr algn="l"/>
+          <a:bodyPr xmlns:a="http://schemas.openxmlformats.org/drawingml/2006/main" lIns="182880" tIns="73152" rIns="182880" bIns="73152" anchor="ctr"/>
+          <a:lstStyle xmlns:a="http://schemas.openxmlformats.org/drawingml/2006/main"/>
+          <a:p xmlns:a="http://schemas.openxmlformats.org/drawingml/2006/main">
+            <a:pPr algn="l">
+              <a:buNone/>
+            </a:pPr>
             <a:r>
               <a:rPr sz="1200" b="1">
                 <a:solidFill>
                   <a:srgbClr val="7AA7FF"/>
                 </a:solidFill>
                 <a:latin typeface="Helvetica Neue"/>
+                <a:ea typeface="Helvetica Neue"/>
+                <a:cs typeface="Helvetica Neue"/>
               </a:rPr>
               <a:t>💬 Review minh họa: </a:t>
             </a:r>
@@ -6701,6 +6717,8 @@
                   <a:srgbClr val="F1F5F9"/>
                 </a:solidFill>
                 <a:latin typeface="Helvetica Neue"/>
+                <a:ea typeface="Helvetica Neue"/>
+                <a:cs typeface="Helvetica Neue"/>
               </a:rPr>
               <a:t>"Lương thấp, quản lý thiếu minh bạch và thường xuyên phải OT không lương."</a:t>
             </a:r>
@@ -6710,6 +6728,8 @@
                   <a:srgbClr val="9EABBA"/>
                 </a:solidFill>
                 <a:latin typeface="Helvetica Neue"/>
+                <a:ea typeface="Helvetica Neue"/>
+                <a:cs typeface="Helvetica Neue"/>
               </a:rPr>
               <a:t>  →  Mô hình nhận diện: </a:t>
             </a:r>
@@ -6719,6 +6739,8 @@
                   <a:srgbClr val="FF6677"/>
                 </a:solidFill>
                 <a:latin typeface="Helvetica Neue"/>
+                <a:ea typeface="Helvetica Neue"/>
+                <a:cs typeface="Helvetica Neue"/>
               </a:rPr>
               <a:t>Tiêu cực (99,0%)</a:t>
             </a:r>
@@ -8247,9 +8269,10 @@
             <a:prstDash val="solid"/>
           </a:ln>
         </p:spPr>
-        <p:txBody xmlns:a="http://schemas.openxmlformats.org/drawingml/2006/main">
-          <a:bodyPr/>
-          <a:p/>
+        <p:txBody>
+          <a:bodyPr xmlns:a="http://schemas.openxmlformats.org/drawingml/2006/main"/>
+          <a:lstStyle xmlns:a="http://schemas.openxmlformats.org/drawingml/2006/main"/>
+          <a:p xmlns:a="http://schemas.openxmlformats.org/drawingml/2006/main"/>
         </p:txBody>
       </p:sp>
       <p:sp>
@@ -8400,9 +8423,10 @@
             <a:prstDash val="solid"/>
           </a:ln>
         </p:spPr>
-        <p:txBody xmlns:a="http://schemas.openxmlformats.org/drawingml/2006/main">
-          <a:bodyPr/>
-          <a:p/>
+        <p:txBody>
+          <a:bodyPr xmlns:a="http://schemas.openxmlformats.org/drawingml/2006/main"/>
+          <a:lstStyle xmlns:a="http://schemas.openxmlformats.org/drawingml/2006/main"/>
+          <a:p xmlns:a="http://schemas.openxmlformats.org/drawingml/2006/main"/>
         </p:txBody>
       </p:sp>
       <p:sp>
@@ -8553,9 +8577,10 @@
             <a:prstDash val="solid"/>
           </a:ln>
         </p:spPr>
-        <p:txBody xmlns:a="http://schemas.openxmlformats.org/drawingml/2006/main">
-          <a:bodyPr/>
-          <a:p/>
+        <p:txBody>
+          <a:bodyPr xmlns:a="http://schemas.openxmlformats.org/drawingml/2006/main"/>
+          <a:lstStyle xmlns:a="http://schemas.openxmlformats.org/drawingml/2006/main"/>
+          <a:p xmlns:a="http://schemas.openxmlformats.org/drawingml/2006/main"/>
         </p:txBody>
       </p:sp>
       <p:sp>
@@ -8706,9 +8731,10 @@
             <a:prstDash val="solid"/>
           </a:ln>
         </p:spPr>
-        <p:txBody xmlns:a="http://schemas.openxmlformats.org/drawingml/2006/main">
-          <a:bodyPr/>
-          <a:p/>
+        <p:txBody>
+          <a:bodyPr xmlns:a="http://schemas.openxmlformats.org/drawingml/2006/main"/>
+          <a:lstStyle xmlns:a="http://schemas.openxmlformats.org/drawingml/2006/main"/>
+          <a:p xmlns:a="http://schemas.openxmlformats.org/drawingml/2006/main"/>
         </p:txBody>
       </p:sp>
       <p:sp>
@@ -8857,9 +8883,10 @@
             <a:prstDash val="solid"/>
           </a:ln>
         </p:spPr>
-        <p:txBody xmlns:a="http://schemas.openxmlformats.org/drawingml/2006/main">
-          <a:bodyPr/>
-          <a:p/>
+        <p:txBody>
+          <a:bodyPr xmlns:a="http://schemas.openxmlformats.org/drawingml/2006/main"/>
+          <a:lstStyle xmlns:a="http://schemas.openxmlformats.org/drawingml/2006/main"/>
+          <a:p xmlns:a="http://schemas.openxmlformats.org/drawingml/2006/main"/>
         </p:txBody>
       </p:sp>
       <p:sp>
@@ -8952,9 +8979,10 @@
             <a:prstDash val="solid"/>
           </a:ln>
         </p:spPr>
-        <p:txBody xmlns:a="http://schemas.openxmlformats.org/drawingml/2006/main">
-          <a:bodyPr/>
-          <a:p/>
+        <p:txBody>
+          <a:bodyPr xmlns:a="http://schemas.openxmlformats.org/drawingml/2006/main"/>
+          <a:lstStyle xmlns:a="http://schemas.openxmlformats.org/drawingml/2006/main"/>
+          <a:p xmlns:a="http://schemas.openxmlformats.org/drawingml/2006/main"/>
         </p:txBody>
       </p:sp>
       <p:sp>
@@ -9105,9 +9133,10 @@
             <a:prstDash val="solid"/>
           </a:ln>
         </p:spPr>
-        <p:txBody xmlns:a="http://schemas.openxmlformats.org/drawingml/2006/main">
-          <a:bodyPr/>
-          <a:p/>
+        <p:txBody>
+          <a:bodyPr xmlns:a="http://schemas.openxmlformats.org/drawingml/2006/main"/>
+          <a:lstStyle xmlns:a="http://schemas.openxmlformats.org/drawingml/2006/main"/>
+          <a:p xmlns:a="http://schemas.openxmlformats.org/drawingml/2006/main"/>
         </p:txBody>
       </p:sp>
       <p:sp>
@@ -9258,9 +9287,10 @@
             <a:prstDash val="solid"/>
           </a:ln>
         </p:spPr>
-        <p:txBody xmlns:a="http://schemas.openxmlformats.org/drawingml/2006/main">
-          <a:bodyPr/>
-          <a:p/>
+        <p:txBody>
+          <a:bodyPr xmlns:a="http://schemas.openxmlformats.org/drawingml/2006/main"/>
+          <a:lstStyle xmlns:a="http://schemas.openxmlformats.org/drawingml/2006/main"/>
+          <a:p xmlns:a="http://schemas.openxmlformats.org/drawingml/2006/main"/>
         </p:txBody>
       </p:sp>
       <p:sp>
@@ -9375,64 +9405,6 @@
                 <a:cs typeface="Helvetica Neue"/>
               </a:rPr>
               <a:t>Đối sánh với PhoBERT hoặc ViSoBERT khi có tài nguyên.</a:t>
-            </a:r>
-          </a:p>
-        </p:txBody>
-      </p:sp>
-      <p:sp>
-        <p:nvSpPr>
-          <p:cNvPr id="26" name="">
-            <a:extLst xmlns:a="http://schemas.openxmlformats.org/drawingml/2006/main">
-              <a:ext uri="{FF2B5EF4-FFF2-40B4-BE49-F238E27FC236}">
-                <a16:creationId xmlns:a16="http://schemas.microsoft.com/office/drawing/2014/main" id="{FBF425F4-BB3B-4DF9-A324-02D8E9A703CF}"/>
-              </a:ext>
-            </a:extLst>
-          </p:cNvPr>
-          <p:cNvSpPr>
-            <a:spLocks xmlns:a="http://schemas.openxmlformats.org/drawingml/2006/main" noGrp="1"/>
-          </p:cNvSpPr>
-          <p:nvPr/>
-        </p:nvSpPr>
-        <p:spPr>
-          <a:xfrm xmlns:a="http://schemas.openxmlformats.org/drawingml/2006/main">
-            <a:off x="609600" y="5905500"/>
-            <a:ext cx="10287000" cy="419100"/>
-          </a:xfrm>
-          <a:prstGeom xmlns:a="http://schemas.openxmlformats.org/drawingml/2006/main" prst="rect">
-            <a:avLst/>
-          </a:prstGeom>
-          <a:noFill xmlns:a="http://schemas.openxmlformats.org/drawingml/2006/main"/>
-          <a:ln xmlns:a="http://schemas.openxmlformats.org/drawingml/2006/main" w="0">
-            <a:noFill/>
-          </a:ln>
-        </p:spPr>
-        <p:txBody>
-          <a:bodyPr xmlns:a="http://schemas.openxmlformats.org/drawingml/2006/main" anchor="t">
-            <a:normAutofit fontScale="100000"/>
-          </a:bodyPr>
-          <a:lstStyle xmlns:a="http://schemas.openxmlformats.org/drawingml/2006/main"/>
-          <a:p xmlns:a="http://schemas.openxmlformats.org/drawingml/2006/main">
-            <a:pPr algn="l">
-              <a:buNone/>
-              <a:defRPr sz="2100" b="1">
-                <a:solidFill>
-                  <a:srgbClr val="45D9A0"/>
-                </a:solidFill>
-                <a:latin typeface="Helvetica Neue"/>
-                <a:ea typeface="Helvetica Neue"/>
-                <a:cs typeface="Helvetica Neue"/>
-              </a:defRPr>
-            </a:pPr>
-            <a:r>
-              <a:rPr sz="2100" b="1">
-                <a:solidFill>
-                  <a:srgbClr val="45D9A0"/>
-                </a:solidFill>
-                <a:latin typeface="Helvetica Neue"/>
-                <a:ea typeface="Helvetica Neue"/>
-                <a:cs typeface="Helvetica Neue"/>
-              </a:rPr>
-              <a:t>Kết thúc nội dung chính. Tiếp theo: live demo.</a:t>
             </a:r>
           </a:p>
         </p:txBody>
@@ -9612,9 +9584,10 @@
             <a:prstDash val="solid"/>
           </a:ln>
         </p:spPr>
-        <p:txBody xmlns:a="http://schemas.openxmlformats.org/drawingml/2006/main">
-          <a:bodyPr/>
-          <a:p/>
+        <p:txBody>
+          <a:bodyPr xmlns:a="http://schemas.openxmlformats.org/drawingml/2006/main"/>
+          <a:lstStyle xmlns:a="http://schemas.openxmlformats.org/drawingml/2006/main"/>
+          <a:p xmlns:a="http://schemas.openxmlformats.org/drawingml/2006/main"/>
         </p:txBody>
       </p:sp>
       <p:sp>
@@ -9879,9 +9852,10 @@
             <a:prstDash val="solid"/>
           </a:ln>
         </p:spPr>
-        <p:txBody xmlns:a="http://schemas.openxmlformats.org/drawingml/2006/main">
-          <a:bodyPr/>
-          <a:p/>
+        <p:txBody>
+          <a:bodyPr xmlns:a="http://schemas.openxmlformats.org/drawingml/2006/main"/>
+          <a:lstStyle xmlns:a="http://schemas.openxmlformats.org/drawingml/2006/main"/>
+          <a:p xmlns:a="http://schemas.openxmlformats.org/drawingml/2006/main"/>
         </p:txBody>
       </p:sp>
       <p:sp>
@@ -10884,7 +10858,7 @@
         </p:xfrm>
         <a:graphic xmlns:a="http://schemas.openxmlformats.org/drawingml/2006/main">
           <a:graphicData uri="http://schemas.openxmlformats.org/drawingml/2006/chart">
-            <c:chart xmlns:r="http://schemas.openxmlformats.org/officeDocument/2006/relationships" xmlns:c="http://schemas.openxmlformats.org/drawingml/2006/chart" r:id="Rd715ca4579904bc8"/>
+            <c:chart xmlns:r="http://schemas.openxmlformats.org/officeDocument/2006/relationships" xmlns:c="http://schemas.openxmlformats.org/drawingml/2006/chart" r:id="R6d33cb1b258045f1"/>
           </a:graphicData>
         </a:graphic>
       </p:graphicFrame>
@@ -12784,7 +12758,7 @@
       </p:sp>
       <p:cxnSp>
         <p:nvCxnSpPr>
-          <p:cNvPr id="114" name=""/>
+          <p:cNvPr id="142" name=""/>
           <p:cNvCxnSpPr>
             <a:stCxn xmlns:a="http://schemas.openxmlformats.org/drawingml/2006/main" id="8" idx="3"/>
             <a:endCxn xmlns:a="http://schemas.openxmlformats.org/drawingml/2006/main" id="12" idx="1"/>
@@ -12810,7 +12784,7 @@
       </p:cxnSp>
       <p:cxnSp>
         <p:nvCxnSpPr>
-          <p:cNvPr id="115" name=""/>
+          <p:cNvPr id="143" name=""/>
           <p:cNvCxnSpPr>
             <a:stCxn xmlns:a="http://schemas.openxmlformats.org/drawingml/2006/main" id="12" idx="3"/>
             <a:endCxn xmlns:a="http://schemas.openxmlformats.org/drawingml/2006/main" id="16" idx="1"/>
@@ -12836,7 +12810,7 @@
       </p:cxnSp>
       <p:cxnSp>
         <p:nvCxnSpPr>
-          <p:cNvPr id="116" name=""/>
+          <p:cNvPr id="144" name=""/>
           <p:cNvCxnSpPr>
             <a:stCxn xmlns:a="http://schemas.openxmlformats.org/drawingml/2006/main" id="16" idx="3"/>
             <a:endCxn xmlns:a="http://schemas.openxmlformats.org/drawingml/2006/main" id="20" idx="1"/>
@@ -12862,7 +12836,7 @@
       </p:cxnSp>
       <p:cxnSp>
         <p:nvCxnSpPr>
-          <p:cNvPr id="117" name=""/>
+          <p:cNvPr id="145" name=""/>
           <p:cNvCxnSpPr>
             <a:stCxn xmlns:a="http://schemas.openxmlformats.org/drawingml/2006/main" id="20" idx="3"/>
             <a:endCxn xmlns:a="http://schemas.openxmlformats.org/drawingml/2006/main" id="24" idx="1"/>
@@ -14640,7 +14614,7 @@
           <p:nvPr/>
         </p:nvPicPr>
         <p:blipFill>
-          <a:blip xmlns:r="http://schemas.openxmlformats.org/officeDocument/2006/relationships" xmlns:a="http://schemas.openxmlformats.org/drawingml/2006/main" r:embed="Rf3f4e884f7034a0a"/>
+          <a:blip xmlns:r="http://schemas.openxmlformats.org/officeDocument/2006/relationships" xmlns:a="http://schemas.openxmlformats.org/drawingml/2006/main" r:embed="R1481708e5bd44e57"/>
           <a:stretch xmlns:a="http://schemas.openxmlformats.org/drawingml/2006/main"/>
         </p:blipFill>
         <p:spPr>
@@ -15305,7 +15279,7 @@
         </p:xfrm>
         <a:graphic xmlns:a="http://schemas.openxmlformats.org/drawingml/2006/main">
           <a:graphicData uri="http://schemas.openxmlformats.org/drawingml/2006/chart">
-            <c:chart xmlns:r="http://schemas.openxmlformats.org/officeDocument/2006/relationships" xmlns:c="http://schemas.openxmlformats.org/drawingml/2006/chart" r:id="Rb17d24a0874d4fb8"/>
+            <c:chart xmlns:r="http://schemas.openxmlformats.org/officeDocument/2006/relationships" xmlns:c="http://schemas.openxmlformats.org/drawingml/2006/chart" r:id="Rb7ed362d7b48419c"/>
           </a:graphicData>
         </a:graphic>
       </p:graphicFrame>
@@ -17528,7 +17502,7 @@
       </p:sp>
       <p:cxnSp>
         <p:nvCxnSpPr>
-          <p:cNvPr id="123" name=""/>
+          <p:cNvPr id="154" name=""/>
           <p:cNvCxnSpPr>
             <a:stCxn xmlns:a="http://schemas.openxmlformats.org/drawingml/2006/main" id="17" idx="3"/>
             <a:endCxn xmlns:a="http://schemas.openxmlformats.org/drawingml/2006/main" id="20" idx="1"/>
@@ -17554,7 +17528,7 @@
       </p:cxnSp>
       <p:cxnSp>
         <p:nvCxnSpPr>
-          <p:cNvPr id="124" name=""/>
+          <p:cNvPr id="155" name=""/>
           <p:cNvCxnSpPr>
             <a:stCxn xmlns:a="http://schemas.openxmlformats.org/drawingml/2006/main" id="20" idx="3"/>
             <a:endCxn xmlns:a="http://schemas.openxmlformats.org/drawingml/2006/main" id="23" idx="1"/>
@@ -17580,7 +17554,7 @@
       </p:cxnSp>
       <p:cxnSp>
         <p:nvCxnSpPr>
-          <p:cNvPr id="125" name=""/>
+          <p:cNvPr id="156" name=""/>
           <p:cNvCxnSpPr>
             <a:stCxn xmlns:a="http://schemas.openxmlformats.org/drawingml/2006/main" id="23" idx="3"/>
             <a:endCxn xmlns:a="http://schemas.openxmlformats.org/drawingml/2006/main" id="26" idx="1"/>
@@ -17837,9 +17811,10 @@
             <a:prstDash val="solid"/>
           </a:ln>
         </p:spPr>
-        <p:txBody xmlns:a="http://schemas.openxmlformats.org/drawingml/2006/main">
-          <a:bodyPr/>
-          <a:p/>
+        <p:txBody>
+          <a:bodyPr xmlns:a="http://schemas.openxmlformats.org/drawingml/2006/main"/>
+          <a:lstStyle xmlns:a="http://schemas.openxmlformats.org/drawingml/2006/main"/>
+          <a:p xmlns:a="http://schemas.openxmlformats.org/drawingml/2006/main"/>
         </p:txBody>
       </p:sp>
       <p:sp>
@@ -17912,7 +17887,7 @@
         </p:xfrm>
         <a:graphic xmlns:a="http://schemas.openxmlformats.org/drawingml/2006/main">
           <a:graphicData uri="http://schemas.openxmlformats.org/drawingml/2006/chart">
-            <c:chart xmlns:r="http://schemas.openxmlformats.org/officeDocument/2006/relationships" xmlns:c="http://schemas.openxmlformats.org/drawingml/2006/chart" r:id="Re88c139d27314149"/>
+            <c:chart xmlns:r="http://schemas.openxmlformats.org/officeDocument/2006/relationships" xmlns:c="http://schemas.openxmlformats.org/drawingml/2006/chart" r:id="R8dc8b11500ca4baf"/>
           </a:graphicData>
         </a:graphic>
       </p:graphicFrame>
@@ -18180,9 +18155,10 @@
             <a:prstDash val="solid"/>
           </a:ln>
         </p:spPr>
-        <p:txBody xmlns:a="http://schemas.openxmlformats.org/drawingml/2006/main">
-          <a:bodyPr/>
-          <a:p/>
+        <p:txBody>
+          <a:bodyPr xmlns:a="http://schemas.openxmlformats.org/drawingml/2006/main"/>
+          <a:lstStyle xmlns:a="http://schemas.openxmlformats.org/drawingml/2006/main"/>
+          <a:p xmlns:a="http://schemas.openxmlformats.org/drawingml/2006/main"/>
         </p:txBody>
       </p:sp>
       <p:sp>
@@ -18333,9 +18309,10 @@
             <a:prstDash val="solid"/>
           </a:ln>
         </p:spPr>
-        <p:txBody xmlns:a="http://schemas.openxmlformats.org/drawingml/2006/main">
-          <a:bodyPr/>
-          <a:p/>
+        <p:txBody>
+          <a:bodyPr xmlns:a="http://schemas.openxmlformats.org/drawingml/2006/main"/>
+          <a:lstStyle xmlns:a="http://schemas.openxmlformats.org/drawingml/2006/main"/>
+          <a:p xmlns:a="http://schemas.openxmlformats.org/drawingml/2006/main"/>
         </p:txBody>
       </p:sp>
       <p:sp>
@@ -18486,9 +18463,10 @@
             <a:prstDash val="solid"/>
           </a:ln>
         </p:spPr>
-        <p:txBody xmlns:a="http://schemas.openxmlformats.org/drawingml/2006/main">
-          <a:bodyPr/>
-          <a:p/>
+        <p:txBody>
+          <a:bodyPr xmlns:a="http://schemas.openxmlformats.org/drawingml/2006/main"/>
+          <a:lstStyle xmlns:a="http://schemas.openxmlformats.org/drawingml/2006/main"/>
+          <a:p xmlns:a="http://schemas.openxmlformats.org/drawingml/2006/main"/>
         </p:txBody>
       </p:sp>
       <p:sp>
@@ -18782,9 +18760,10 @@
             <a:prstDash val="solid"/>
           </a:ln>
         </p:spPr>
-        <p:txBody xmlns:a="http://schemas.openxmlformats.org/drawingml/2006/main">
-          <a:bodyPr/>
-          <a:p/>
+        <p:txBody>
+          <a:bodyPr xmlns:a="http://schemas.openxmlformats.org/drawingml/2006/main"/>
+          <a:lstStyle xmlns:a="http://schemas.openxmlformats.org/drawingml/2006/main"/>
+          <a:p xmlns:a="http://schemas.openxmlformats.org/drawingml/2006/main"/>
         </p:txBody>
       </p:sp>
       <p:sp>
@@ -19308,13 +19287,17 @@
             </a:r>
           </a:p>
           <a:p xmlns:a="http://schemas.openxmlformats.org/drawingml/2006/main">
-            <a:pPr algn="l"/>
+            <a:pPr algn="l">
+              <a:buNone/>
+            </a:pPr>
             <a:r>
               <a:rPr sz="1100" b="1">
                 <a:solidFill>
                   <a:srgbClr val="50E3A4"/>
                 </a:solidFill>
                 <a:latin typeface="Helvetica Neue"/>
+                <a:ea typeface="Helvetica Neue"/>
+                <a:cs typeface="Helvetica Neue"/>
               </a:rPr>
               <a:t>(Bản cũ: 442 → Giảm 10 mẫu)</a:t>
             </a:r>
@@ -19323,7 +19306,7 @@
       </p:sp>
       <p:graphicFrame>
         <p:nvGraphicFramePr>
-          <p:cNvPr id="32" name=""/>
+          <p:cNvPr id="49" name=""/>
           <p:cNvGraphicFramePr/>
           <p:nvPr/>
         </p:nvGraphicFramePr>
@@ -19469,10 +19452,14 @@
                     <a:bodyPr/>
                     <a:lstStyle/>
                     <a:p>
-                      <a:pPr algn="ctr"/>
+                      <a:pPr algn="ctr">
+                        <a:buNone/>
+                      </a:pPr>
                       <a:r>
                         <a:rPr sz="1300" b="1">
                           <a:latin typeface="Helvetica Neue"/>
+                          <a:ea typeface="Helvetica Neue"/>
+                          <a:cs typeface="Helvetica Neue"/>
                         </a:rPr>
                         <a:t>52 (45,6%)</a:t>
                       </a:r>
@@ -19587,10 +19574,14 @@
                     <a:bodyPr/>
                     <a:lstStyle/>
                     <a:p>
-                      <a:pPr algn="ctr"/>
+                      <a:pPr algn="ctr">
+                        <a:buNone/>
+                      </a:pPr>
                       <a:r>
                         <a:rPr sz="1300" b="1">
                           <a:latin typeface="Helvetica Neue"/>
+                          <a:ea typeface="Helvetica Neue"/>
+                          <a:cs typeface="Helvetica Neue"/>
                         </a:rPr>
                         <a:t>168 (51,2%)</a:t>
                       </a:r>
@@ -19705,10 +19696,14 @@
                     <a:bodyPr/>
                     <a:lstStyle/>
                     <a:p>
-                      <a:pPr algn="ctr"/>
+                      <a:pPr algn="ctr">
+                        <a:buNone/>
+                      </a:pPr>
                       <a:r>
                         <a:rPr sz="1300" b="1">
                           <a:latin typeface="Helvetica Neue"/>
+                          <a:ea typeface="Helvetica Neue"/>
+                          <a:cs typeface="Helvetica Neue"/>
                         </a:rPr>
                         <a:t>1.031 (83,1%)</a:t>
                       </a:r>
@@ -19727,7 +19722,7 @@
       </p:graphicFrame>
       <p:graphicFrame>
         <p:nvGraphicFramePr>
-          <p:cNvPr id="33" name="Chart"/>
+          <p:cNvPr id="50" name="Chart"/>
           <p:cNvGraphicFramePr/>
           <p:nvPr/>
         </p:nvGraphicFramePr>
@@ -19737,7 +19732,7 @@
         </p:xfrm>
         <a:graphic xmlns:a="http://schemas.openxmlformats.org/drawingml/2006/main">
           <a:graphicData uri="http://schemas.openxmlformats.org/drawingml/2006/chart">
-            <c:chart xmlns:r="http://schemas.openxmlformats.org/officeDocument/2006/relationships" xmlns:c="http://schemas.openxmlformats.org/drawingml/2006/chart" r:id="Rfdddb44e8e944fdc"/>
+            <c:chart xmlns:r="http://schemas.openxmlformats.org/officeDocument/2006/relationships" xmlns:c="http://schemas.openxmlformats.org/drawingml/2006/chart" r:id="R2795b788fb2e4081"/>
           </a:graphicData>
         </a:graphic>
       </p:graphicFrame>
@@ -19857,56 +19852,68 @@
           </a:p>
         </p:txBody>
       </p:sp>
-      <p:sp xmlns:a="http://schemas.openxmlformats.org/drawingml/2006/main">
-        <p:nvSpPr>
-          <p:cNvPr id="34" name="Rounded Rectangle 33"/>
-          <p:cNvSpPr/>
-          <p:nvPr/>
-        </p:nvSpPr>
-        <p:spPr>
-          <a:xfrm>
+      <p:sp>
+        <p:nvSpPr>
+          <p:cNvPr id="34" name="Rounded Rectangle 33">
+            <a:extLst xmlns:a="http://schemas.openxmlformats.org/drawingml/2006/main">
+              <a:ext uri="{FF2B5EF4-FFF2-40B4-BE49-F238E27FC236}">
+                <a16:creationId xmlns:a16="http://schemas.microsoft.com/office/drawing/2014/main" id="{9D2DFA3B-6B5F-4A31-ABCD-E8D09A5BD22C}"/>
+              </a:ext>
+            </a:extLst>
+          </p:cNvPr>
+          <p:cNvSpPr>
+            <a:spLocks xmlns:a="http://schemas.openxmlformats.org/drawingml/2006/main" noGrp="1"/>
+          </p:cNvSpPr>
+          <p:nvPr/>
+        </p:nvSpPr>
+        <p:spPr>
+          <a:xfrm xmlns:a="http://schemas.openxmlformats.org/drawingml/2006/main">
             <a:off x="7242048" y="5321808"/>
             <a:ext cx="4005072" cy="347472"/>
           </a:xfrm>
-          <a:prstGeom prst="roundRect">
+          <a:prstGeom xmlns:a="http://schemas.openxmlformats.org/drawingml/2006/main" prst="roundRect">
             <a:avLst>
               <a:gd name="adj" fmla="val 20000"/>
             </a:avLst>
           </a:prstGeom>
-          <a:solidFill>
+          <a:solidFill xmlns:a="http://schemas.openxmlformats.org/drawingml/2006/main">
             <a:srgbClr val="1B2433"/>
           </a:solidFill>
-          <a:ln w="12700">
+          <a:ln xmlns:a="http://schemas.openxmlformats.org/drawingml/2006/main" w="12700">
             <a:solidFill>
               <a:srgbClr val="FF6677"/>
             </a:solidFill>
           </a:ln>
         </p:spPr>
         <p:style>
-          <a:lnRef idx="1">
+          <a:lnRef xmlns:a="http://schemas.openxmlformats.org/drawingml/2006/main" idx="1">
             <a:schemeClr val="accent1"/>
           </a:lnRef>
-          <a:fillRef idx="3">
+          <a:fillRef xmlns:a="http://schemas.openxmlformats.org/drawingml/2006/main" idx="3">
             <a:schemeClr val="accent1"/>
           </a:fillRef>
-          <a:effectRef idx="2">
+          <a:effectRef xmlns:a="http://schemas.openxmlformats.org/drawingml/2006/main" idx="2">
             <a:schemeClr val="accent1"/>
           </a:effectRef>
-          <a:fontRef idx="minor">
+          <a:fontRef xmlns:a="http://schemas.openxmlformats.org/drawingml/2006/main" idx="minor">
             <a:schemeClr val="lt1"/>
           </a:fontRef>
         </p:style>
         <p:txBody>
-          <a:bodyPr rtlCol="0" anchor="ctr" lIns="0" rIns="0" tIns="0" bIns="0"/>
-          <a:lstStyle/>
-          <a:p>
-            <a:pPr algn="ctr"/>
+          <a:bodyPr xmlns:a="http://schemas.openxmlformats.org/drawingml/2006/main" lIns="0" tIns="0" rIns="0" bIns="0" anchor="ctr"/>
+          <a:lstStyle xmlns:a="http://schemas.openxmlformats.org/drawingml/2006/main"/>
+          <a:p xmlns:a="http://schemas.openxmlformats.org/drawingml/2006/main">
+            <a:pPr algn="ctr">
+              <a:buNone/>
+            </a:pPr>
             <a:r>
               <a:rPr sz="1100" b="1">
                 <a:solidFill>
                   <a:srgbClr val="FF6677"/>
                 </a:solidFill>
                 <a:latin typeface="Helvetica Neue"/>
+                <a:ea typeface="Helvetica Neue"/>
+                <a:cs typeface="Helvetica Neue"/>
               </a:rPr>
               <a:t>⚠️ Recall Negative: 45,6% (đoán đúng 52 / 114 mẫu)</a:t>
             </a:r>

</xml_diff>